<commit_message>
Finalizing .json, .md file for first submission
</commit_message>
<xml_diff>
--- a/seminar-2_submission/WILD_SIGNAL_Seminar2_Presentation.pptx
+++ b/seminar-2_submission/WILD_SIGNAL_Seminar2_Presentation.pptx
@@ -1,19 +1,19 @@
 
 <file path=ppt/presentation.xml><?xml version="1.0" encoding="utf-8"?>
-<p:presentation xmlns:a="http://schemas.openxmlformats.org/drawingml/2006/main" xmlns:r="http://schemas.openxmlformats.org/officeDocument/2006/relationships" xmlns:p="http://schemas.openxmlformats.org/presentationml/2006/main" xmlns:m="http://schemas.openxmlformats.org/officeDocument/2006/math" xmlns:a14="http://schemas.microsoft.com/office/drawing/2010/main">
+<p:presentation xmlns:a="http://schemas.openxmlformats.org/drawingml/2006/main" xmlns:r="http://schemas.openxmlformats.org/officeDocument/2006/relationships" xmlns:p="http://schemas.openxmlformats.org/presentationml/2006/main">
   <p:sldMasterIdLst>
-    <p:sldMasterId id="2147483648" r:id="rId5"/>
+    <p:sldMasterId id="2147483648" r:id="rId1"/>
   </p:sldMasterIdLst>
   <p:notesMasterIdLst>
-    <p:notesMasterId r:id="rId7"/>
+    <p:notesMasterId r:id="rId9"/>
   </p:notesMasterIdLst>
   <p:sldIdLst>
-    <p:sldId id="256" r:id="rId8"/>
-    <p:sldId id="257" r:id="rId9"/>
-    <p:sldId id="258" r:id="rId10"/>
-    <p:sldId id="259" r:id="rId11"/>
-    <p:sldId id="260" r:id="rId12"/>
-    <p:sldId id="261" r:id="rId13"/>
+    <p:sldId id="256" r:id="rId3"/>
+    <p:sldId id="257" r:id="rId4"/>
+    <p:sldId id="258" r:id="rId5"/>
+    <p:sldId id="259" r:id="rId6"/>
+    <p:sldId id="260" r:id="rId7"/>
+    <p:sldId id="261" r:id="rId8"/>
   </p:sldIdLst>
   <p:sldSz cx="12179300" cy="6858000"/>
   <p:notesSz cx="6858000" cy="9144000"/>
@@ -32,8 +32,7 @@
       <a:buSzTx/>
       <a:buFontTx/>
       <a:buNone/>
-      <a:tabLst/>
-      <a:defRPr b="0" baseline="0" cap="none" i="0" spc="0" strike="noStrike" sz="1800" u="none" kumimoji="0" normalizeH="0">
+      <a:defRPr kumimoji="0" sz="1800" b="0" i="0" u="none" strike="noStrike" cap="none" spc="0" normalizeH="0" baseline="0">
         <a:ln>
           <a:noFill/>
         </a:ln>
@@ -58,8 +57,7 @@
       <a:buSzTx/>
       <a:buFontTx/>
       <a:buNone/>
-      <a:tabLst/>
-      <a:defRPr b="0" baseline="0" cap="none" i="0" spc="0" strike="noStrike" sz="1800" u="none" kumimoji="0" normalizeH="0">
+      <a:defRPr kumimoji="0" sz="1800" b="0" i="0" u="none" strike="noStrike" cap="none" spc="0" normalizeH="0" baseline="0">
         <a:ln>
           <a:noFill/>
         </a:ln>
@@ -88,8 +86,7 @@
       <a:buSzTx/>
       <a:buFontTx/>
       <a:buNone/>
-      <a:tabLst/>
-      <a:defRPr b="0" baseline="0" cap="none" i="0" spc="0" strike="noStrike" sz="1800" u="none" kumimoji="0" normalizeH="0">
+      <a:defRPr kumimoji="0" sz="1800" b="0" i="0" u="none" strike="noStrike" cap="none" spc="0" normalizeH="0" baseline="0">
         <a:ln>
           <a:noFill/>
         </a:ln>
@@ -118,8 +115,7 @@
       <a:buSzTx/>
       <a:buFontTx/>
       <a:buNone/>
-      <a:tabLst/>
-      <a:defRPr b="0" baseline="0" cap="none" i="0" spc="0" strike="noStrike" sz="1800" u="none" kumimoji="0" normalizeH="0">
+      <a:defRPr kumimoji="0" sz="1800" b="0" i="0" u="none" strike="noStrike" cap="none" spc="0" normalizeH="0" baseline="0">
         <a:ln>
           <a:noFill/>
         </a:ln>
@@ -148,8 +144,7 @@
       <a:buSzTx/>
       <a:buFontTx/>
       <a:buNone/>
-      <a:tabLst/>
-      <a:defRPr b="0" baseline="0" cap="none" i="0" spc="0" strike="noStrike" sz="1800" u="none" kumimoji="0" normalizeH="0">
+      <a:defRPr kumimoji="0" sz="1800" b="0" i="0" u="none" strike="noStrike" cap="none" spc="0" normalizeH="0" baseline="0">
         <a:ln>
           <a:noFill/>
         </a:ln>
@@ -178,8 +173,7 @@
       <a:buSzTx/>
       <a:buFontTx/>
       <a:buNone/>
-      <a:tabLst/>
-      <a:defRPr b="0" baseline="0" cap="none" i="0" spc="0" strike="noStrike" sz="1800" u="none" kumimoji="0" normalizeH="0">
+      <a:defRPr kumimoji="0" sz="1800" b="0" i="0" u="none" strike="noStrike" cap="none" spc="0" normalizeH="0" baseline="0">
         <a:ln>
           <a:noFill/>
         </a:ln>
@@ -208,8 +202,7 @@
       <a:buSzTx/>
       <a:buFontTx/>
       <a:buNone/>
-      <a:tabLst/>
-      <a:defRPr b="0" baseline="0" cap="none" i="0" spc="0" strike="noStrike" sz="1800" u="none" kumimoji="0" normalizeH="0">
+      <a:defRPr kumimoji="0" sz="1800" b="0" i="0" u="none" strike="noStrike" cap="none" spc="0" normalizeH="0" baseline="0">
         <a:ln>
           <a:noFill/>
         </a:ln>
@@ -238,8 +231,7 @@
       <a:buSzTx/>
       <a:buFontTx/>
       <a:buNone/>
-      <a:tabLst/>
-      <a:defRPr b="0" baseline="0" cap="none" i="0" spc="0" strike="noStrike" sz="1800" u="none" kumimoji="0" normalizeH="0">
+      <a:defRPr kumimoji="0" sz="1800" b="0" i="0" u="none" strike="noStrike" cap="none" spc="0" normalizeH="0" baseline="0">
         <a:ln>
           <a:noFill/>
         </a:ln>
@@ -268,8 +260,7 @@
       <a:buSzTx/>
       <a:buFontTx/>
       <a:buNone/>
-      <a:tabLst/>
-      <a:defRPr b="0" baseline="0" cap="none" i="0" spc="0" strike="noStrike" sz="1800" u="none" kumimoji="0" normalizeH="0">
+      <a:defRPr kumimoji="0" sz="1800" b="0" i="0" u="none" strike="noStrike" cap="none" spc="0" normalizeH="0" baseline="0">
         <a:ln>
           <a:noFill/>
         </a:ln>
@@ -298,8 +289,7 @@
       <a:buSzTx/>
       <a:buFontTx/>
       <a:buNone/>
-      <a:tabLst/>
-      <a:defRPr b="0" baseline="0" cap="none" i="0" spc="0" strike="noStrike" sz="1800" u="none" kumimoji="0" normalizeH="0">
+      <a:defRPr kumimoji="0" sz="1800" b="0" i="0" u="none" strike="noStrike" cap="none" spc="0" normalizeH="0" baseline="0">
         <a:ln>
           <a:noFill/>
         </a:ln>
@@ -318,13 +308,14 @@
 </p:presentation>
 </file>
 
-<file path=ppt/commentAuthors.xml><?xml version="1.0" encoding="utf-8"?>
-<p:cmAuthorLst xmlns:a="http://schemas.openxmlformats.org/drawingml/2006/main" xmlns:r="http://schemas.openxmlformats.org/officeDocument/2006/relationships" xmlns:p="http://schemas.openxmlformats.org/presentationml/2006/main" xmlns:m="http://schemas.openxmlformats.org/officeDocument/2006/math" xmlns:a14="http://schemas.microsoft.com/office/drawing/2010/main"/>
-</file>
-
 <file path=ppt/notesMasters/notesMaster1.xml><?xml version="1.0" encoding="utf-8"?>
-<p:notesMaster xmlns:a="http://schemas.openxmlformats.org/drawingml/2006/main" xmlns:r="http://schemas.openxmlformats.org/officeDocument/2006/relationships" xmlns:p="http://schemas.openxmlformats.org/presentationml/2006/main" xmlns:m="http://schemas.openxmlformats.org/officeDocument/2006/math" xmlns:a14="http://schemas.microsoft.com/office/drawing/2010/main">
+<p:notesMaster xmlns:a="http://schemas.openxmlformats.org/drawingml/2006/main" xmlns:r="http://schemas.openxmlformats.org/officeDocument/2006/relationships" xmlns:p="http://schemas.openxmlformats.org/presentationml/2006/main">
   <p:cSld>
+    <p:bg>
+      <p:bgRef idx="1001">
+        <a:schemeClr val="bg1"/>
+      </p:bgRef>
+    </p:bg>
     <p:spTree>
       <p:nvGrpSpPr>
         <p:cNvPr id="1" name=""/>
@@ -359,9 +350,7 @@
         <p:txBody>
           <a:bodyPr/>
           <a:lstStyle/>
-          <a:p>
-            <a:pPr/>
-          </a:p>
+          <a:p/>
         </p:txBody>
       </p:sp>
       <p:sp>
@@ -384,9 +373,7 @@
         <p:txBody>
           <a:bodyPr/>
           <a:lstStyle/>
-          <a:p>
-            <a:pPr/>
-          </a:p>
+          <a:p/>
         </p:txBody>
       </p:sp>
     </p:spTree>
@@ -470,7 +457,7 @@
 </file>
 
 <file path=ppt/slideLayouts/slideLayout1.xml><?xml version="1.0" encoding="utf-8"?>
-<p:sldLayout xmlns:a="http://schemas.openxmlformats.org/drawingml/2006/main" xmlns:r="http://schemas.openxmlformats.org/officeDocument/2006/relationships" xmlns:p="http://schemas.openxmlformats.org/presentationml/2006/main" xmlns:m="http://schemas.openxmlformats.org/officeDocument/2006/math" xmlns:a14="http://schemas.microsoft.com/office/drawing/2010/main" type="title" showMasterSp="1" showMasterPhAnim="1">
+<p:sldLayout xmlns:a="http://schemas.openxmlformats.org/drawingml/2006/main" xmlns:r="http://schemas.openxmlformats.org/officeDocument/2006/relationships" xmlns:p="http://schemas.openxmlformats.org/presentationml/2006/main" type="title">
   <p:cSld name="Title Slide">
     <p:spTree>
       <p:nvGrpSpPr>
@@ -491,7 +478,7 @@
           <p:cNvPr id="11" name="Title Text"/>
           <p:cNvSpPr txBox="1"/>
           <p:nvPr>
-            <p:ph type="title"/>
+            <p:ph type="title" hasCustomPrompt="1"/>
           </p:nvPr>
         </p:nvSpPr>
         <p:spPr>
@@ -507,7 +494,6 @@
           <a:bodyPr/>
           <a:lstStyle/>
           <a:p>
-            <a:pPr/>
             <a:r>
               <a:t>Title Text</a:t>
             </a:r>
@@ -519,7 +505,7 @@
           <p:cNvPr id="12" name="Body Level One…"/>
           <p:cNvSpPr txBox="1"/>
           <p:nvPr>
-            <p:ph type="body" sz="quarter" idx="1"/>
+            <p:ph type="body" sz="quarter" idx="1" hasCustomPrompt="1"/>
           </p:nvPr>
         </p:nvSpPr>
         <p:spPr>
@@ -586,7 +572,6 @@
             </a:lvl5pPr>
           </a:lstStyle>
           <a:p>
-            <a:pPr/>
             <a:r>
               <a:t>Body Level One</a:t>
             </a:r>
@@ -634,8 +619,10 @@
           <a:bodyPr/>
           <a:lstStyle/>
           <a:p>
-            <a:pPr/>
-            <a:fld id="{86CB4B4D-7CA3-9044-876B-883B54F8677D}" type="slidenum"/>
+            <a:fld id="{86CB4B4D-7CA3-9044-876B-883B54F8677D}" type="slidenum">
+              <a:rPr/>
+            </a:fld>
+            <a:endParaRPr/>
           </a:p>
         </p:txBody>
       </p:sp>
@@ -644,12 +631,12 @@
   <p:clrMapOvr>
     <a:masterClrMapping/>
   </p:clrMapOvr>
-  <p:transition xmlns:p14="http://schemas.microsoft.com/office/powerpoint/2010/main" spd="med" advClick="1"/>
+  <p:transition spd="med"/>
 </p:sldLayout>
 </file>
 
 <file path=ppt/slideLayouts/slideLayout2.xml><?xml version="1.0" encoding="utf-8"?>
-<p:sldLayout xmlns:a="http://schemas.openxmlformats.org/drawingml/2006/main" xmlns:r="http://schemas.openxmlformats.org/officeDocument/2006/relationships" xmlns:p="http://schemas.openxmlformats.org/presentationml/2006/main" xmlns:m="http://schemas.openxmlformats.org/officeDocument/2006/math" xmlns:a14="http://schemas.microsoft.com/office/drawing/2010/main" type="tx" showMasterSp="1" showMasterPhAnim="1">
+<p:sldLayout xmlns:a="http://schemas.openxmlformats.org/drawingml/2006/main" xmlns:r="http://schemas.openxmlformats.org/officeDocument/2006/relationships" xmlns:p="http://schemas.openxmlformats.org/presentationml/2006/main" type="tx">
   <p:cSld name="Title and Content">
     <p:spTree>
       <p:nvGrpSpPr>
@@ -670,7 +657,7 @@
           <p:cNvPr id="20" name="Title Text"/>
           <p:cNvSpPr txBox="1"/>
           <p:nvPr>
-            <p:ph type="title"/>
+            <p:ph type="title" hasCustomPrompt="1"/>
           </p:nvPr>
         </p:nvSpPr>
         <p:spPr>
@@ -686,7 +673,6 @@
           <a:bodyPr/>
           <a:lstStyle/>
           <a:p>
-            <a:pPr/>
             <a:r>
               <a:t>Title Text</a:t>
             </a:r>
@@ -698,7 +684,7 @@
           <p:cNvPr id="21" name="Body Level One…"/>
           <p:cNvSpPr txBox="1"/>
           <p:nvPr>
-            <p:ph type="body" idx="1"/>
+            <p:ph type="body" idx="1" hasCustomPrompt="1"/>
           </p:nvPr>
         </p:nvSpPr>
         <p:spPr>
@@ -714,7 +700,6 @@
           <a:bodyPr/>
           <a:lstStyle/>
           <a:p>
-            <a:pPr/>
             <a:r>
               <a:t>Body Level One</a:t>
             </a:r>
@@ -762,8 +747,10 @@
           <a:bodyPr/>
           <a:lstStyle/>
           <a:p>
-            <a:pPr/>
-            <a:fld id="{86CB4B4D-7CA3-9044-876B-883B54F8677D}" type="slidenum"/>
+            <a:fld id="{86CB4B4D-7CA3-9044-876B-883B54F8677D}" type="slidenum">
+              <a:rPr/>
+            </a:fld>
+            <a:endParaRPr/>
           </a:p>
         </p:txBody>
       </p:sp>
@@ -772,12 +759,12 @@
   <p:clrMapOvr>
     <a:masterClrMapping/>
   </p:clrMapOvr>
-  <p:transition xmlns:p14="http://schemas.microsoft.com/office/powerpoint/2010/main" spd="med" advClick="1"/>
+  <p:transition spd="med"/>
 </p:sldLayout>
 </file>
 
 <file path=ppt/slideLayouts/slideLayout3.xml><?xml version="1.0" encoding="utf-8"?>
-<p:sldLayout xmlns:a="http://schemas.openxmlformats.org/drawingml/2006/main" xmlns:r="http://schemas.openxmlformats.org/officeDocument/2006/relationships" xmlns:p="http://schemas.openxmlformats.org/presentationml/2006/main" xmlns:m="http://schemas.openxmlformats.org/officeDocument/2006/math" xmlns:a14="http://schemas.microsoft.com/office/drawing/2010/main" type="tx" showMasterSp="1" showMasterPhAnim="1">
+<p:sldLayout xmlns:a="http://schemas.openxmlformats.org/drawingml/2006/main" xmlns:r="http://schemas.openxmlformats.org/officeDocument/2006/relationships" xmlns:p="http://schemas.openxmlformats.org/presentationml/2006/main" type="tx">
   <p:cSld name="Section Header">
     <p:spTree>
       <p:nvGrpSpPr>
@@ -798,7 +785,7 @@
           <p:cNvPr id="29" name="Title Text"/>
           <p:cNvSpPr txBox="1"/>
           <p:nvPr>
-            <p:ph type="title"/>
+            <p:ph type="title" hasCustomPrompt="1"/>
           </p:nvPr>
         </p:nvSpPr>
         <p:spPr>
@@ -814,11 +801,10 @@
           <a:bodyPr anchor="t"/>
           <a:lstStyle>
             <a:lvl1pPr algn="l">
-              <a:defRPr b="1" cap="all" sz="4000"/>
+              <a:defRPr sz="4000" b="1" cap="all"/>
             </a:lvl1pPr>
           </a:lstStyle>
           <a:p>
-            <a:pPr/>
             <a:r>
               <a:t>Title Text</a:t>
             </a:r>
@@ -830,7 +816,7 @@
           <p:cNvPr id="30" name="Body Level One…"/>
           <p:cNvSpPr txBox="1"/>
           <p:nvPr>
-            <p:ph type="body" sz="quarter" idx="1"/>
+            <p:ph type="body" sz="quarter" idx="1" hasCustomPrompt="1"/>
           </p:nvPr>
         </p:nvSpPr>
         <p:spPr>
@@ -912,7 +898,6 @@
             </a:lvl5pPr>
           </a:lstStyle>
           <a:p>
-            <a:pPr/>
             <a:r>
               <a:t>Body Level One</a:t>
             </a:r>
@@ -960,8 +945,10 @@
           <a:bodyPr/>
           <a:lstStyle/>
           <a:p>
-            <a:pPr/>
-            <a:fld id="{86CB4B4D-7CA3-9044-876B-883B54F8677D}" type="slidenum"/>
+            <a:fld id="{86CB4B4D-7CA3-9044-876B-883B54F8677D}" type="slidenum">
+              <a:rPr/>
+            </a:fld>
+            <a:endParaRPr/>
           </a:p>
         </p:txBody>
       </p:sp>
@@ -970,12 +957,12 @@
   <p:clrMapOvr>
     <a:masterClrMapping/>
   </p:clrMapOvr>
-  <p:transition xmlns:p14="http://schemas.microsoft.com/office/powerpoint/2010/main" spd="med" advClick="1"/>
+  <p:transition spd="med"/>
 </p:sldLayout>
 </file>
 
 <file path=ppt/slideLayouts/slideLayout4.xml><?xml version="1.0" encoding="utf-8"?>
-<p:sldLayout xmlns:a="http://schemas.openxmlformats.org/drawingml/2006/main" xmlns:r="http://schemas.openxmlformats.org/officeDocument/2006/relationships" xmlns:p="http://schemas.openxmlformats.org/presentationml/2006/main" xmlns:m="http://schemas.openxmlformats.org/officeDocument/2006/math" xmlns:a14="http://schemas.microsoft.com/office/drawing/2010/main" type="tx" showMasterSp="1" showMasterPhAnim="1">
+<p:sldLayout xmlns:a="http://schemas.openxmlformats.org/drawingml/2006/main" xmlns:r="http://schemas.openxmlformats.org/officeDocument/2006/relationships" xmlns:p="http://schemas.openxmlformats.org/presentationml/2006/main" type="tx">
   <p:cSld name="Two Content">
     <p:spTree>
       <p:nvGrpSpPr>
@@ -996,7 +983,7 @@
           <p:cNvPr id="38" name="Title Text"/>
           <p:cNvSpPr txBox="1"/>
           <p:nvPr>
-            <p:ph type="title"/>
+            <p:ph type="title" hasCustomPrompt="1"/>
           </p:nvPr>
         </p:nvSpPr>
         <p:spPr>
@@ -1012,7 +999,6 @@
           <a:bodyPr/>
           <a:lstStyle/>
           <a:p>
-            <a:pPr/>
             <a:r>
               <a:t>Title Text</a:t>
             </a:r>
@@ -1024,7 +1010,7 @@
           <p:cNvPr id="39" name="Body Level One…"/>
           <p:cNvSpPr txBox="1"/>
           <p:nvPr>
-            <p:ph type="body" sz="half" idx="1"/>
+            <p:ph type="body" sz="half" idx="1" hasCustomPrompt="1"/>
           </p:nvPr>
         </p:nvSpPr>
         <p:spPr>
@@ -1051,7 +1037,7 @@
               </a:spcBef>
               <a:defRPr sz="2800"/>
             </a:lvl2pPr>
-            <a:lvl3pPr marL="1234439" indent="-320039">
+            <a:lvl3pPr marL="1234440" indent="-320040">
               <a:spcBef>
                 <a:spcPts val="600"/>
               </a:spcBef>
@@ -1071,7 +1057,6 @@
             </a:lvl5pPr>
           </a:lstStyle>
           <a:p>
-            <a:pPr/>
             <a:r>
               <a:t>Body Level One</a:t>
             </a:r>
@@ -1119,8 +1104,10 @@
           <a:bodyPr/>
           <a:lstStyle/>
           <a:p>
-            <a:pPr/>
-            <a:fld id="{86CB4B4D-7CA3-9044-876B-883B54F8677D}" type="slidenum"/>
+            <a:fld id="{86CB4B4D-7CA3-9044-876B-883B54F8677D}" type="slidenum">
+              <a:rPr/>
+            </a:fld>
+            <a:endParaRPr/>
           </a:p>
         </p:txBody>
       </p:sp>
@@ -1129,12 +1116,12 @@
   <p:clrMapOvr>
     <a:masterClrMapping/>
   </p:clrMapOvr>
-  <p:transition xmlns:p14="http://schemas.microsoft.com/office/powerpoint/2010/main" spd="med" advClick="1"/>
+  <p:transition spd="med"/>
 </p:sldLayout>
 </file>
 
 <file path=ppt/slideLayouts/slideLayout5.xml><?xml version="1.0" encoding="utf-8"?>
-<p:sldLayout xmlns:a="http://schemas.openxmlformats.org/drawingml/2006/main" xmlns:r="http://schemas.openxmlformats.org/officeDocument/2006/relationships" xmlns:p="http://schemas.openxmlformats.org/presentationml/2006/main" xmlns:m="http://schemas.openxmlformats.org/officeDocument/2006/math" xmlns:a14="http://schemas.microsoft.com/office/drawing/2010/main" type="tx" showMasterSp="1" showMasterPhAnim="1">
+<p:sldLayout xmlns:a="http://schemas.openxmlformats.org/drawingml/2006/main" xmlns:r="http://schemas.openxmlformats.org/officeDocument/2006/relationships" xmlns:p="http://schemas.openxmlformats.org/presentationml/2006/main" type="tx">
   <p:cSld name="Comparison">
     <p:spTree>
       <p:nvGrpSpPr>
@@ -1155,7 +1142,7 @@
           <p:cNvPr id="47" name="Title Text"/>
           <p:cNvSpPr txBox="1"/>
           <p:nvPr>
-            <p:ph type="title"/>
+            <p:ph type="title" hasCustomPrompt="1"/>
           </p:nvPr>
         </p:nvSpPr>
         <p:spPr>
@@ -1171,7 +1158,6 @@
           <a:bodyPr/>
           <a:lstStyle/>
           <a:p>
-            <a:pPr/>
             <a:r>
               <a:t>Title Text</a:t>
             </a:r>
@@ -1183,7 +1169,7 @@
           <p:cNvPr id="48" name="Body Level One…"/>
           <p:cNvSpPr txBox="1"/>
           <p:nvPr>
-            <p:ph type="body" sz="quarter" idx="1"/>
+            <p:ph type="body" sz="quarter" idx="1" hasCustomPrompt="1"/>
           </p:nvPr>
         </p:nvSpPr>
         <p:spPr>
@@ -1205,7 +1191,7 @@
               <a:buSzTx/>
               <a:buFontTx/>
               <a:buNone/>
-              <a:defRPr b="1" sz="2400"/>
+              <a:defRPr sz="2400" b="1"/>
             </a:lvl1pPr>
             <a:lvl2pPr marL="0" indent="457200">
               <a:spcBef>
@@ -1214,7 +1200,7 @@
               <a:buSzTx/>
               <a:buFontTx/>
               <a:buNone/>
-              <a:defRPr b="1" sz="2400"/>
+              <a:defRPr sz="2400" b="1"/>
             </a:lvl2pPr>
             <a:lvl3pPr marL="0" indent="914400">
               <a:spcBef>
@@ -1223,7 +1209,7 @@
               <a:buSzTx/>
               <a:buFontTx/>
               <a:buNone/>
-              <a:defRPr b="1" sz="2400"/>
+              <a:defRPr sz="2400" b="1"/>
             </a:lvl3pPr>
             <a:lvl4pPr marL="0" indent="1371600">
               <a:spcBef>
@@ -1232,7 +1218,7 @@
               <a:buSzTx/>
               <a:buFontTx/>
               <a:buNone/>
-              <a:defRPr b="1" sz="2400"/>
+              <a:defRPr sz="2400" b="1"/>
             </a:lvl4pPr>
             <a:lvl5pPr marL="0" indent="1828800">
               <a:spcBef>
@@ -1241,11 +1227,10 @@
               <a:buSzTx/>
               <a:buFontTx/>
               <a:buNone/>
-              <a:defRPr b="1" sz="2400"/>
+              <a:defRPr sz="2400" b="1"/>
             </a:lvl5pPr>
           </a:lstStyle>
           <a:p>
-            <a:pPr/>
             <a:r>
               <a:t>Body Level One</a:t>
             </a:r>
@@ -1304,7 +1289,7 @@
               <a:buSzTx/>
               <a:buFontTx/>
               <a:buNone/>
-              <a:defRPr b="1" sz="2400"/>
+              <a:defRPr sz="2400" b="1"/>
             </a:pPr>
           </a:p>
         </p:txBody>
@@ -1326,8 +1311,10 @@
           <a:bodyPr/>
           <a:lstStyle/>
           <a:p>
-            <a:pPr/>
-            <a:fld id="{86CB4B4D-7CA3-9044-876B-883B54F8677D}" type="slidenum"/>
+            <a:fld id="{86CB4B4D-7CA3-9044-876B-883B54F8677D}" type="slidenum">
+              <a:rPr/>
+            </a:fld>
+            <a:endParaRPr/>
           </a:p>
         </p:txBody>
       </p:sp>
@@ -1336,12 +1323,12 @@
   <p:clrMapOvr>
     <a:masterClrMapping/>
   </p:clrMapOvr>
-  <p:transition xmlns:p14="http://schemas.microsoft.com/office/powerpoint/2010/main" spd="med" advClick="1"/>
+  <p:transition spd="med"/>
 </p:sldLayout>
 </file>
 
 <file path=ppt/slideLayouts/slideLayout6.xml><?xml version="1.0" encoding="utf-8"?>
-<p:sldLayout xmlns:a="http://schemas.openxmlformats.org/drawingml/2006/main" xmlns:r="http://schemas.openxmlformats.org/officeDocument/2006/relationships" xmlns:p="http://schemas.openxmlformats.org/presentationml/2006/main" xmlns:m="http://schemas.openxmlformats.org/officeDocument/2006/math" xmlns:a14="http://schemas.microsoft.com/office/drawing/2010/main" type="tx" showMasterSp="1" showMasterPhAnim="1">
+<p:sldLayout xmlns:a="http://schemas.openxmlformats.org/drawingml/2006/main" xmlns:r="http://schemas.openxmlformats.org/officeDocument/2006/relationships" xmlns:p="http://schemas.openxmlformats.org/presentationml/2006/main" type="tx">
   <p:cSld name="Title Only">
     <p:spTree>
       <p:nvGrpSpPr>
@@ -1362,7 +1349,7 @@
           <p:cNvPr id="57" name="Title Text"/>
           <p:cNvSpPr txBox="1"/>
           <p:nvPr>
-            <p:ph type="title"/>
+            <p:ph type="title" hasCustomPrompt="1"/>
           </p:nvPr>
         </p:nvSpPr>
         <p:spPr>
@@ -1378,7 +1365,6 @@
           <a:bodyPr/>
           <a:lstStyle/>
           <a:p>
-            <a:pPr/>
             <a:r>
               <a:t>Title Text</a:t>
             </a:r>
@@ -1402,8 +1388,10 @@
           <a:bodyPr/>
           <a:lstStyle/>
           <a:p>
-            <a:pPr/>
-            <a:fld id="{86CB4B4D-7CA3-9044-876B-883B54F8677D}" type="slidenum"/>
+            <a:fld id="{86CB4B4D-7CA3-9044-876B-883B54F8677D}" type="slidenum">
+              <a:rPr/>
+            </a:fld>
+            <a:endParaRPr/>
           </a:p>
         </p:txBody>
       </p:sp>
@@ -1412,12 +1400,12 @@
   <p:clrMapOvr>
     <a:masterClrMapping/>
   </p:clrMapOvr>
-  <p:transition xmlns:p14="http://schemas.microsoft.com/office/powerpoint/2010/main" spd="med" advClick="1"/>
+  <p:transition spd="med"/>
 </p:sldLayout>
 </file>
 
 <file path=ppt/slideLayouts/slideLayout7.xml><?xml version="1.0" encoding="utf-8"?>
-<p:sldLayout xmlns:a="http://schemas.openxmlformats.org/drawingml/2006/main" xmlns:r="http://schemas.openxmlformats.org/officeDocument/2006/relationships" xmlns:p="http://schemas.openxmlformats.org/presentationml/2006/main" xmlns:m="http://schemas.openxmlformats.org/officeDocument/2006/math" xmlns:a14="http://schemas.microsoft.com/office/drawing/2010/main" type="tx" showMasterSp="1" showMasterPhAnim="1">
+<p:sldLayout xmlns:a="http://schemas.openxmlformats.org/drawingml/2006/main" xmlns:r="http://schemas.openxmlformats.org/officeDocument/2006/relationships" xmlns:p="http://schemas.openxmlformats.org/presentationml/2006/main" type="tx">
   <p:cSld name="Blank">
     <p:spTree>
       <p:nvGrpSpPr>
@@ -1450,8 +1438,10 @@
           <a:bodyPr/>
           <a:lstStyle/>
           <a:p>
-            <a:pPr/>
-            <a:fld id="{86CB4B4D-7CA3-9044-876B-883B54F8677D}" type="slidenum"/>
+            <a:fld id="{86CB4B4D-7CA3-9044-876B-883B54F8677D}" type="slidenum">
+              <a:rPr/>
+            </a:fld>
+            <a:endParaRPr/>
           </a:p>
         </p:txBody>
       </p:sp>
@@ -1460,12 +1450,12 @@
   <p:clrMapOvr>
     <a:masterClrMapping/>
   </p:clrMapOvr>
-  <p:transition xmlns:p14="http://schemas.microsoft.com/office/powerpoint/2010/main" spd="med" advClick="1"/>
+  <p:transition spd="med"/>
 </p:sldLayout>
 </file>
 
 <file path=ppt/slideLayouts/slideLayout8.xml><?xml version="1.0" encoding="utf-8"?>
-<p:sldLayout xmlns:a="http://schemas.openxmlformats.org/drawingml/2006/main" xmlns:r="http://schemas.openxmlformats.org/officeDocument/2006/relationships" xmlns:p="http://schemas.openxmlformats.org/presentationml/2006/main" xmlns:m="http://schemas.openxmlformats.org/officeDocument/2006/math" xmlns:a14="http://schemas.microsoft.com/office/drawing/2010/main" type="tx" showMasterSp="1" showMasterPhAnim="1">
+<p:sldLayout xmlns:a="http://schemas.openxmlformats.org/drawingml/2006/main" xmlns:r="http://schemas.openxmlformats.org/officeDocument/2006/relationships" xmlns:p="http://schemas.openxmlformats.org/presentationml/2006/main" type="tx">
   <p:cSld name="Content with Caption">
     <p:spTree>
       <p:nvGrpSpPr>
@@ -1486,7 +1476,7 @@
           <p:cNvPr id="72" name="Title Text"/>
           <p:cNvSpPr txBox="1"/>
           <p:nvPr>
-            <p:ph type="title"/>
+            <p:ph type="title" hasCustomPrompt="1"/>
           </p:nvPr>
         </p:nvSpPr>
         <p:spPr>
@@ -1502,11 +1492,10 @@
           <a:bodyPr anchor="b"/>
           <a:lstStyle>
             <a:lvl1pPr algn="l">
-              <a:defRPr b="1" sz="2000"/>
+              <a:defRPr sz="2000" b="1"/>
             </a:lvl1pPr>
           </a:lstStyle>
           <a:p>
-            <a:pPr/>
             <a:r>
               <a:t>Title Text</a:t>
             </a:r>
@@ -1518,7 +1507,7 @@
           <p:cNvPr id="73" name="Body Level One…"/>
           <p:cNvSpPr txBox="1"/>
           <p:nvPr>
-            <p:ph type="body" sz="half" idx="1"/>
+            <p:ph type="body" sz="half" idx="1" hasCustomPrompt="1"/>
           </p:nvPr>
         </p:nvSpPr>
         <p:spPr>
@@ -1534,7 +1523,6 @@
           <a:bodyPr/>
           <a:lstStyle/>
           <a:p>
-            <a:pPr/>
             <a:r>
               <a:t>Body Level One</a:t>
             </a:r>
@@ -1615,8 +1603,10 @@
           <a:bodyPr/>
           <a:lstStyle/>
           <a:p>
-            <a:pPr/>
-            <a:fld id="{86CB4B4D-7CA3-9044-876B-883B54F8677D}" type="slidenum"/>
+            <a:fld id="{86CB4B4D-7CA3-9044-876B-883B54F8677D}" type="slidenum">
+              <a:rPr/>
+            </a:fld>
+            <a:endParaRPr/>
           </a:p>
         </p:txBody>
       </p:sp>
@@ -1625,12 +1615,12 @@
   <p:clrMapOvr>
     <a:masterClrMapping/>
   </p:clrMapOvr>
-  <p:transition xmlns:p14="http://schemas.microsoft.com/office/powerpoint/2010/main" spd="med" advClick="1"/>
+  <p:transition spd="med"/>
 </p:sldLayout>
 </file>
 
 <file path=ppt/slideLayouts/slideLayout9.xml><?xml version="1.0" encoding="utf-8"?>
-<p:sldLayout xmlns:a="http://schemas.openxmlformats.org/drawingml/2006/main" xmlns:r="http://schemas.openxmlformats.org/officeDocument/2006/relationships" xmlns:p="http://schemas.openxmlformats.org/presentationml/2006/main" xmlns:m="http://schemas.openxmlformats.org/officeDocument/2006/math" xmlns:a14="http://schemas.microsoft.com/office/drawing/2010/main" type="tx" showMasterSp="1" showMasterPhAnim="1">
+<p:sldLayout xmlns:a="http://schemas.openxmlformats.org/drawingml/2006/main" xmlns:r="http://schemas.openxmlformats.org/officeDocument/2006/relationships" xmlns:p="http://schemas.openxmlformats.org/presentationml/2006/main" type="tx">
   <p:cSld name="Picture with Caption">
     <p:spTree>
       <p:nvGrpSpPr>
@@ -1651,7 +1641,7 @@
           <p:cNvPr id="82" name="Title Text"/>
           <p:cNvSpPr txBox="1"/>
           <p:nvPr>
-            <p:ph type="title"/>
+            <p:ph type="title" hasCustomPrompt="1"/>
           </p:nvPr>
         </p:nvSpPr>
         <p:spPr>
@@ -1667,11 +1657,10 @@
           <a:bodyPr anchor="b"/>
           <a:lstStyle>
             <a:lvl1pPr algn="l">
-              <a:defRPr b="1" sz="2000"/>
+              <a:defRPr sz="2000" b="1"/>
             </a:lvl1pPr>
           </a:lstStyle>
           <a:p>
-            <a:pPr/>
             <a:r>
               <a:t>Title Text</a:t>
             </a:r>
@@ -1700,9 +1689,7 @@
             <a:noAutofit/>
           </a:bodyPr>
           <a:lstStyle/>
-          <a:p>
-            <a:pPr/>
-          </a:p>
+          <a:p/>
         </p:txBody>
       </p:sp>
       <p:sp>
@@ -1710,7 +1697,7 @@
           <p:cNvPr id="84" name="Body Level One…"/>
           <p:cNvSpPr txBox="1"/>
           <p:nvPr>
-            <p:ph type="body" sz="quarter" idx="1"/>
+            <p:ph type="body" sz="quarter" idx="1" hasCustomPrompt="1"/>
           </p:nvPr>
         </p:nvSpPr>
         <p:spPr>
@@ -1772,7 +1759,6 @@
             </a:lvl5pPr>
           </a:lstStyle>
           <a:p>
-            <a:pPr/>
             <a:r>
               <a:t>Body Level One</a:t>
             </a:r>
@@ -1820,8 +1806,10 @@
           <a:bodyPr/>
           <a:lstStyle/>
           <a:p>
-            <a:pPr/>
-            <a:fld id="{86CB4B4D-7CA3-9044-876B-883B54F8677D}" type="slidenum"/>
+            <a:fld id="{86CB4B4D-7CA3-9044-876B-883B54F8677D}" type="slidenum">
+              <a:rPr/>
+            </a:fld>
+            <a:endParaRPr/>
           </a:p>
         </p:txBody>
       </p:sp>
@@ -1830,18 +1818,19 @@
   <p:clrMapOvr>
     <a:masterClrMapping/>
   </p:clrMapOvr>
-  <p:transition xmlns:p14="http://schemas.microsoft.com/office/powerpoint/2010/main" spd="med" advClick="1"/>
+  <p:transition spd="med"/>
 </p:sldLayout>
 </file>
 
 <file path=ppt/slideMasters/slideMaster1.xml><?xml version="1.0" encoding="utf-8"?>
-<p:sldMaster xmlns:a="http://schemas.openxmlformats.org/drawingml/2006/main" xmlns:r="http://schemas.openxmlformats.org/officeDocument/2006/relationships" xmlns:p="http://schemas.openxmlformats.org/presentationml/2006/main" xmlns:m="http://schemas.openxmlformats.org/officeDocument/2006/math" xmlns:a14="http://schemas.microsoft.com/office/drawing/2010/main">
+<p:sldMaster xmlns:a="http://schemas.openxmlformats.org/drawingml/2006/main" xmlns:r="http://schemas.openxmlformats.org/officeDocument/2006/relationships" xmlns:p="http://schemas.openxmlformats.org/presentationml/2006/main">
   <p:cSld>
     <p:bg>
       <p:bgPr>
         <a:solidFill>
           <a:srgbClr val="FFFFFF"/>
         </a:solidFill>
+        <a:effectLst/>
       </p:bgPr>
     </p:bg>
     <p:spTree>
@@ -1877,19 +1866,13 @@
           <a:ln w="12700">
             <a:miter lim="400000"/>
           </a:ln>
-          <a:extLst>
-            <a:ext uri="{C572A759-6A51-4108-AA02-DFA0A04FC94B}">
-              <ma14:wrappingTextBoxFlag xmlns:ma14="http://schemas.microsoft.com/office/mac/drawingml/2011/main" val="1"/>
-            </a:ext>
-          </a:extLst>
         </p:spPr>
         <p:txBody>
           <a:bodyPr lIns="45719" rIns="45719" anchor="ctr">
-            <a:normAutofit fontScale="100000" lnSpcReduction="0"/>
+            <a:normAutofit/>
           </a:bodyPr>
           <a:lstStyle/>
           <a:p>
-            <a:pPr/>
             <a:r>
               <a:t>Title Text</a:t>
             </a:r>
@@ -1915,19 +1898,13 @@
           <a:ln w="12700">
             <a:miter lim="400000"/>
           </a:ln>
-          <a:extLst>
-            <a:ext uri="{C572A759-6A51-4108-AA02-DFA0A04FC94B}">
-              <ma14:wrappingTextBoxFlag xmlns:ma14="http://schemas.microsoft.com/office/mac/drawingml/2011/main" val="1"/>
-            </a:ext>
-          </a:extLst>
         </p:spPr>
         <p:txBody>
           <a:bodyPr lIns="45719" rIns="45719">
-            <a:normAutofit fontScale="100000" lnSpcReduction="0"/>
+            <a:normAutofit/>
           </a:bodyPr>
           <a:lstStyle/>
           <a:p>
-            <a:pPr/>
             <a:r>
               <a:t>Body Level One</a:t>
             </a:r>
@@ -1992,8 +1969,10 @@
             </a:lvl1pPr>
           </a:lstStyle>
           <a:p>
-            <a:pPr/>
-            <a:fld id="{86CB4B4D-7CA3-9044-876B-883B54F8677D}" type="slidenum"/>
+            <a:fld id="{86CB4B4D-7CA3-9044-876B-883B54F8677D}" type="slidenum">
+              <a:rPr/>
+            </a:fld>
+            <a:endParaRPr/>
           </a:p>
         </p:txBody>
       </p:sp>
@@ -2001,17 +1980,17 @@
   </p:cSld>
   <p:clrMap bg1="lt1" tx1="dk1" bg2="lt2" tx2="dk2" accent1="accent1" accent2="accent2" accent3="accent3" accent4="accent4" accent5="accent5" accent6="accent6" hlink="hlink" folHlink="folHlink"/>
   <p:sldLayoutIdLst>
-    <p:sldLayoutId id="2147483649" r:id="rId2"/>
-    <p:sldLayoutId id="2147483650" r:id="rId3"/>
-    <p:sldLayoutId id="2147483651" r:id="rId4"/>
-    <p:sldLayoutId id="2147483652" r:id="rId5"/>
-    <p:sldLayoutId id="2147483653" r:id="rId6"/>
-    <p:sldLayoutId id="2147483654" r:id="rId7"/>
-    <p:sldLayoutId id="2147483655" r:id="rId8"/>
-    <p:sldLayoutId id="2147483656" r:id="rId9"/>
-    <p:sldLayoutId id="2147483657" r:id="rId10"/>
+    <p:sldLayoutId id="2147483649" r:id="rId1"/>
+    <p:sldLayoutId id="2147483650" r:id="rId2"/>
+    <p:sldLayoutId id="2147483651" r:id="rId3"/>
+    <p:sldLayoutId id="2147483652" r:id="rId4"/>
+    <p:sldLayoutId id="2147483653" r:id="rId5"/>
+    <p:sldLayoutId id="2147483654" r:id="rId6"/>
+    <p:sldLayoutId id="2147483655" r:id="rId7"/>
+    <p:sldLayoutId id="2147483656" r:id="rId8"/>
+    <p:sldLayoutId id="2147483657" r:id="rId9"/>
   </p:sldLayoutIdLst>
-  <p:transition xmlns:p14="http://schemas.microsoft.com/office/powerpoint/2010/main" spd="med" advClick="1"/>
+  <p:transition spd="med"/>
   <p:txStyles>
     <p:titleStyle>
       <a:lvl1pPr marL="0" marR="0" indent="0" algn="ctr" defTabSz="457200" rtl="0" latinLnBrk="0">
@@ -2028,8 +2007,7 @@
         <a:buSzTx/>
         <a:buFontTx/>
         <a:buNone/>
-        <a:tabLst/>
-        <a:defRPr b="0" baseline="0" cap="none" i="0" spc="0" strike="noStrike" sz="4400" u="none">
+        <a:defRPr sz="4400" b="0" i="0" u="none" strike="noStrike" cap="none" spc="0" baseline="0">
           <a:solidFill>
             <a:srgbClr val="000000"/>
           </a:solidFill>
@@ -2054,8 +2032,7 @@
         <a:buSzTx/>
         <a:buFontTx/>
         <a:buNone/>
-        <a:tabLst/>
-        <a:defRPr b="0" baseline="0" cap="none" i="0" spc="0" strike="noStrike" sz="4400" u="none">
+        <a:defRPr sz="4400" b="0" i="0" u="none" strike="noStrike" cap="none" spc="0" baseline="0">
           <a:solidFill>
             <a:srgbClr val="000000"/>
           </a:solidFill>
@@ -2080,8 +2057,7 @@
         <a:buSzTx/>
         <a:buFontTx/>
         <a:buNone/>
-        <a:tabLst/>
-        <a:defRPr b="0" baseline="0" cap="none" i="0" spc="0" strike="noStrike" sz="4400" u="none">
+        <a:defRPr sz="4400" b="0" i="0" u="none" strike="noStrike" cap="none" spc="0" baseline="0">
           <a:solidFill>
             <a:srgbClr val="000000"/>
           </a:solidFill>
@@ -2106,8 +2082,7 @@
         <a:buSzTx/>
         <a:buFontTx/>
         <a:buNone/>
-        <a:tabLst/>
-        <a:defRPr b="0" baseline="0" cap="none" i="0" spc="0" strike="noStrike" sz="4400" u="none">
+        <a:defRPr sz="4400" b="0" i="0" u="none" strike="noStrike" cap="none" spc="0" baseline="0">
           <a:solidFill>
             <a:srgbClr val="000000"/>
           </a:solidFill>
@@ -2132,8 +2107,7 @@
         <a:buSzTx/>
         <a:buFontTx/>
         <a:buNone/>
-        <a:tabLst/>
-        <a:defRPr b="0" baseline="0" cap="none" i="0" spc="0" strike="noStrike" sz="4400" u="none">
+        <a:defRPr sz="4400" b="0" i="0" u="none" strike="noStrike" cap="none" spc="0" baseline="0">
           <a:solidFill>
             <a:srgbClr val="000000"/>
           </a:solidFill>
@@ -2158,8 +2132,7 @@
         <a:buSzTx/>
         <a:buFontTx/>
         <a:buNone/>
-        <a:tabLst/>
-        <a:defRPr b="0" baseline="0" cap="none" i="0" spc="0" strike="noStrike" sz="4400" u="none">
+        <a:defRPr sz="4400" b="0" i="0" u="none" strike="noStrike" cap="none" spc="0" baseline="0">
           <a:solidFill>
             <a:srgbClr val="000000"/>
           </a:solidFill>
@@ -2184,8 +2157,7 @@
         <a:buSzTx/>
         <a:buFontTx/>
         <a:buNone/>
-        <a:tabLst/>
-        <a:defRPr b="0" baseline="0" cap="none" i="0" spc="0" strike="noStrike" sz="4400" u="none">
+        <a:defRPr sz="4400" b="0" i="0" u="none" strike="noStrike" cap="none" spc="0" baseline="0">
           <a:solidFill>
             <a:srgbClr val="000000"/>
           </a:solidFill>
@@ -2210,8 +2182,7 @@
         <a:buSzTx/>
         <a:buFontTx/>
         <a:buNone/>
-        <a:tabLst/>
-        <a:defRPr b="0" baseline="0" cap="none" i="0" spc="0" strike="noStrike" sz="4400" u="none">
+        <a:defRPr sz="4400" b="0" i="0" u="none" strike="noStrike" cap="none" spc="0" baseline="0">
           <a:solidFill>
             <a:srgbClr val="000000"/>
           </a:solidFill>
@@ -2236,8 +2207,7 @@
         <a:buSzTx/>
         <a:buFontTx/>
         <a:buNone/>
-        <a:tabLst/>
-        <a:defRPr b="0" baseline="0" cap="none" i="0" spc="0" strike="noStrike" sz="4400" u="none">
+        <a:defRPr sz="4400" b="0" i="0" u="none" strike="noStrike" cap="none" spc="0" baseline="0">
           <a:solidFill>
             <a:srgbClr val="000000"/>
           </a:solidFill>
@@ -2262,10 +2232,9 @@
         </a:spcAft>
         <a:buClrTx/>
         <a:buSzPct val="100000"/>
-        <a:buFont typeface="Arial"/>
+        <a:buFont typeface="Arial" panose="020B0604020202090204"/>
         <a:buChar char="•"/>
-        <a:tabLst/>
-        <a:defRPr b="0" baseline="0" cap="none" i="0" spc="0" strike="noStrike" sz="3200" u="none">
+        <a:defRPr sz="3200" b="0" i="0" u="none" strike="noStrike" cap="none" spc="0" baseline="0">
           <a:solidFill>
             <a:srgbClr val="000000"/>
           </a:solidFill>
@@ -2276,7 +2245,7 @@
           <a:sym typeface="Calibri"/>
         </a:defRPr>
       </a:lvl1pPr>
-      <a:lvl2pPr marL="783771" marR="0" indent="-326571" algn="l" defTabSz="457200" rtl="0" latinLnBrk="0">
+      <a:lvl2pPr marL="783590" marR="0" indent="-326390" algn="l" defTabSz="457200" rtl="0" latinLnBrk="0">
         <a:lnSpc>
           <a:spcPct val="100000"/>
         </a:lnSpc>
@@ -2288,10 +2257,9 @@
         </a:spcAft>
         <a:buClrTx/>
         <a:buSzPct val="100000"/>
-        <a:buFont typeface="Arial"/>
+        <a:buFont typeface="Arial" panose="020B0604020202090204"/>
         <a:buChar char="–"/>
-        <a:tabLst/>
-        <a:defRPr b="0" baseline="0" cap="none" i="0" spc="0" strike="noStrike" sz="3200" u="none">
+        <a:defRPr sz="3200" b="0" i="0" u="none" strike="noStrike" cap="none" spc="0" baseline="0">
           <a:solidFill>
             <a:srgbClr val="000000"/>
           </a:solidFill>
@@ -2314,10 +2282,9 @@
         </a:spcAft>
         <a:buClrTx/>
         <a:buSzPct val="100000"/>
-        <a:buFont typeface="Arial"/>
+        <a:buFont typeface="Arial" panose="020B0604020202090204"/>
         <a:buChar char="•"/>
-        <a:tabLst/>
-        <a:defRPr b="0" baseline="0" cap="none" i="0" spc="0" strike="noStrike" sz="3200" u="none">
+        <a:defRPr sz="3200" b="0" i="0" u="none" strike="noStrike" cap="none" spc="0" baseline="0">
           <a:solidFill>
             <a:srgbClr val="000000"/>
           </a:solidFill>
@@ -2340,10 +2307,9 @@
         </a:spcAft>
         <a:buClrTx/>
         <a:buSzPct val="100000"/>
-        <a:buFont typeface="Arial"/>
+        <a:buFont typeface="Arial" panose="020B0604020202090204"/>
         <a:buChar char="–"/>
-        <a:tabLst/>
-        <a:defRPr b="0" baseline="0" cap="none" i="0" spc="0" strike="noStrike" sz="3200" u="none">
+        <a:defRPr sz="3200" b="0" i="0" u="none" strike="noStrike" cap="none" spc="0" baseline="0">
           <a:solidFill>
             <a:srgbClr val="000000"/>
           </a:solidFill>
@@ -2366,10 +2332,9 @@
         </a:spcAft>
         <a:buClrTx/>
         <a:buSzPct val="100000"/>
-        <a:buFont typeface="Arial"/>
+        <a:buFont typeface="Arial" panose="020B0604020202090204"/>
         <a:buChar char="»"/>
-        <a:tabLst/>
-        <a:defRPr b="0" baseline="0" cap="none" i="0" spc="0" strike="noStrike" sz="3200" u="none">
+        <a:defRPr sz="3200" b="0" i="0" u="none" strike="noStrike" cap="none" spc="0" baseline="0">
           <a:solidFill>
             <a:srgbClr val="000000"/>
           </a:solidFill>
@@ -2392,10 +2357,9 @@
         </a:spcAft>
         <a:buClrTx/>
         <a:buSzPct val="100000"/>
-        <a:buFont typeface="Arial"/>
+        <a:buFont typeface="Arial" panose="020B0604020202090204"/>
         <a:buChar char="•"/>
-        <a:tabLst/>
-        <a:defRPr b="0" baseline="0" cap="none" i="0" spc="0" strike="noStrike" sz="3200" u="none">
+        <a:defRPr sz="3200" b="0" i="0" u="none" strike="noStrike" cap="none" spc="0" baseline="0">
           <a:solidFill>
             <a:srgbClr val="000000"/>
           </a:solidFill>
@@ -2418,10 +2382,9 @@
         </a:spcAft>
         <a:buClrTx/>
         <a:buSzPct val="100000"/>
-        <a:buFont typeface="Arial"/>
+        <a:buFont typeface="Arial" panose="020B0604020202090204"/>
         <a:buChar char="•"/>
-        <a:tabLst/>
-        <a:defRPr b="0" baseline="0" cap="none" i="0" spc="0" strike="noStrike" sz="3200" u="none">
+        <a:defRPr sz="3200" b="0" i="0" u="none" strike="noStrike" cap="none" spc="0" baseline="0">
           <a:solidFill>
             <a:srgbClr val="000000"/>
           </a:solidFill>
@@ -2432,7 +2395,7 @@
           <a:sym typeface="Calibri"/>
         </a:defRPr>
       </a:lvl7pPr>
-      <a:lvl8pPr marL="3566159" marR="0" indent="-365759" algn="l" defTabSz="457200" rtl="0" latinLnBrk="0">
+      <a:lvl8pPr marL="3566160" marR="0" indent="-365760" algn="l" defTabSz="457200" rtl="0" latinLnBrk="0">
         <a:lnSpc>
           <a:spcPct val="100000"/>
         </a:lnSpc>
@@ -2444,10 +2407,9 @@
         </a:spcAft>
         <a:buClrTx/>
         <a:buSzPct val="100000"/>
-        <a:buFont typeface="Arial"/>
+        <a:buFont typeface="Arial" panose="020B0604020202090204"/>
         <a:buChar char="•"/>
-        <a:tabLst/>
-        <a:defRPr b="0" baseline="0" cap="none" i="0" spc="0" strike="noStrike" sz="3200" u="none">
+        <a:defRPr sz="3200" b="0" i="0" u="none" strike="noStrike" cap="none" spc="0" baseline="0">
           <a:solidFill>
             <a:srgbClr val="000000"/>
           </a:solidFill>
@@ -2458,7 +2420,7 @@
           <a:sym typeface="Calibri"/>
         </a:defRPr>
       </a:lvl8pPr>
-      <a:lvl9pPr marL="4023359" marR="0" indent="-365759" algn="l" defTabSz="457200" rtl="0" latinLnBrk="0">
+      <a:lvl9pPr marL="4023360" marR="0" indent="-365760" algn="l" defTabSz="457200" rtl="0" latinLnBrk="0">
         <a:lnSpc>
           <a:spcPct val="100000"/>
         </a:lnSpc>
@@ -2470,10 +2432,9 @@
         </a:spcAft>
         <a:buClrTx/>
         <a:buSzPct val="100000"/>
-        <a:buFont typeface="Arial"/>
+        <a:buFont typeface="Arial" panose="020B0604020202090204"/>
         <a:buChar char="•"/>
-        <a:tabLst/>
-        <a:defRPr b="0" baseline="0" cap="none" i="0" spc="0" strike="noStrike" sz="3200" u="none">
+        <a:defRPr sz="3200" b="0" i="0" u="none" strike="noStrike" cap="none" spc="0" baseline="0">
           <a:solidFill>
             <a:srgbClr val="000000"/>
           </a:solidFill>
@@ -2500,8 +2461,7 @@
         <a:buSzTx/>
         <a:buFontTx/>
         <a:buNone/>
-        <a:tabLst/>
-        <a:defRPr b="0" baseline="0" cap="none" i="0" spc="0" strike="noStrike" sz="1200" u="none">
+        <a:defRPr sz="1200" b="0" i="0" u="none" strike="noStrike" cap="none" spc="0" baseline="0">
           <a:solidFill>
             <a:schemeClr val="tx1"/>
           </a:solidFill>
@@ -2526,8 +2486,7 @@
         <a:buSzTx/>
         <a:buFontTx/>
         <a:buNone/>
-        <a:tabLst/>
-        <a:defRPr b="0" baseline="0" cap="none" i="0" spc="0" strike="noStrike" sz="1200" u="none">
+        <a:defRPr sz="1200" b="0" i="0" u="none" strike="noStrike" cap="none" spc="0" baseline="0">
           <a:solidFill>
             <a:schemeClr val="tx1"/>
           </a:solidFill>
@@ -2552,8 +2511,7 @@
         <a:buSzTx/>
         <a:buFontTx/>
         <a:buNone/>
-        <a:tabLst/>
-        <a:defRPr b="0" baseline="0" cap="none" i="0" spc="0" strike="noStrike" sz="1200" u="none">
+        <a:defRPr sz="1200" b="0" i="0" u="none" strike="noStrike" cap="none" spc="0" baseline="0">
           <a:solidFill>
             <a:schemeClr val="tx1"/>
           </a:solidFill>
@@ -2578,8 +2536,7 @@
         <a:buSzTx/>
         <a:buFontTx/>
         <a:buNone/>
-        <a:tabLst/>
-        <a:defRPr b="0" baseline="0" cap="none" i="0" spc="0" strike="noStrike" sz="1200" u="none">
+        <a:defRPr sz="1200" b="0" i="0" u="none" strike="noStrike" cap="none" spc="0" baseline="0">
           <a:solidFill>
             <a:schemeClr val="tx1"/>
           </a:solidFill>
@@ -2604,8 +2561,7 @@
         <a:buSzTx/>
         <a:buFontTx/>
         <a:buNone/>
-        <a:tabLst/>
-        <a:defRPr b="0" baseline="0" cap="none" i="0" spc="0" strike="noStrike" sz="1200" u="none">
+        <a:defRPr sz="1200" b="0" i="0" u="none" strike="noStrike" cap="none" spc="0" baseline="0">
           <a:solidFill>
             <a:schemeClr val="tx1"/>
           </a:solidFill>
@@ -2630,8 +2586,7 @@
         <a:buSzTx/>
         <a:buFontTx/>
         <a:buNone/>
-        <a:tabLst/>
-        <a:defRPr b="0" baseline="0" cap="none" i="0" spc="0" strike="noStrike" sz="1200" u="none">
+        <a:defRPr sz="1200" b="0" i="0" u="none" strike="noStrike" cap="none" spc="0" baseline="0">
           <a:solidFill>
             <a:schemeClr val="tx1"/>
           </a:solidFill>
@@ -2656,8 +2611,7 @@
         <a:buSzTx/>
         <a:buFontTx/>
         <a:buNone/>
-        <a:tabLst/>
-        <a:defRPr b="0" baseline="0" cap="none" i="0" spc="0" strike="noStrike" sz="1200" u="none">
+        <a:defRPr sz="1200" b="0" i="0" u="none" strike="noStrike" cap="none" spc="0" baseline="0">
           <a:solidFill>
             <a:schemeClr val="tx1"/>
           </a:solidFill>
@@ -2682,8 +2636,7 @@
         <a:buSzTx/>
         <a:buFontTx/>
         <a:buNone/>
-        <a:tabLst/>
-        <a:defRPr b="0" baseline="0" cap="none" i="0" spc="0" strike="noStrike" sz="1200" u="none">
+        <a:defRPr sz="1200" b="0" i="0" u="none" strike="noStrike" cap="none" spc="0" baseline="0">
           <a:solidFill>
             <a:schemeClr val="tx1"/>
           </a:solidFill>
@@ -2708,8 +2661,7 @@
         <a:buSzTx/>
         <a:buFontTx/>
         <a:buNone/>
-        <a:tabLst/>
-        <a:defRPr b="0" baseline="0" cap="none" i="0" spc="0" strike="noStrike" sz="1200" u="none">
+        <a:defRPr sz="1200" b="0" i="0" u="none" strike="noStrike" cap="none" spc="0" baseline="0">
           <a:solidFill>
             <a:schemeClr val="tx1"/>
           </a:solidFill>
@@ -2726,13 +2678,14 @@
 </file>
 
 <file path=ppt/slides/slide1.xml><?xml version="1.0" encoding="utf-8"?>
-<p:sld xmlns:a="http://schemas.openxmlformats.org/drawingml/2006/main" xmlns:r="http://schemas.openxmlformats.org/officeDocument/2006/relationships" xmlns:p="http://schemas.openxmlformats.org/presentationml/2006/main" xmlns:m="http://schemas.openxmlformats.org/officeDocument/2006/math" xmlns:a14="http://schemas.microsoft.com/office/drawing/2010/main" showMasterSp="1" showMasterPhAnim="1">
+<p:sld xmlns:a="http://schemas.openxmlformats.org/drawingml/2006/main" xmlns:r="http://schemas.openxmlformats.org/officeDocument/2006/relationships" xmlns:p="http://schemas.openxmlformats.org/presentationml/2006/main">
   <p:cSld>
     <p:bg>
       <p:bgPr>
         <a:solidFill>
           <a:srgbClr val="132620"/>
         </a:solidFill>
+        <a:effectLst/>
       </p:bgPr>
     </p:bg>
     <p:spTree>
@@ -2769,7 +2722,7 @@
             </a:solidFill>
           </a:ln>
           <a:effectLst>
-            <a:outerShdw sx="100000" sy="100000" kx="0" ky="0" algn="b" rotWithShape="0" blurRad="38100" dist="23000" dir="5400000">
+            <a:outerShdw blurRad="38100" dist="23000" dir="5400000" rotWithShape="0">
               <a:srgbClr val="000000">
                 <a:alpha val="35000"/>
               </a:srgbClr>
@@ -2810,7 +2763,7 @@
             </a:solidFill>
           </a:ln>
           <a:effectLst>
-            <a:outerShdw sx="100000" sy="100000" kx="0" ky="0" algn="b" rotWithShape="0" blurRad="38100" dist="23000" dir="5400000">
+            <a:outerShdw blurRad="38100" dist="23000" dir="5400000" rotWithShape="0">
               <a:srgbClr val="000000">
                 <a:alpha val="35000"/>
               </a:srgbClr>
@@ -2851,7 +2804,7 @@
             </a:solidFill>
           </a:ln>
           <a:effectLst>
-            <a:outerShdw sx="100000" sy="100000" kx="0" ky="0" algn="b" rotWithShape="0" blurRad="38100" dist="23000" dir="5400000">
+            <a:outerShdw blurRad="38100" dist="23000" dir="5400000" rotWithShape="0">
               <a:srgbClr val="000000">
                 <a:alpha val="35000"/>
               </a:srgbClr>
@@ -2892,7 +2845,7 @@
             </a:solidFill>
           </a:ln>
           <a:effectLst>
-            <a:outerShdw sx="100000" sy="100000" kx="0" ky="0" algn="b" rotWithShape="0" blurRad="38100" dist="23000" dir="5400000">
+            <a:outerShdw blurRad="38100" dist="23000" dir="5400000" rotWithShape="0">
               <a:srgbClr val="000000">
                 <a:alpha val="35000"/>
               </a:srgbClr>
@@ -2930,11 +2883,6 @@
           <a:ln w="12700">
             <a:miter lim="400000"/>
           </a:ln>
-          <a:extLst>
-            <a:ext uri="{C572A759-6A51-4108-AA02-DFA0A04FC94B}">
-              <ma14:wrappingTextBoxFlag xmlns:ma14="http://schemas.microsoft.com/office/mac/drawingml/2011/main" val="1"/>
-            </a:ext>
-          </a:extLst>
         </p:spPr>
         <p:txBody>
           <a:bodyPr lIns="27432" tIns="27432" rIns="27432" bIns="27432">
@@ -2945,7 +2893,7 @@
               <a:spcBef>
                 <a:spcPts val="600"/>
               </a:spcBef>
-              <a:defRPr b="1" sz="1200">
+              <a:defRPr sz="1200" b="1">
                 <a:solidFill>
                   <a:srgbClr val="CAE270"/>
                 </a:solidFill>
@@ -2957,7 +2905,6 @@
             </a:lvl1pPr>
           </a:lstStyle>
           <a:p>
-            <a:pPr/>
             <a:r>
               <a:t>SEMINAR 2 / SEMINAR 1 ASSIGNMENT</a:t>
             </a:r>
@@ -2972,8 +2919,8 @@
         </p:nvSpPr>
         <p:spPr>
           <a:xfrm>
-            <a:off x="713231" y="1325880"/>
-            <a:ext cx="6986018" cy="1451865"/>
+            <a:off x="713105" y="1325880"/>
+            <a:ext cx="6986270" cy="816610"/>
           </a:xfrm>
           <a:prstGeom prst="rect">
             <a:avLst/>
@@ -2981,15 +2928,10 @@
           <a:ln w="12700">
             <a:miter lim="400000"/>
           </a:ln>
-          <a:extLst>
-            <a:ext uri="{C572A759-6A51-4108-AA02-DFA0A04FC94B}">
-              <ma14:wrappingTextBoxFlag xmlns:ma14="http://schemas.microsoft.com/office/mac/drawingml/2011/main" val="1"/>
-            </a:ext>
-          </a:extLst>
         </p:spPr>
         <p:txBody>
           <a:bodyPr lIns="27432" tIns="27432" rIns="27432" bIns="27432">
-            <a:spAutoFit/>
+            <a:noAutofit/>
           </a:bodyPr>
           <a:lstStyle/>
           <a:p>
@@ -2997,7 +2939,7 @@
               <a:spcBef>
                 <a:spcPts val="600"/>
               </a:spcBef>
-              <a:defRPr b="1" sz="4300">
+              <a:defRPr sz="4300" b="1">
                 <a:solidFill>
                   <a:srgbClr val="F7F2E0"/>
                 </a:solidFill>
@@ -3010,22 +2952,10 @@
             <a:r>
               <a:t>WILD</a:t>
             </a:r>
-          </a:p>
-          <a:p>
-            <a:pPr>
-              <a:spcBef>
-                <a:spcPts val="600"/>
-              </a:spcBef>
-              <a:defRPr b="1" sz="4300">
-                <a:solidFill>
-                  <a:srgbClr val="F7F2E0"/>
-                </a:solidFill>
-                <a:latin typeface="Aptos"/>
-                <a:ea typeface="Aptos"/>
-                <a:cs typeface="Aptos"/>
-                <a:sym typeface="Aptos"/>
-              </a:defRPr>
-            </a:pPr>
+            <a:r>
+              <a:rPr lang="en-US"/>
+              <a:t> </a:t>
+            </a:r>
             <a:r>
               <a:t>SIGNAL</a:t>
             </a:r>
@@ -3040,7 +2970,7 @@
         </p:nvSpPr>
         <p:spPr>
           <a:xfrm>
-            <a:off x="758951" y="3657600"/>
+            <a:off x="713231" y="2457450"/>
             <a:ext cx="6803137" cy="346965"/>
           </a:xfrm>
           <a:prstGeom prst="rect">
@@ -3049,11 +2979,6 @@
           <a:ln w="12700">
             <a:miter lim="400000"/>
           </a:ln>
-          <a:extLst>
-            <a:ext uri="{C572A759-6A51-4108-AA02-DFA0A04FC94B}">
-              <ma14:wrappingTextBoxFlag xmlns:ma14="http://schemas.microsoft.com/office/mac/drawingml/2011/main" val="1"/>
-            </a:ext>
-          </a:extLst>
         </p:spPr>
         <p:txBody>
           <a:bodyPr lIns="27432" tIns="27432" rIns="27432" bIns="27432">
@@ -3064,7 +2989,7 @@
               <a:spcBef>
                 <a:spcPts val="600"/>
               </a:spcBef>
-              <a:defRPr b="1" sz="1900">
+              <a:defRPr sz="1900" b="1">
                 <a:solidFill>
                   <a:srgbClr val="CAE270"/>
                 </a:solidFill>
@@ -3076,7 +3001,6 @@
             </a:lvl1pPr>
           </a:lstStyle>
           <a:p>
-            <a:pPr/>
             <a:r>
               <a:t>Ecology • Sound Art • Experimental Music</a:t>
             </a:r>
@@ -3091,7 +3015,7 @@
         </p:nvSpPr>
         <p:spPr>
           <a:xfrm>
-            <a:off x="758951" y="4389120"/>
+            <a:off x="689101" y="3199765"/>
             <a:ext cx="6894577" cy="613665"/>
           </a:xfrm>
           <a:prstGeom prst="rect">
@@ -3100,11 +3024,6 @@
           <a:ln w="12700">
             <a:miter lim="400000"/>
           </a:ln>
-          <a:extLst>
-            <a:ext uri="{C572A759-6A51-4108-AA02-DFA0A04FC94B}">
-              <ma14:wrappingTextBoxFlag xmlns:ma14="http://schemas.microsoft.com/office/mac/drawingml/2011/main" val="1"/>
-            </a:ext>
-          </a:extLst>
         </p:spPr>
         <p:txBody>
           <a:bodyPr lIns="27432" tIns="27432" rIns="27432" bIns="27432">
@@ -3168,11 +3087,6 @@
           <a:ln w="12700">
             <a:miter lim="400000"/>
           </a:ln>
-          <a:extLst>
-            <a:ext uri="{C572A759-6A51-4108-AA02-DFA0A04FC94B}">
-              <ma14:wrappingTextBoxFlag xmlns:ma14="http://schemas.microsoft.com/office/mac/drawingml/2011/main" val="1"/>
-            </a:ext>
-          </a:extLst>
         </p:spPr>
         <p:txBody>
           <a:bodyPr lIns="27432" tIns="27432" rIns="27432" bIns="27432">
@@ -3195,7 +3109,6 @@
             </a:lvl1pPr>
           </a:lstStyle>
           <a:p>
-            <a:pPr/>
             <a:r>
               <a:t>Festival concept, website UX, data and AI verification</a:t>
             </a:r>
@@ -3219,11 +3132,6 @@
           <a:ln w="12700">
             <a:miter lim="400000"/>
           </a:ln>
-          <a:extLst>
-            <a:ext uri="{C572A759-6A51-4108-AA02-DFA0A04FC94B}">
-              <ma14:wrappingTextBoxFlag xmlns:ma14="http://schemas.microsoft.com/office/mac/drawingml/2011/main" val="1"/>
-            </a:ext>
-          </a:extLst>
         </p:spPr>
         <p:txBody>
           <a:bodyPr lIns="27432" tIns="27432" rIns="27432" bIns="27432">
@@ -3234,7 +3142,7 @@
               <a:spcBef>
                 <a:spcPts val="600"/>
               </a:spcBef>
-              <a:defRPr b="1" sz="900">
+              <a:defRPr sz="900" b="1">
                 <a:solidFill>
                   <a:srgbClr val="BFCCBE"/>
                 </a:solidFill>
@@ -3246,7 +3154,6 @@
             </a:lvl1pPr>
           </a:lstStyle>
           <a:p>
-            <a:pPr/>
             <a:r>
               <a:t>WILD SIGNAL • SEMINAR 2</a:t>
             </a:r>
@@ -3270,11 +3177,6 @@
           <a:ln w="12700">
             <a:miter lim="400000"/>
           </a:ln>
-          <a:extLst>
-            <a:ext uri="{C572A759-6A51-4108-AA02-DFA0A04FC94B}">
-              <ma14:wrappingTextBoxFlag xmlns:ma14="http://schemas.microsoft.com/office/mac/drawingml/2011/main" val="1"/>
-            </a:ext>
-          </a:extLst>
         </p:spPr>
         <p:txBody>
           <a:bodyPr lIns="27432" tIns="27432" rIns="27432" bIns="27432">
@@ -3285,7 +3187,7 @@
               <a:spcBef>
                 <a:spcPts val="600"/>
               </a:spcBef>
-              <a:defRPr b="1" sz="900">
+              <a:defRPr sz="900" b="1">
                 <a:solidFill>
                   <a:srgbClr val="CAE270"/>
                 </a:solidFill>
@@ -3297,10 +3199,239 @@
             </a:lvl1pPr>
           </a:lstStyle>
           <a:p>
-            <a:pPr/>
             <a:r>
               <a:t>01</a:t>
             </a:r>
+          </a:p>
+        </p:txBody>
+      </p:sp>
+      <p:sp>
+        <p:nvSpPr>
+          <p:cNvPr id="2" name="Text Box 1"/>
+          <p:cNvSpPr txBox="1"/>
+          <p:nvPr/>
+        </p:nvSpPr>
+        <p:spPr>
+          <a:xfrm>
+            <a:off x="745490" y="4152265"/>
+            <a:ext cx="4059555" cy="951865"/>
+          </a:xfrm>
+          <a:prstGeom prst="rect">
+            <a:avLst/>
+          </a:prstGeom>
+          <a:noFill/>
+          <a:ln w="12700" cap="flat">
+            <a:noFill/>
+            <a:miter lim="400000"/>
+          </a:ln>
+        </p:spPr>
+        <p:style>
+          <a:lnRef idx="0">
+            <a:srgbClr val="FFFFFF"/>
+          </a:lnRef>
+          <a:fillRef idx="0">
+            <a:srgbClr val="FFFFFF"/>
+          </a:fillRef>
+          <a:effectRef idx="0">
+            <a:srgbClr val="FFFFFF"/>
+          </a:effectRef>
+          <a:fontRef idx="none"/>
+        </p:style>
+        <p:txBody>
+          <a:bodyPr rot="0" vertOverflow="overflow" horzOverflow="overflow" vert="horz" wrap="square" lIns="45719" tIns="45719" rIns="45719" bIns="45719" numCol="1" spcCol="38100" rtlCol="0" anchor="t" forceAA="0" upright="0">
+            <a:spAutoFit/>
+          </a:bodyPr>
+          <a:p>
+            <a:pPr marL="0" marR="0" indent="0" algn="l" defTabSz="457200" rtl="0" fontAlgn="auto" latinLnBrk="0" hangingPunct="0">
+              <a:lnSpc>
+                <a:spcPct val="100000"/>
+              </a:lnSpc>
+              <a:spcBef>
+                <a:spcPts val="0"/>
+              </a:spcBef>
+              <a:spcAft>
+                <a:spcPts val="0"/>
+              </a:spcAft>
+              <a:buClrTx/>
+              <a:buSzTx/>
+              <a:buFontTx/>
+              <a:buNone/>
+            </a:pPr>
+            <a:r>
+              <a:rPr kumimoji="0" lang="en-US" altLang="en-US" sz="1400" b="0" i="0" u="none" strike="noStrike" cap="none" spc="0" normalizeH="0" baseline="0">
+                <a:ln>
+                  <a:noFill/>
+                </a:ln>
+                <a:solidFill>
+                  <a:schemeClr val="bg1"/>
+                </a:solidFill>
+                <a:effectLst/>
+                <a:uFillTx/>
+                <a:latin typeface="+mn-lt"/>
+                <a:ea typeface="+mn-ea"/>
+                <a:cs typeface="+mn-cs"/>
+                <a:sym typeface="Calibri"/>
+              </a:rPr>
+              <a:t>Vishant Gohel (xgohv001)</a:t>
+            </a:r>
+            <a:endParaRPr kumimoji="0" lang="en-US" altLang="en-US" sz="1400" b="0" i="0" u="none" strike="noStrike" cap="none" spc="0" normalizeH="0" baseline="0">
+              <a:ln>
+                <a:noFill/>
+              </a:ln>
+              <a:solidFill>
+                <a:schemeClr val="bg1"/>
+              </a:solidFill>
+              <a:effectLst/>
+              <a:uFillTx/>
+              <a:latin typeface="+mn-lt"/>
+              <a:ea typeface="+mn-ea"/>
+              <a:cs typeface="+mn-cs"/>
+              <a:sym typeface="Calibri"/>
+            </a:endParaRPr>
+          </a:p>
+          <a:p>
+            <a:pPr marL="0" marR="0" indent="0" algn="l" defTabSz="457200" rtl="0" fontAlgn="auto" latinLnBrk="0" hangingPunct="0">
+              <a:lnSpc>
+                <a:spcPct val="100000"/>
+              </a:lnSpc>
+              <a:spcBef>
+                <a:spcPts val="0"/>
+              </a:spcBef>
+              <a:spcAft>
+                <a:spcPts val="0"/>
+              </a:spcAft>
+              <a:buClrTx/>
+              <a:buSzTx/>
+              <a:buFontTx/>
+              <a:buNone/>
+            </a:pPr>
+            <a:r>
+              <a:rPr kumimoji="0" lang="en-US" altLang="en-US" sz="1400" b="0" i="0" u="none" strike="noStrike" cap="none" spc="0" normalizeH="0" baseline="0">
+                <a:ln>
+                  <a:noFill/>
+                </a:ln>
+                <a:solidFill>
+                  <a:schemeClr val="bg1"/>
+                </a:solidFill>
+                <a:effectLst/>
+                <a:uFillTx/>
+                <a:latin typeface="+mn-lt"/>
+                <a:ea typeface="+mn-ea"/>
+                <a:cs typeface="+mn-cs"/>
+                <a:sym typeface="Calibri"/>
+              </a:rPr>
+              <a:t>Md Zahid Hasan (xhasm026)</a:t>
+            </a:r>
+            <a:endParaRPr kumimoji="0" lang="en-US" altLang="en-US" sz="1400" b="0" i="0" u="none" strike="noStrike" cap="none" spc="0" normalizeH="0" baseline="0">
+              <a:ln>
+                <a:noFill/>
+              </a:ln>
+              <a:solidFill>
+                <a:schemeClr val="bg1"/>
+              </a:solidFill>
+              <a:effectLst/>
+              <a:uFillTx/>
+              <a:latin typeface="+mn-lt"/>
+              <a:ea typeface="+mn-ea"/>
+              <a:cs typeface="+mn-cs"/>
+              <a:sym typeface="Calibri"/>
+            </a:endParaRPr>
+          </a:p>
+          <a:p>
+            <a:pPr marL="0" marR="0" indent="0" algn="l" defTabSz="457200" rtl="0" fontAlgn="auto" latinLnBrk="0" hangingPunct="0">
+              <a:lnSpc>
+                <a:spcPct val="100000"/>
+              </a:lnSpc>
+              <a:spcBef>
+                <a:spcPts val="0"/>
+              </a:spcBef>
+              <a:spcAft>
+                <a:spcPts val="0"/>
+              </a:spcAft>
+              <a:buClrTx/>
+              <a:buSzTx/>
+              <a:buFontTx/>
+              <a:buNone/>
+            </a:pPr>
+            <a:r>
+              <a:rPr kumimoji="0" lang="en-US" altLang="en-US" sz="1400" b="0" i="0" u="none" strike="noStrike" cap="none" spc="0" normalizeH="0" baseline="0">
+                <a:ln>
+                  <a:noFill/>
+                </a:ln>
+                <a:solidFill>
+                  <a:schemeClr val="bg1"/>
+                </a:solidFill>
+                <a:effectLst/>
+                <a:uFillTx/>
+                <a:latin typeface="+mn-lt"/>
+                <a:ea typeface="+mn-ea"/>
+                <a:cs typeface="+mn-cs"/>
+                <a:sym typeface="Calibri"/>
+              </a:rPr>
+              <a:t>Kyaw Sithu (xsitk004)</a:t>
+            </a:r>
+            <a:endParaRPr kumimoji="0" lang="en-US" altLang="en-US" sz="1400" b="0" i="0" u="none" strike="noStrike" cap="none" spc="0" normalizeH="0" baseline="0">
+              <a:ln>
+                <a:noFill/>
+              </a:ln>
+              <a:solidFill>
+                <a:schemeClr val="bg1"/>
+              </a:solidFill>
+              <a:effectLst/>
+              <a:uFillTx/>
+              <a:latin typeface="+mn-lt"/>
+              <a:ea typeface="+mn-ea"/>
+              <a:cs typeface="+mn-cs"/>
+              <a:sym typeface="Calibri"/>
+            </a:endParaRPr>
+          </a:p>
+          <a:p>
+            <a:pPr marL="0" marR="0" indent="0" algn="l" defTabSz="457200" rtl="0" fontAlgn="auto" latinLnBrk="0" hangingPunct="0">
+              <a:lnSpc>
+                <a:spcPct val="100000"/>
+              </a:lnSpc>
+              <a:spcBef>
+                <a:spcPts val="0"/>
+              </a:spcBef>
+              <a:spcAft>
+                <a:spcPts val="0"/>
+              </a:spcAft>
+              <a:buClrTx/>
+              <a:buSzTx/>
+              <a:buFontTx/>
+              <a:buNone/>
+            </a:pPr>
+            <a:r>
+              <a:rPr kumimoji="0" lang="en-US" altLang="en-US" sz="1400" b="0" i="0" u="none" strike="noStrike" cap="none" spc="0" normalizeH="0" baseline="0">
+                <a:ln>
+                  <a:noFill/>
+                </a:ln>
+                <a:solidFill>
+                  <a:schemeClr val="bg1"/>
+                </a:solidFill>
+                <a:effectLst/>
+                <a:uFillTx/>
+                <a:latin typeface="+mn-lt"/>
+                <a:ea typeface="+mn-ea"/>
+                <a:cs typeface="+mn-cs"/>
+                <a:sym typeface="Calibri"/>
+              </a:rPr>
+              <a:t>Davit Tsintskiladze (xtsid001)</a:t>
+            </a:r>
+            <a:endParaRPr kumimoji="0" lang="en-US" altLang="en-US" sz="1400" b="0" i="0" u="none" strike="noStrike" cap="none" spc="0" normalizeH="0" baseline="0">
+              <a:ln>
+                <a:noFill/>
+              </a:ln>
+              <a:solidFill>
+                <a:schemeClr val="bg1"/>
+              </a:solidFill>
+              <a:effectLst/>
+              <a:uFillTx/>
+              <a:latin typeface="+mn-lt"/>
+              <a:ea typeface="+mn-ea"/>
+              <a:cs typeface="+mn-cs"/>
+              <a:sym typeface="Calibri"/>
+            </a:endParaRPr>
           </a:p>
         </p:txBody>
       </p:sp>
@@ -3309,18 +3440,19 @@
   <p:clrMapOvr>
     <a:masterClrMapping/>
   </p:clrMapOvr>
-  <p:transition xmlns:p14="http://schemas.microsoft.com/office/powerpoint/2010/main" spd="med" advClick="1"/>
+  <p:transition spd="med"/>
 </p:sld>
 </file>
 
 <file path=ppt/slides/slide2.xml><?xml version="1.0" encoding="utf-8"?>
-<p:sld xmlns:a="http://schemas.openxmlformats.org/drawingml/2006/main" xmlns:r="http://schemas.openxmlformats.org/officeDocument/2006/relationships" xmlns:p="http://schemas.openxmlformats.org/presentationml/2006/main" xmlns:m="http://schemas.openxmlformats.org/officeDocument/2006/math" xmlns:a14="http://schemas.microsoft.com/office/drawing/2010/main" showMasterSp="1" showMasterPhAnim="1">
+<p:sld xmlns:a="http://schemas.openxmlformats.org/drawingml/2006/main" xmlns:r="http://schemas.openxmlformats.org/officeDocument/2006/relationships" xmlns:p="http://schemas.openxmlformats.org/presentationml/2006/main">
   <p:cSld>
     <p:bg>
       <p:bgPr>
         <a:solidFill>
           <a:srgbClr val="132620"/>
         </a:solidFill>
+        <a:effectLst/>
       </p:bgPr>
     </p:bg>
     <p:spTree>
@@ -3354,11 +3486,6 @@
           <a:ln w="12700">
             <a:miter lim="400000"/>
           </a:ln>
-          <a:extLst>
-            <a:ext uri="{C572A759-6A51-4108-AA02-DFA0A04FC94B}">
-              <ma14:wrappingTextBoxFlag xmlns:ma14="http://schemas.microsoft.com/office/mac/drawingml/2011/main" val="1"/>
-            </a:ext>
-          </a:extLst>
         </p:spPr>
         <p:txBody>
           <a:bodyPr lIns="27432" tIns="27432" rIns="27432" bIns="27432">
@@ -3369,7 +3496,7 @@
               <a:spcBef>
                 <a:spcPts val="600"/>
               </a:spcBef>
-              <a:defRPr b="1" sz="1100">
+              <a:defRPr sz="1100" b="1">
                 <a:solidFill>
                   <a:srgbClr val="CAE270"/>
                 </a:solidFill>
@@ -3381,7 +3508,6 @@
             </a:lvl1pPr>
           </a:lstStyle>
           <a:p>
-            <a:pPr/>
             <a:r>
               <a:t>02 / FESTIVAL &amp; PURPOSE</a:t>
             </a:r>
@@ -3405,11 +3531,6 @@
           <a:ln w="12700">
             <a:miter lim="400000"/>
           </a:ln>
-          <a:extLst>
-            <a:ext uri="{C572A759-6A51-4108-AA02-DFA0A04FC94B}">
-              <ma14:wrappingTextBoxFlag xmlns:ma14="http://schemas.microsoft.com/office/mac/drawingml/2011/main" val="1"/>
-            </a:ext>
-          </a:extLst>
         </p:spPr>
         <p:txBody>
           <a:bodyPr lIns="27432" tIns="27432" rIns="27432" bIns="27432">
@@ -3420,7 +3541,7 @@
               <a:spcBef>
                 <a:spcPts val="600"/>
               </a:spcBef>
-              <a:defRPr b="1" sz="2800">
+              <a:defRPr sz="2800" b="1">
                 <a:solidFill>
                   <a:srgbClr val="F7F2E0"/>
                 </a:solidFill>
@@ -3432,7 +3553,6 @@
             </a:lvl1pPr>
           </a:lstStyle>
           <a:p>
-            <a:pPr/>
             <a:r>
               <a:t>A festival about listening to the natural world</a:t>
             </a:r>
@@ -3456,11 +3576,6 @@
           <a:ln w="12700">
             <a:miter lim="400000"/>
           </a:ln>
-          <a:extLst>
-            <a:ext uri="{C572A759-6A51-4108-AA02-DFA0A04FC94B}">
-              <ma14:wrappingTextBoxFlag xmlns:ma14="http://schemas.microsoft.com/office/mac/drawingml/2011/main" val="1"/>
-            </a:ext>
-          </a:extLst>
         </p:spPr>
         <p:txBody>
           <a:bodyPr lIns="27432" tIns="27432" rIns="27432" bIns="27432">
@@ -3483,7 +3598,6 @@
             </a:lvl1pPr>
           </a:lstStyle>
           <a:p>
-            <a:pPr/>
             <a:r>
               <a:t>WILD SIGNAL is fictional; the venue names are part of our concept.</a:t>
             </a:r>
@@ -3507,11 +3621,6 @@
           <a:ln w="12700">
             <a:miter lim="400000"/>
           </a:ln>
-          <a:extLst>
-            <a:ext uri="{C572A759-6A51-4108-AA02-DFA0A04FC94B}">
-              <ma14:wrappingTextBoxFlag xmlns:ma14="http://schemas.microsoft.com/office/mac/drawingml/2011/main" val="1"/>
-            </a:ext>
-          </a:extLst>
         </p:spPr>
         <p:txBody>
           <a:bodyPr lIns="27432" tIns="27432" rIns="27432" bIns="27432">
@@ -3522,7 +3631,7 @@
               <a:spcBef>
                 <a:spcPts val="600"/>
               </a:spcBef>
-              <a:defRPr b="1" sz="900">
+              <a:defRPr sz="900" b="1">
                 <a:solidFill>
                   <a:srgbClr val="BFCCBE"/>
                 </a:solidFill>
@@ -3534,7 +3643,6 @@
             </a:lvl1pPr>
           </a:lstStyle>
           <a:p>
-            <a:pPr/>
             <a:r>
               <a:t>WILD SIGNAL • SEMINAR 2</a:t>
             </a:r>
@@ -3558,11 +3666,6 @@
           <a:ln w="12700">
             <a:miter lim="400000"/>
           </a:ln>
-          <a:extLst>
-            <a:ext uri="{C572A759-6A51-4108-AA02-DFA0A04FC94B}">
-              <ma14:wrappingTextBoxFlag xmlns:ma14="http://schemas.microsoft.com/office/mac/drawingml/2011/main" val="1"/>
-            </a:ext>
-          </a:extLst>
         </p:spPr>
         <p:txBody>
           <a:bodyPr lIns="27432" tIns="27432" rIns="27432" bIns="27432">
@@ -3573,7 +3676,7 @@
               <a:spcBef>
                 <a:spcPts val="600"/>
               </a:spcBef>
-              <a:defRPr b="1" sz="900">
+              <a:defRPr sz="900" b="1">
                 <a:solidFill>
                   <a:srgbClr val="CAE270"/>
                 </a:solidFill>
@@ -3585,7 +3688,6 @@
             </a:lvl1pPr>
           </a:lstStyle>
           <a:p>
-            <a:pPr/>
             <a:r>
               <a:t>02</a:t>
             </a:r>
@@ -3617,7 +3719,7 @@
             </a:solidFill>
           </a:ln>
           <a:effectLst>
-            <a:outerShdw sx="100000" sy="100000" kx="0" ky="0" algn="b" rotWithShape="0" blurRad="38100" dist="23000" dir="5400000">
+            <a:outerShdw blurRad="38100" dist="23000" dir="5400000" rotWithShape="0">
               <a:srgbClr val="000000">
                 <a:alpha val="35000"/>
               </a:srgbClr>
@@ -3661,7 +3763,7 @@
             </a:solidFill>
           </a:ln>
           <a:effectLst>
-            <a:outerShdw sx="100000" sy="100000" kx="0" ky="0" algn="b" rotWithShape="0" blurRad="38100" dist="23000" dir="5400000">
+            <a:outerShdw blurRad="38100" dist="23000" dir="5400000" rotWithShape="0">
               <a:srgbClr val="000000">
                 <a:alpha val="35000"/>
               </a:srgbClr>
@@ -3699,11 +3801,6 @@
           <a:ln w="12700">
             <a:miter lim="400000"/>
           </a:ln>
-          <a:extLst>
-            <a:ext uri="{C572A759-6A51-4108-AA02-DFA0A04FC94B}">
-              <ma14:wrappingTextBoxFlag xmlns:ma14="http://schemas.microsoft.com/office/mac/drawingml/2011/main" val="1"/>
-            </a:ext>
-          </a:extLst>
         </p:spPr>
         <p:txBody>
           <a:bodyPr lIns="27432" tIns="27432" rIns="27432" bIns="27432">
@@ -3714,7 +3811,7 @@
               <a:spcBef>
                 <a:spcPts val="600"/>
               </a:spcBef>
-              <a:defRPr b="1" sz="1600">
+              <a:defRPr sz="1600" b="1">
                 <a:solidFill>
                   <a:srgbClr val="CAE270"/>
                 </a:solidFill>
@@ -3726,7 +3823,6 @@
             </a:lvl1pPr>
           </a:lstStyle>
           <a:p>
-            <a:pPr/>
             <a:r>
               <a:t>THE FESTIVAL</a:t>
             </a:r>
@@ -3750,11 +3846,6 @@
           <a:ln w="12700">
             <a:miter lim="400000"/>
           </a:ln>
-          <a:extLst>
-            <a:ext uri="{C572A759-6A51-4108-AA02-DFA0A04FC94B}">
-              <ma14:wrappingTextBoxFlag xmlns:ma14="http://schemas.microsoft.com/office/mac/drawingml/2011/main" val="1"/>
-            </a:ext>
-          </a:extLst>
         </p:spPr>
         <p:txBody>
           <a:bodyPr lIns="27432" tIns="27432" rIns="27432" bIns="27432">
@@ -3777,7 +3868,6 @@
             </a:lvl1pPr>
           </a:lstStyle>
           <a:p>
-            <a:pPr/>
             <a:r>
               <a:t>A three-day festival combining ecology, sound art, field recording, experimental music, and environmental storytelling.</a:t>
             </a:r>
@@ -3809,7 +3899,7 @@
             </a:solidFill>
           </a:ln>
           <a:effectLst>
-            <a:outerShdw sx="100000" sy="100000" kx="0" ky="0" algn="b" rotWithShape="0" blurRad="38100" dist="23000" dir="5400000">
+            <a:outerShdw blurRad="38100" dist="23000" dir="5400000" rotWithShape="0">
               <a:srgbClr val="000000">
                 <a:alpha val="35000"/>
               </a:srgbClr>
@@ -3853,7 +3943,7 @@
             </a:solidFill>
           </a:ln>
           <a:effectLst>
-            <a:outerShdw sx="100000" sy="100000" kx="0" ky="0" algn="b" rotWithShape="0" blurRad="38100" dist="23000" dir="5400000">
+            <a:outerShdw blurRad="38100" dist="23000" dir="5400000" rotWithShape="0">
               <a:srgbClr val="000000">
                 <a:alpha val="35000"/>
               </a:srgbClr>
@@ -3891,11 +3981,6 @@
           <a:ln w="12700">
             <a:miter lim="400000"/>
           </a:ln>
-          <a:extLst>
-            <a:ext uri="{C572A759-6A51-4108-AA02-DFA0A04FC94B}">
-              <ma14:wrappingTextBoxFlag xmlns:ma14="http://schemas.microsoft.com/office/mac/drawingml/2011/main" val="1"/>
-            </a:ext>
-          </a:extLst>
         </p:spPr>
         <p:txBody>
           <a:bodyPr lIns="27432" tIns="27432" rIns="27432" bIns="27432">
@@ -3906,7 +3991,7 @@
               <a:spcBef>
                 <a:spcPts val="600"/>
               </a:spcBef>
-              <a:defRPr b="1" sz="1600">
+              <a:defRPr sz="1600" b="1">
                 <a:solidFill>
                   <a:srgbClr val="EB9D69"/>
                 </a:solidFill>
@@ -3918,7 +4003,6 @@
             </a:lvl1pPr>
           </a:lstStyle>
           <a:p>
-            <a:pPr/>
             <a:r>
               <a:t>THE WEBSITE</a:t>
             </a:r>
@@ -3942,11 +4026,6 @@
           <a:ln w="12700">
             <a:miter lim="400000"/>
           </a:ln>
-          <a:extLst>
-            <a:ext uri="{C572A759-6A51-4108-AA02-DFA0A04FC94B}">
-              <ma14:wrappingTextBoxFlag xmlns:ma14="http://schemas.microsoft.com/office/mac/drawingml/2011/main" val="1"/>
-            </a:ext>
-          </a:extLst>
         </p:spPr>
         <p:txBody>
           <a:bodyPr lIns="27432" tIns="27432" rIns="27432" bIns="27432">
@@ -3969,7 +4048,6 @@
             </a:lvl1pPr>
           </a:lstStyle>
           <a:p>
-            <a:pPr/>
             <a:r>
               <a:t>Help visitors discover events, explore performers and stages, find practical information, and plan their festival day.</a:t>
             </a:r>
@@ -4001,7 +4079,7 @@
             </a:solidFill>
           </a:ln>
           <a:effectLst>
-            <a:outerShdw sx="100000" sy="100000" kx="0" ky="0" algn="b" rotWithShape="0" blurRad="38100" dist="23000" dir="5400000">
+            <a:outerShdw blurRad="38100" dist="23000" dir="5400000" rotWithShape="0">
               <a:srgbClr val="000000">
                 <a:alpha val="35000"/>
               </a:srgbClr>
@@ -4045,7 +4123,7 @@
             </a:solidFill>
           </a:ln>
           <a:effectLst>
-            <a:outerShdw sx="100000" sy="100000" kx="0" ky="0" algn="b" rotWithShape="0" blurRad="38100" dist="23000" dir="5400000">
+            <a:outerShdw blurRad="38100" dist="23000" dir="5400000" rotWithShape="0">
               <a:srgbClr val="000000">
                 <a:alpha val="35000"/>
               </a:srgbClr>
@@ -4083,11 +4161,6 @@
           <a:ln w="12700">
             <a:miter lim="400000"/>
           </a:ln>
-          <a:extLst>
-            <a:ext uri="{C572A759-6A51-4108-AA02-DFA0A04FC94B}">
-              <ma14:wrappingTextBoxFlag xmlns:ma14="http://schemas.microsoft.com/office/mac/drawingml/2011/main" val="1"/>
-            </a:ext>
-          </a:extLst>
         </p:spPr>
         <p:txBody>
           <a:bodyPr lIns="27432" tIns="27432" rIns="27432" bIns="27432">
@@ -4098,7 +4171,7 @@
               <a:spcBef>
                 <a:spcPts val="600"/>
               </a:spcBef>
-              <a:defRPr b="1" sz="1600">
+              <a:defRPr sz="1600" b="1">
                 <a:solidFill>
                   <a:srgbClr val="CAE270"/>
                 </a:solidFill>
@@ -4110,7 +4183,6 @@
             </a:lvl1pPr>
           </a:lstStyle>
           <a:p>
-            <a:pPr/>
             <a:r>
               <a:t>THE SETTING</a:t>
             </a:r>
@@ -4134,11 +4206,6 @@
           <a:ln w="12700">
             <a:miter lim="400000"/>
           </a:ln>
-          <a:extLst>
-            <a:ext uri="{C572A759-6A51-4108-AA02-DFA0A04FC94B}">
-              <ma14:wrappingTextBoxFlag xmlns:ma14="http://schemas.microsoft.com/office/mac/drawingml/2011/main" val="1"/>
-            </a:ext>
-          </a:extLst>
         </p:spPr>
         <p:txBody>
           <a:bodyPr lIns="27432" tIns="27432" rIns="27432" bIns="27432">
@@ -4161,7 +4228,6 @@
             </a:lvl1pPr>
           </a:lstStyle>
           <a:p>
-            <a:pPr/>
             <a:r>
               <a:t>Prague, 18–20 June 2027. Two fictional spaces: River Stage at Riverside Pavilion and Canopy Lab at the Old Greenhouse.</a:t>
             </a:r>
@@ -4185,11 +4251,6 @@
           <a:ln w="12700">
             <a:miter lim="400000"/>
           </a:ln>
-          <a:extLst>
-            <a:ext uri="{C572A759-6A51-4108-AA02-DFA0A04FC94B}">
-              <ma14:wrappingTextBoxFlag xmlns:ma14="http://schemas.microsoft.com/office/mac/drawingml/2011/main" val="1"/>
-            </a:ext>
-          </a:extLst>
         </p:spPr>
         <p:txBody>
           <a:bodyPr lIns="27432" tIns="27432" rIns="27432" bIns="27432">
@@ -4200,7 +4261,7 @@
               <a:spcBef>
                 <a:spcPts val="600"/>
               </a:spcBef>
-              <a:defRPr b="1" sz="1700">
+              <a:defRPr sz="1700" b="1">
                 <a:solidFill>
                   <a:srgbClr val="BFCCBE"/>
                 </a:solidFill>
@@ -4212,7 +4273,6 @@
             </a:lvl1pPr>
           </a:lstStyle>
           <a:p>
-            <a:pPr/>
             <a:r>
               <a:t>Main UX goal: make relevant information easy to find and understand.</a:t>
             </a:r>
@@ -4224,18 +4284,19 @@
   <p:clrMapOvr>
     <a:masterClrMapping/>
   </p:clrMapOvr>
-  <p:transition xmlns:p14="http://schemas.microsoft.com/office/powerpoint/2010/main" spd="med" advClick="1"/>
+  <p:transition spd="med"/>
 </p:sld>
 </file>
 
 <file path=ppt/slides/slide3.xml><?xml version="1.0" encoding="utf-8"?>
-<p:sld xmlns:a="http://schemas.openxmlformats.org/drawingml/2006/main" xmlns:r="http://schemas.openxmlformats.org/officeDocument/2006/relationships" xmlns:p="http://schemas.openxmlformats.org/presentationml/2006/main" xmlns:m="http://schemas.openxmlformats.org/officeDocument/2006/math" xmlns:a14="http://schemas.microsoft.com/office/drawing/2010/main" showMasterSp="1" showMasterPhAnim="1">
+<p:sld xmlns:a="http://schemas.openxmlformats.org/drawingml/2006/main" xmlns:r="http://schemas.openxmlformats.org/officeDocument/2006/relationships" xmlns:p="http://schemas.openxmlformats.org/presentationml/2006/main">
   <p:cSld>
     <p:bg>
       <p:bgPr>
         <a:solidFill>
           <a:srgbClr val="132620"/>
         </a:solidFill>
+        <a:effectLst/>
       </p:bgPr>
     </p:bg>
     <p:spTree>
@@ -4269,11 +4330,6 @@
           <a:ln w="12700">
             <a:miter lim="400000"/>
           </a:ln>
-          <a:extLst>
-            <a:ext uri="{C572A759-6A51-4108-AA02-DFA0A04FC94B}">
-              <ma14:wrappingTextBoxFlag xmlns:ma14="http://schemas.microsoft.com/office/mac/drawingml/2011/main" val="1"/>
-            </a:ext>
-          </a:extLst>
         </p:spPr>
         <p:txBody>
           <a:bodyPr lIns="27432" tIns="27432" rIns="27432" bIns="27432">
@@ -4284,7 +4340,7 @@
               <a:spcBef>
                 <a:spcPts val="600"/>
               </a:spcBef>
-              <a:defRPr b="1" sz="1100">
+              <a:defRPr sz="1100" b="1">
                 <a:solidFill>
                   <a:srgbClr val="CAE270"/>
                 </a:solidFill>
@@ -4296,7 +4352,6 @@
             </a:lvl1pPr>
           </a:lstStyle>
           <a:p>
-            <a:pPr/>
             <a:r>
               <a:t>03 / TARGET GROUPS</a:t>
             </a:r>
@@ -4320,11 +4375,6 @@
           <a:ln w="12700">
             <a:miter lim="400000"/>
           </a:ln>
-          <a:extLst>
-            <a:ext uri="{C572A759-6A51-4108-AA02-DFA0A04FC94B}">
-              <ma14:wrappingTextBoxFlag xmlns:ma14="http://schemas.microsoft.com/office/mac/drawingml/2011/main" val="1"/>
-            </a:ext>
-          </a:extLst>
         </p:spPr>
         <p:txBody>
           <a:bodyPr lIns="27432" tIns="27432" rIns="27432" bIns="27432">
@@ -4335,7 +4385,7 @@
               <a:spcBef>
                 <a:spcPts val="600"/>
               </a:spcBef>
-              <a:defRPr b="1" sz="2800">
+              <a:defRPr sz="2800" b="1">
                 <a:solidFill>
                   <a:srgbClr val="F7F2E0"/>
                 </a:solidFill>
@@ -4347,7 +4397,6 @@
             </a:lvl1pPr>
           </a:lstStyle>
           <a:p>
-            <a:pPr/>
             <a:r>
               <a:t>Different visitors, different information needs</a:t>
             </a:r>
@@ -4371,11 +4420,6 @@
           <a:ln w="12700">
             <a:miter lim="400000"/>
           </a:ln>
-          <a:extLst>
-            <a:ext uri="{C572A759-6A51-4108-AA02-DFA0A04FC94B}">
-              <ma14:wrappingTextBoxFlag xmlns:ma14="http://schemas.microsoft.com/office/mac/drawingml/2011/main" val="1"/>
-            </a:ext>
-          </a:extLst>
         </p:spPr>
         <p:txBody>
           <a:bodyPr lIns="27432" tIns="27432" rIns="27432" bIns="27432">
@@ -4398,7 +4442,6 @@
             </a:lvl1pPr>
           </a:lstStyle>
           <a:p>
-            <a:pPr/>
             <a:r>
               <a:t>The website should support quick decisions as well as exploration.</a:t>
             </a:r>
@@ -4422,11 +4465,6 @@
           <a:ln w="12700">
             <a:miter lim="400000"/>
           </a:ln>
-          <a:extLst>
-            <a:ext uri="{C572A759-6A51-4108-AA02-DFA0A04FC94B}">
-              <ma14:wrappingTextBoxFlag xmlns:ma14="http://schemas.microsoft.com/office/mac/drawingml/2011/main" val="1"/>
-            </a:ext>
-          </a:extLst>
         </p:spPr>
         <p:txBody>
           <a:bodyPr lIns="27432" tIns="27432" rIns="27432" bIns="27432">
@@ -4437,7 +4475,7 @@
               <a:spcBef>
                 <a:spcPts val="600"/>
               </a:spcBef>
-              <a:defRPr b="1" sz="900">
+              <a:defRPr sz="900" b="1">
                 <a:solidFill>
                   <a:srgbClr val="BFCCBE"/>
                 </a:solidFill>
@@ -4449,7 +4487,6 @@
             </a:lvl1pPr>
           </a:lstStyle>
           <a:p>
-            <a:pPr/>
             <a:r>
               <a:t>WILD SIGNAL • SEMINAR 2</a:t>
             </a:r>
@@ -4473,11 +4510,6 @@
           <a:ln w="12700">
             <a:miter lim="400000"/>
           </a:ln>
-          <a:extLst>
-            <a:ext uri="{C572A759-6A51-4108-AA02-DFA0A04FC94B}">
-              <ma14:wrappingTextBoxFlag xmlns:ma14="http://schemas.microsoft.com/office/mac/drawingml/2011/main" val="1"/>
-            </a:ext>
-          </a:extLst>
         </p:spPr>
         <p:txBody>
           <a:bodyPr lIns="27432" tIns="27432" rIns="27432" bIns="27432">
@@ -4488,7 +4520,7 @@
               <a:spcBef>
                 <a:spcPts val="600"/>
               </a:spcBef>
-              <a:defRPr b="1" sz="900">
+              <a:defRPr sz="900" b="1">
                 <a:solidFill>
                   <a:srgbClr val="CAE270"/>
                 </a:solidFill>
@@ -4500,7 +4532,6 @@
             </a:lvl1pPr>
           </a:lstStyle>
           <a:p>
-            <a:pPr/>
             <a:r>
               <a:t>03</a:t>
             </a:r>
@@ -4532,7 +4563,7 @@
             </a:solidFill>
           </a:ln>
           <a:effectLst>
-            <a:outerShdw sx="100000" sy="100000" kx="0" ky="0" algn="b" rotWithShape="0" blurRad="38100" dist="23000" dir="5400000">
+            <a:outerShdw blurRad="38100" dist="23000" dir="5400000" rotWithShape="0">
               <a:srgbClr val="000000">
                 <a:alpha val="35000"/>
               </a:srgbClr>
@@ -4576,7 +4607,7 @@
             </a:solidFill>
           </a:ln>
           <a:effectLst>
-            <a:outerShdw sx="100000" sy="100000" kx="0" ky="0" algn="b" rotWithShape="0" blurRad="38100" dist="23000" dir="5400000">
+            <a:outerShdw blurRad="38100" dist="23000" dir="5400000" rotWithShape="0">
               <a:srgbClr val="000000">
                 <a:alpha val="35000"/>
               </a:srgbClr>
@@ -4614,11 +4645,6 @@
           <a:ln w="12700">
             <a:miter lim="400000"/>
           </a:ln>
-          <a:extLst>
-            <a:ext uri="{C572A759-6A51-4108-AA02-DFA0A04FC94B}">
-              <ma14:wrappingTextBoxFlag xmlns:ma14="http://schemas.microsoft.com/office/mac/drawingml/2011/main" val="1"/>
-            </a:ext>
-          </a:extLst>
         </p:spPr>
         <p:txBody>
           <a:bodyPr lIns="27432" tIns="27432" rIns="27432" bIns="27432"/>
@@ -4627,7 +4653,7 @@
               <a:spcBef>
                 <a:spcPts val="600"/>
               </a:spcBef>
-              <a:defRPr b="1" sz="1600">
+              <a:defRPr sz="1600" b="1">
                 <a:solidFill>
                   <a:srgbClr val="CAE270"/>
                 </a:solidFill>
@@ -4639,7 +4665,6 @@
             </a:lvl1pPr>
           </a:lstStyle>
           <a:p>
-            <a:pPr/>
             <a:r>
               <a:t>FESTIVAL VISITORS</a:t>
             </a:r>
@@ -4663,11 +4688,6 @@
           <a:ln w="12700">
             <a:miter lim="400000"/>
           </a:ln>
-          <a:extLst>
-            <a:ext uri="{C572A759-6A51-4108-AA02-DFA0A04FC94B}">
-              <ma14:wrappingTextBoxFlag xmlns:ma14="http://schemas.microsoft.com/office/mac/drawingml/2011/main" val="1"/>
-            </a:ext>
-          </a:extLst>
         </p:spPr>
         <p:txBody>
           <a:bodyPr lIns="27432" tIns="27432" rIns="27432" bIns="27432"/>
@@ -4688,7 +4708,6 @@
             </a:lvl1pPr>
           </a:lstStyle>
           <a:p>
-            <a:pPr/>
             <a:r>
               <a:t>Browse by day and stage, compare events, and plan a personal schedule.</a:t>
             </a:r>
@@ -4720,7 +4739,7 @@
             </a:solidFill>
           </a:ln>
           <a:effectLst>
-            <a:outerShdw sx="100000" sy="100000" kx="0" ky="0" algn="b" rotWithShape="0" blurRad="38100" dist="23000" dir="5400000">
+            <a:outerShdw blurRad="38100" dist="23000" dir="5400000" rotWithShape="0">
               <a:srgbClr val="000000">
                 <a:alpha val="35000"/>
               </a:srgbClr>
@@ -4764,7 +4783,7 @@
             </a:solidFill>
           </a:ln>
           <a:effectLst>
-            <a:outerShdw sx="100000" sy="100000" kx="0" ky="0" algn="b" rotWithShape="0" blurRad="38100" dist="23000" dir="5400000">
+            <a:outerShdw blurRad="38100" dist="23000" dir="5400000" rotWithShape="0">
               <a:srgbClr val="000000">
                 <a:alpha val="35000"/>
               </a:srgbClr>
@@ -4802,11 +4821,6 @@
           <a:ln w="12700">
             <a:miter lim="400000"/>
           </a:ln>
-          <a:extLst>
-            <a:ext uri="{C572A759-6A51-4108-AA02-DFA0A04FC94B}">
-              <ma14:wrappingTextBoxFlag xmlns:ma14="http://schemas.microsoft.com/office/mac/drawingml/2011/main" val="1"/>
-            </a:ext>
-          </a:extLst>
         </p:spPr>
         <p:txBody>
           <a:bodyPr lIns="27432" tIns="27432" rIns="27432" bIns="27432"/>
@@ -4815,7 +4829,7 @@
               <a:spcBef>
                 <a:spcPts val="600"/>
               </a:spcBef>
-              <a:defRPr b="1" sz="1600">
+              <a:defRPr sz="1600" b="1">
                 <a:solidFill>
                   <a:srgbClr val="EB9D69"/>
                 </a:solidFill>
@@ -4827,7 +4841,6 @@
             </a:lvl1pPr>
           </a:lstStyle>
           <a:p>
-            <a:pPr/>
             <a:r>
               <a:t>MUSIC &amp; SOUND ART FANS</a:t>
             </a:r>
@@ -4851,11 +4864,6 @@
           <a:ln w="12700">
             <a:miter lim="400000"/>
           </a:ln>
-          <a:extLst>
-            <a:ext uri="{C572A759-6A51-4108-AA02-DFA0A04FC94B}">
-              <ma14:wrappingTextBoxFlag xmlns:ma14="http://schemas.microsoft.com/office/mac/drawingml/2011/main" val="1"/>
-            </a:ext>
-          </a:extLst>
         </p:spPr>
         <p:txBody>
           <a:bodyPr lIns="27432" tIns="27432" rIns="27432" bIns="27432"/>
@@ -4876,7 +4884,6 @@
             </a:lvl1pPr>
           </a:lstStyle>
           <a:p>
-            <a:pPr/>
             <a:r>
               <a:t>Discover performers, read short descriptions, and find their programme appearances.</a:t>
             </a:r>
@@ -4908,7 +4915,7 @@
             </a:solidFill>
           </a:ln>
           <a:effectLst>
-            <a:outerShdw sx="100000" sy="100000" kx="0" ky="0" algn="b" rotWithShape="0" blurRad="38100" dist="23000" dir="5400000">
+            <a:outerShdw blurRad="38100" dist="23000" dir="5400000" rotWithShape="0">
               <a:srgbClr val="000000">
                 <a:alpha val="35000"/>
               </a:srgbClr>
@@ -4952,7 +4959,7 @@
             </a:solidFill>
           </a:ln>
           <a:effectLst>
-            <a:outerShdw sx="100000" sy="100000" kx="0" ky="0" algn="b" rotWithShape="0" blurRad="38100" dist="23000" dir="5400000">
+            <a:outerShdw blurRad="38100" dist="23000" dir="5400000" rotWithShape="0">
               <a:srgbClr val="000000">
                 <a:alpha val="35000"/>
               </a:srgbClr>
@@ -4990,11 +4997,6 @@
           <a:ln w="12700">
             <a:miter lim="400000"/>
           </a:ln>
-          <a:extLst>
-            <a:ext uri="{C572A759-6A51-4108-AA02-DFA0A04FC94B}">
-              <ma14:wrappingTextBoxFlag xmlns:ma14="http://schemas.microsoft.com/office/mac/drawingml/2011/main" val="1"/>
-            </a:ext>
-          </a:extLst>
         </p:spPr>
         <p:txBody>
           <a:bodyPr lIns="27432" tIns="27432" rIns="27432" bIns="27432"/>
@@ -5003,7 +5005,7 @@
               <a:spcBef>
                 <a:spcPts val="600"/>
               </a:spcBef>
-              <a:defRPr b="1" sz="1600">
+              <a:defRPr sz="1600" b="1">
                 <a:solidFill>
                   <a:srgbClr val="CAE270"/>
                 </a:solidFill>
@@ -5015,7 +5017,6 @@
             </a:lvl1pPr>
           </a:lstStyle>
           <a:p>
-            <a:pPr/>
             <a:r>
               <a:t>FIRST-TIME VISITORS</a:t>
             </a:r>
@@ -5039,11 +5040,6 @@
           <a:ln w="12700">
             <a:miter lim="400000"/>
           </a:ln>
-          <a:extLst>
-            <a:ext uri="{C572A759-6A51-4108-AA02-DFA0A04FC94B}">
-              <ma14:wrappingTextBoxFlag xmlns:ma14="http://schemas.microsoft.com/office/mac/drawingml/2011/main" val="1"/>
-            </a:ext>
-          </a:extLst>
         </p:spPr>
         <p:txBody>
           <a:bodyPr lIns="27432" tIns="27432" rIns="27432" bIns="27432"/>
@@ -5064,7 +5060,6 @@
             </a:lvl1pPr>
           </a:lstStyle>
           <a:p>
-            <a:pPr/>
             <a:r>
               <a:t>Find venue details, dates, access information, and travel guidance.</a:t>
             </a:r>
@@ -5088,11 +5083,6 @@
           <a:ln w="12700">
             <a:miter lim="400000"/>
           </a:ln>
-          <a:extLst>
-            <a:ext uri="{C572A759-6A51-4108-AA02-DFA0A04FC94B}">
-              <ma14:wrappingTextBoxFlag xmlns:ma14="http://schemas.microsoft.com/office/mac/drawingml/2011/main" val="1"/>
-            </a:ext>
-          </a:extLst>
         </p:spPr>
         <p:txBody>
           <a:bodyPr lIns="27432" tIns="27432" rIns="27432" bIns="27432">
@@ -5103,7 +5093,7 @@
               <a:spcBef>
                 <a:spcPts val="600"/>
               </a:spcBef>
-              <a:defRPr b="1" sz="1400">
+              <a:defRPr sz="1400" b="1">
                 <a:solidFill>
                   <a:srgbClr val="BFCCBE"/>
                 </a:solidFill>
@@ -5115,7 +5105,6 @@
             </a:lvl1pPr>
           </a:lstStyle>
           <a:p>
-            <a:pPr/>
             <a:r>
               <a:t>Design implications: clear labels, useful filters, consistent event details, accessible practical information.</a:t>
             </a:r>
@@ -5127,18 +5116,19 @@
   <p:clrMapOvr>
     <a:masterClrMapping/>
   </p:clrMapOvr>
-  <p:transition xmlns:p14="http://schemas.microsoft.com/office/powerpoint/2010/main" spd="med" advClick="1"/>
+  <p:transition spd="med"/>
 </p:sld>
 </file>
 
 <file path=ppt/slides/slide4.xml><?xml version="1.0" encoding="utf-8"?>
-<p:sld xmlns:a="http://schemas.openxmlformats.org/drawingml/2006/main" xmlns:r="http://schemas.openxmlformats.org/officeDocument/2006/relationships" xmlns:p="http://schemas.openxmlformats.org/presentationml/2006/main" xmlns:m="http://schemas.openxmlformats.org/officeDocument/2006/math" xmlns:a14="http://schemas.microsoft.com/office/drawing/2010/main" showMasterSp="1" showMasterPhAnim="1">
+<p:sld xmlns:a="http://schemas.openxmlformats.org/drawingml/2006/main" xmlns:r="http://schemas.openxmlformats.org/officeDocument/2006/relationships" xmlns:p="http://schemas.openxmlformats.org/presentationml/2006/main">
   <p:cSld>
     <p:bg>
       <p:bgPr>
         <a:solidFill>
           <a:srgbClr val="132620"/>
         </a:solidFill>
+        <a:effectLst/>
       </p:bgPr>
     </p:bg>
     <p:spTree>
@@ -5172,11 +5162,6 @@
           <a:ln w="12700">
             <a:miter lim="400000"/>
           </a:ln>
-          <a:extLst>
-            <a:ext uri="{C572A759-6A51-4108-AA02-DFA0A04FC94B}">
-              <ma14:wrappingTextBoxFlag xmlns:ma14="http://schemas.microsoft.com/office/mac/drawingml/2011/main" val="1"/>
-            </a:ext>
-          </a:extLst>
         </p:spPr>
         <p:txBody>
           <a:bodyPr lIns="27432" tIns="27432" rIns="27432" bIns="27432">
@@ -5187,7 +5172,7 @@
               <a:spcBef>
                 <a:spcPts val="600"/>
               </a:spcBef>
-              <a:defRPr b="1" sz="1100">
+              <a:defRPr sz="1100" b="1">
                 <a:solidFill>
                   <a:srgbClr val="CAE270"/>
                 </a:solidFill>
@@ -5199,7 +5184,6 @@
             </a:lvl1pPr>
           </a:lstStyle>
           <a:p>
-            <a:pPr/>
             <a:r>
               <a:t>04 / INFORMATION ARCHITECTURE</a:t>
             </a:r>
@@ -5223,11 +5207,6 @@
           <a:ln w="12700">
             <a:miter lim="400000"/>
           </a:ln>
-          <a:extLst>
-            <a:ext uri="{C572A759-6A51-4108-AA02-DFA0A04FC94B}">
-              <ma14:wrappingTextBoxFlag xmlns:ma14="http://schemas.microsoft.com/office/mac/drawingml/2011/main" val="1"/>
-            </a:ext>
-          </a:extLst>
         </p:spPr>
         <p:txBody>
           <a:bodyPr lIns="27432" tIns="27432" rIns="27432" bIns="27432">
@@ -5238,7 +5217,7 @@
               <a:spcBef>
                 <a:spcPts val="600"/>
               </a:spcBef>
-              <a:defRPr b="1" sz="2800">
+              <a:defRPr sz="2800" b="1">
                 <a:solidFill>
                   <a:srgbClr val="F7F2E0"/>
                 </a:solidFill>
@@ -5250,7 +5229,6 @@
             </a:lvl1pPr>
           </a:lstStyle>
           <a:p>
-            <a:pPr/>
             <a:r>
               <a:t>A simple structure organised around visitor tasks</a:t>
             </a:r>
@@ -5274,11 +5252,6 @@
           <a:ln w="12700">
             <a:miter lim="400000"/>
           </a:ln>
-          <a:extLst>
-            <a:ext uri="{C572A759-6A51-4108-AA02-DFA0A04FC94B}">
-              <ma14:wrappingTextBoxFlag xmlns:ma14="http://schemas.microsoft.com/office/mac/drawingml/2011/main" val="1"/>
-            </a:ext>
-          </a:extLst>
         </p:spPr>
         <p:txBody>
           <a:bodyPr lIns="27432" tIns="27432" rIns="27432" bIns="27432">
@@ -5301,7 +5274,6 @@
             </a:lvl1pPr>
           </a:lstStyle>
           <a:p>
-            <a:pPr/>
             <a:r>
               <a:t>Main navigation groups content into predictable destinations.</a:t>
             </a:r>
@@ -5325,11 +5297,6 @@
           <a:ln w="12700">
             <a:miter lim="400000"/>
           </a:ln>
-          <a:extLst>
-            <a:ext uri="{C572A759-6A51-4108-AA02-DFA0A04FC94B}">
-              <ma14:wrappingTextBoxFlag xmlns:ma14="http://schemas.microsoft.com/office/mac/drawingml/2011/main" val="1"/>
-            </a:ext>
-          </a:extLst>
         </p:spPr>
         <p:txBody>
           <a:bodyPr lIns="27432" tIns="27432" rIns="27432" bIns="27432">
@@ -5340,7 +5307,7 @@
               <a:spcBef>
                 <a:spcPts val="600"/>
               </a:spcBef>
-              <a:defRPr b="1" sz="900">
+              <a:defRPr sz="900" b="1">
                 <a:solidFill>
                   <a:srgbClr val="BFCCBE"/>
                 </a:solidFill>
@@ -5352,7 +5319,6 @@
             </a:lvl1pPr>
           </a:lstStyle>
           <a:p>
-            <a:pPr/>
             <a:r>
               <a:t>WILD SIGNAL • SEMINAR 2</a:t>
             </a:r>
@@ -5376,11 +5342,6 @@
           <a:ln w="12700">
             <a:miter lim="400000"/>
           </a:ln>
-          <a:extLst>
-            <a:ext uri="{C572A759-6A51-4108-AA02-DFA0A04FC94B}">
-              <ma14:wrappingTextBoxFlag xmlns:ma14="http://schemas.microsoft.com/office/mac/drawingml/2011/main" val="1"/>
-            </a:ext>
-          </a:extLst>
         </p:spPr>
         <p:txBody>
           <a:bodyPr lIns="27432" tIns="27432" rIns="27432" bIns="27432">
@@ -5391,7 +5352,7 @@
               <a:spcBef>
                 <a:spcPts val="600"/>
               </a:spcBef>
-              <a:defRPr b="1" sz="900">
+              <a:defRPr sz="900" b="1">
                 <a:solidFill>
                   <a:srgbClr val="CAE270"/>
                 </a:solidFill>
@@ -5403,7 +5364,6 @@
             </a:lvl1pPr>
           </a:lstStyle>
           <a:p>
-            <a:pPr/>
             <a:r>
               <a:t>04</a:t>
             </a:r>
@@ -5435,7 +5395,7 @@
             </a:solidFill>
           </a:ln>
           <a:effectLst>
-            <a:outerShdw sx="100000" sy="100000" kx="0" ky="0" algn="b" rotWithShape="0" blurRad="38100" dist="23000" dir="5400000">
+            <a:outerShdw blurRad="38100" dist="23000" dir="5400000" rotWithShape="0">
               <a:srgbClr val="000000">
                 <a:alpha val="35000"/>
               </a:srgbClr>
@@ -5479,7 +5439,7 @@
             </a:solidFill>
           </a:ln>
           <a:effectLst>
-            <a:outerShdw sx="100000" sy="100000" kx="0" ky="0" algn="b" rotWithShape="0" blurRad="38100" dist="23000" dir="5400000">
+            <a:outerShdw blurRad="38100" dist="23000" dir="5400000" rotWithShape="0">
               <a:srgbClr val="000000">
                 <a:alpha val="35000"/>
               </a:srgbClr>
@@ -5517,11 +5477,6 @@
           <a:ln w="12700">
             <a:miter lim="400000"/>
           </a:ln>
-          <a:extLst>
-            <a:ext uri="{C572A759-6A51-4108-AA02-DFA0A04FC94B}">
-              <ma14:wrappingTextBoxFlag xmlns:ma14="http://schemas.microsoft.com/office/mac/drawingml/2011/main" val="1"/>
-            </a:ext>
-          </a:extLst>
         </p:spPr>
         <p:txBody>
           <a:bodyPr lIns="27432" tIns="27432" rIns="27432" bIns="27432"/>
@@ -5530,7 +5485,7 @@
               <a:spcBef>
                 <a:spcPts val="600"/>
               </a:spcBef>
-              <a:defRPr b="1" sz="1600">
+              <a:defRPr sz="1600" b="1">
                 <a:solidFill>
                   <a:srgbClr val="CAE270"/>
                 </a:solidFill>
@@ -5542,7 +5497,6 @@
             </a:lvl1pPr>
           </a:lstStyle>
           <a:p>
-            <a:pPr/>
             <a:r>
               <a:t>HOME</a:t>
             </a:r>
@@ -5566,11 +5520,6 @@
           <a:ln w="12700">
             <a:miter lim="400000"/>
           </a:ln>
-          <a:extLst>
-            <a:ext uri="{C572A759-6A51-4108-AA02-DFA0A04FC94B}">
-              <ma14:wrappingTextBoxFlag xmlns:ma14="http://schemas.microsoft.com/office/mac/drawingml/2011/main" val="1"/>
-            </a:ext>
-          </a:extLst>
         </p:spPr>
         <p:txBody>
           <a:bodyPr lIns="27432" tIns="27432" rIns="27432" bIns="27432"/>
@@ -5591,7 +5540,6 @@
             </a:lvl1pPr>
           </a:lstStyle>
           <a:p>
-            <a:pPr/>
             <a:r>
               <a:t>Overview &amp; highlights</a:t>
             </a:r>
@@ -5623,7 +5571,7 @@
             </a:solidFill>
           </a:ln>
           <a:effectLst>
-            <a:outerShdw sx="100000" sy="100000" kx="0" ky="0" algn="b" rotWithShape="0" blurRad="38100" dist="23000" dir="5400000">
+            <a:outerShdw blurRad="38100" dist="23000" dir="5400000" rotWithShape="0">
               <a:srgbClr val="000000">
                 <a:alpha val="35000"/>
               </a:srgbClr>
@@ -5667,7 +5615,7 @@
             </a:solidFill>
           </a:ln>
           <a:effectLst>
-            <a:outerShdw sx="100000" sy="100000" kx="0" ky="0" algn="b" rotWithShape="0" blurRad="38100" dist="23000" dir="5400000">
+            <a:outerShdw blurRad="38100" dist="23000" dir="5400000" rotWithShape="0">
               <a:srgbClr val="000000">
                 <a:alpha val="35000"/>
               </a:srgbClr>
@@ -5705,11 +5653,6 @@
           <a:ln w="12700">
             <a:miter lim="400000"/>
           </a:ln>
-          <a:extLst>
-            <a:ext uri="{C572A759-6A51-4108-AA02-DFA0A04FC94B}">
-              <ma14:wrappingTextBoxFlag xmlns:ma14="http://schemas.microsoft.com/office/mac/drawingml/2011/main" val="1"/>
-            </a:ext>
-          </a:extLst>
         </p:spPr>
         <p:txBody>
           <a:bodyPr lIns="27432" tIns="27432" rIns="27432" bIns="27432"/>
@@ -5718,7 +5661,7 @@
               <a:spcBef>
                 <a:spcPts val="600"/>
               </a:spcBef>
-              <a:defRPr b="1" sz="1600">
+              <a:defRPr sz="1600" b="1">
                 <a:solidFill>
                   <a:srgbClr val="EB9D69"/>
                 </a:solidFill>
@@ -5730,7 +5673,6 @@
             </a:lvl1pPr>
           </a:lstStyle>
           <a:p>
-            <a:pPr/>
             <a:r>
               <a:t>PROGRAMME</a:t>
             </a:r>
@@ -5754,11 +5696,6 @@
           <a:ln w="12700">
             <a:miter lim="400000"/>
           </a:ln>
-          <a:extLst>
-            <a:ext uri="{C572A759-6A51-4108-AA02-DFA0A04FC94B}">
-              <ma14:wrappingTextBoxFlag xmlns:ma14="http://schemas.microsoft.com/office/mac/drawingml/2011/main" val="1"/>
-            </a:ext>
-          </a:extLst>
         </p:spPr>
         <p:txBody>
           <a:bodyPr lIns="27432" tIns="27432" rIns="27432" bIns="27432"/>
@@ -5779,7 +5716,6 @@
             </a:lvl1pPr>
           </a:lstStyle>
           <a:p>
-            <a:pPr/>
             <a:r>
               <a:t>Browse by day / stage</a:t>
             </a:r>
@@ -5811,7 +5747,7 @@
             </a:solidFill>
           </a:ln>
           <a:effectLst>
-            <a:outerShdw sx="100000" sy="100000" kx="0" ky="0" algn="b" rotWithShape="0" blurRad="38100" dist="23000" dir="5400000">
+            <a:outerShdw blurRad="38100" dist="23000" dir="5400000" rotWithShape="0">
               <a:srgbClr val="000000">
                 <a:alpha val="35000"/>
               </a:srgbClr>
@@ -5855,7 +5791,7 @@
             </a:solidFill>
           </a:ln>
           <a:effectLst>
-            <a:outerShdw sx="100000" sy="100000" kx="0" ky="0" algn="b" rotWithShape="0" blurRad="38100" dist="23000" dir="5400000">
+            <a:outerShdw blurRad="38100" dist="23000" dir="5400000" rotWithShape="0">
               <a:srgbClr val="000000">
                 <a:alpha val="35000"/>
               </a:srgbClr>
@@ -5893,11 +5829,6 @@
           <a:ln w="12700">
             <a:miter lim="400000"/>
           </a:ln>
-          <a:extLst>
-            <a:ext uri="{C572A759-6A51-4108-AA02-DFA0A04FC94B}">
-              <ma14:wrappingTextBoxFlag xmlns:ma14="http://schemas.microsoft.com/office/mac/drawingml/2011/main" val="1"/>
-            </a:ext>
-          </a:extLst>
         </p:spPr>
         <p:txBody>
           <a:bodyPr lIns="27432" tIns="27432" rIns="27432" bIns="27432"/>
@@ -5906,7 +5837,7 @@
               <a:spcBef>
                 <a:spcPts val="600"/>
               </a:spcBef>
-              <a:defRPr b="1" sz="1600">
+              <a:defRPr sz="1600" b="1">
                 <a:solidFill>
                   <a:srgbClr val="E0A072"/>
                 </a:solidFill>
@@ -5918,7 +5849,6 @@
             </a:lvl1pPr>
           </a:lstStyle>
           <a:p>
-            <a:pPr/>
             <a:r>
               <a:t>PERFORMERS</a:t>
             </a:r>
@@ -5942,11 +5872,6 @@
           <a:ln w="12700">
             <a:miter lim="400000"/>
           </a:ln>
-          <a:extLst>
-            <a:ext uri="{C572A759-6A51-4108-AA02-DFA0A04FC94B}">
-              <ma14:wrappingTextBoxFlag xmlns:ma14="http://schemas.microsoft.com/office/mac/drawingml/2011/main" val="1"/>
-            </a:ext>
-          </a:extLst>
         </p:spPr>
         <p:txBody>
           <a:bodyPr lIns="27432" tIns="27432" rIns="27432" bIns="27432"/>
@@ -5967,7 +5892,6 @@
             </a:lvl1pPr>
           </a:lstStyle>
           <a:p>
-            <a:pPr/>
             <a:r>
               <a:t>Artist profiles</a:t>
             </a:r>
@@ -5999,7 +5923,7 @@
             </a:solidFill>
           </a:ln>
           <a:effectLst>
-            <a:outerShdw sx="100000" sy="100000" kx="0" ky="0" algn="b" rotWithShape="0" blurRad="38100" dist="23000" dir="5400000">
+            <a:outerShdw blurRad="38100" dist="23000" dir="5400000" rotWithShape="0">
               <a:srgbClr val="000000">
                 <a:alpha val="35000"/>
               </a:srgbClr>
@@ -6043,7 +5967,7 @@
             </a:solidFill>
           </a:ln>
           <a:effectLst>
-            <a:outerShdw sx="100000" sy="100000" kx="0" ky="0" algn="b" rotWithShape="0" blurRad="38100" dist="23000" dir="5400000">
+            <a:outerShdw blurRad="38100" dist="23000" dir="5400000" rotWithShape="0">
               <a:srgbClr val="000000">
                 <a:alpha val="35000"/>
               </a:srgbClr>
@@ -6081,11 +6005,6 @@
           <a:ln w="12700">
             <a:miter lim="400000"/>
           </a:ln>
-          <a:extLst>
-            <a:ext uri="{C572A759-6A51-4108-AA02-DFA0A04FC94B}">
-              <ma14:wrappingTextBoxFlag xmlns:ma14="http://schemas.microsoft.com/office/mac/drawingml/2011/main" val="1"/>
-            </a:ext>
-          </a:extLst>
         </p:spPr>
         <p:txBody>
           <a:bodyPr lIns="27432" tIns="27432" rIns="27432" bIns="27432"/>
@@ -6094,7 +6013,7 @@
               <a:spcBef>
                 <a:spcPts val="600"/>
               </a:spcBef>
-              <a:defRPr b="1" sz="1500">
+              <a:defRPr sz="1500" b="1">
                 <a:solidFill>
                   <a:srgbClr val="EB9D69"/>
                 </a:solidFill>
@@ -6106,7 +6025,6 @@
             </a:lvl1pPr>
           </a:lstStyle>
           <a:p>
-            <a:pPr/>
             <a:r>
               <a:t>STAGES &amp; VENUES</a:t>
             </a:r>
@@ -6130,11 +6048,6 @@
           <a:ln w="12700">
             <a:miter lim="400000"/>
           </a:ln>
-          <a:extLst>
-            <a:ext uri="{C572A759-6A51-4108-AA02-DFA0A04FC94B}">
-              <ma14:wrappingTextBoxFlag xmlns:ma14="http://schemas.microsoft.com/office/mac/drawingml/2011/main" val="1"/>
-            </a:ext>
-          </a:extLst>
         </p:spPr>
         <p:txBody>
           <a:bodyPr lIns="27432" tIns="27432" rIns="27432" bIns="27432"/>
@@ -6155,7 +6068,6 @@
             </a:lvl1pPr>
           </a:lstStyle>
           <a:p>
-            <a:pPr/>
             <a:r>
               <a:t>Location details</a:t>
             </a:r>
@@ -6187,7 +6099,7 @@
             </a:solidFill>
           </a:ln>
           <a:effectLst>
-            <a:outerShdw sx="100000" sy="100000" kx="0" ky="0" algn="b" rotWithShape="0" blurRad="38100" dist="23000" dir="5400000">
+            <a:outerShdw blurRad="38100" dist="23000" dir="5400000" rotWithShape="0">
               <a:srgbClr val="000000">
                 <a:alpha val="35000"/>
               </a:srgbClr>
@@ -6231,7 +6143,7 @@
             </a:solidFill>
           </a:ln>
           <a:effectLst>
-            <a:outerShdw sx="100000" sy="100000" kx="0" ky="0" algn="b" rotWithShape="0" blurRad="38100" dist="23000" dir="5400000">
+            <a:outerShdw blurRad="38100" dist="23000" dir="5400000" rotWithShape="0">
               <a:srgbClr val="000000">
                 <a:alpha val="35000"/>
               </a:srgbClr>
@@ -6269,11 +6181,6 @@
           <a:ln w="12700">
             <a:miter lim="400000"/>
           </a:ln>
-          <a:extLst>
-            <a:ext uri="{C572A759-6A51-4108-AA02-DFA0A04FC94B}">
-              <ma14:wrappingTextBoxFlag xmlns:ma14="http://schemas.microsoft.com/office/mac/drawingml/2011/main" val="1"/>
-            </a:ext>
-          </a:extLst>
         </p:spPr>
         <p:txBody>
           <a:bodyPr lIns="27432" tIns="27432" rIns="27432" bIns="27432"/>
@@ -6282,7 +6189,7 @@
               <a:spcBef>
                 <a:spcPts val="600"/>
               </a:spcBef>
-              <a:defRPr b="1" sz="1500">
+              <a:defRPr sz="1500" b="1">
                 <a:solidFill>
                   <a:srgbClr val="CAE270"/>
                 </a:solidFill>
@@ -6294,7 +6201,6 @@
             </a:lvl1pPr>
           </a:lstStyle>
           <a:p>
-            <a:pPr/>
             <a:r>
               <a:t>PRACTICAL INFO</a:t>
             </a:r>
@@ -6318,11 +6224,6 @@
           <a:ln w="12700">
             <a:miter lim="400000"/>
           </a:ln>
-          <a:extLst>
-            <a:ext uri="{C572A759-6A51-4108-AA02-DFA0A04FC94B}">
-              <ma14:wrappingTextBoxFlag xmlns:ma14="http://schemas.microsoft.com/office/mac/drawingml/2011/main" val="1"/>
-            </a:ext>
-          </a:extLst>
         </p:spPr>
         <p:txBody>
           <a:bodyPr lIns="27432" tIns="27432" rIns="27432" bIns="27432"/>
@@ -6343,7 +6244,6 @@
             </a:lvl1pPr>
           </a:lstStyle>
           <a:p>
-            <a:pPr/>
             <a:r>
               <a:t>Access &amp; travel</a:t>
             </a:r>
@@ -6375,7 +6275,7 @@
             </a:solidFill>
           </a:ln>
           <a:effectLst>
-            <a:outerShdw sx="100000" sy="100000" kx="0" ky="0" algn="b" rotWithShape="0" blurRad="38100" dist="23000" dir="5400000">
+            <a:outerShdw blurRad="38100" dist="23000" dir="5400000" rotWithShape="0">
               <a:srgbClr val="000000">
                 <a:alpha val="35000"/>
               </a:srgbClr>
@@ -6419,7 +6319,7 @@
             </a:solidFill>
           </a:ln>
           <a:effectLst>
-            <a:outerShdw sx="100000" sy="100000" kx="0" ky="0" algn="b" rotWithShape="0" blurRad="38100" dist="23000" dir="5400000">
+            <a:outerShdw blurRad="38100" dist="23000" dir="5400000" rotWithShape="0">
               <a:srgbClr val="000000">
                 <a:alpha val="35000"/>
               </a:srgbClr>
@@ -6457,11 +6357,6 @@
           <a:ln w="12700">
             <a:miter lim="400000"/>
           </a:ln>
-          <a:extLst>
-            <a:ext uri="{C572A759-6A51-4108-AA02-DFA0A04FC94B}">
-              <ma14:wrappingTextBoxFlag xmlns:ma14="http://schemas.microsoft.com/office/mac/drawingml/2011/main" val="1"/>
-            </a:ext>
-          </a:extLst>
         </p:spPr>
         <p:txBody>
           <a:bodyPr lIns="27432" tIns="27432" rIns="27432" bIns="27432"/>
@@ -6470,7 +6365,7 @@
               <a:spcBef>
                 <a:spcPts val="600"/>
               </a:spcBef>
-              <a:defRPr b="1" sz="1600">
+              <a:defRPr sz="1600" b="1">
                 <a:solidFill>
                   <a:srgbClr val="CAE270"/>
                 </a:solidFill>
@@ -6482,7 +6377,6 @@
             </a:lvl1pPr>
           </a:lstStyle>
           <a:p>
-            <a:pPr/>
             <a:r>
               <a:t>ABOUT</a:t>
             </a:r>
@@ -6506,11 +6400,6 @@
           <a:ln w="12700">
             <a:miter lim="400000"/>
           </a:ln>
-          <a:extLst>
-            <a:ext uri="{C572A759-6A51-4108-AA02-DFA0A04FC94B}">
-              <ma14:wrappingTextBoxFlag xmlns:ma14="http://schemas.microsoft.com/office/mac/drawingml/2011/main" val="1"/>
-            </a:ext>
-          </a:extLst>
         </p:spPr>
         <p:txBody>
           <a:bodyPr lIns="27432" tIns="27432" rIns="27432" bIns="27432"/>
@@ -6572,11 +6461,6 @@
           <a:ln w="12700">
             <a:miter lim="400000"/>
           </a:ln>
-          <a:extLst>
-            <a:ext uri="{C572A759-6A51-4108-AA02-DFA0A04FC94B}">
-              <ma14:wrappingTextBoxFlag xmlns:ma14="http://schemas.microsoft.com/office/mac/drawingml/2011/main" val="1"/>
-            </a:ext>
-          </a:extLst>
         </p:spPr>
         <p:txBody>
           <a:bodyPr lIns="27432" tIns="27432" rIns="27432" bIns="27432">
@@ -6587,7 +6471,7 @@
               <a:spcBef>
                 <a:spcPts val="600"/>
               </a:spcBef>
-              <a:defRPr b="1" sz="1600">
+              <a:defRPr sz="1600" b="1">
                 <a:solidFill>
                   <a:srgbClr val="BFCCBE"/>
                 </a:solidFill>
@@ -6599,7 +6483,6 @@
             </a:lvl1pPr>
           </a:lstStyle>
           <a:p>
-            <a:pPr/>
             <a:r>
               <a:t>Use familiar labels and keep navigation consistent across pages.</a:t>
             </a:r>
@@ -6611,18 +6494,19 @@
   <p:clrMapOvr>
     <a:masterClrMapping/>
   </p:clrMapOvr>
-  <p:transition xmlns:p14="http://schemas.microsoft.com/office/powerpoint/2010/main" spd="med" advClick="1"/>
+  <p:transition spd="med"/>
 </p:sld>
 </file>
 
 <file path=ppt/slides/slide5.xml><?xml version="1.0" encoding="utf-8"?>
-<p:sld xmlns:a="http://schemas.openxmlformats.org/drawingml/2006/main" xmlns:r="http://schemas.openxmlformats.org/officeDocument/2006/relationships" xmlns:p="http://schemas.openxmlformats.org/presentationml/2006/main" xmlns:m="http://schemas.openxmlformats.org/officeDocument/2006/math" xmlns:a14="http://schemas.microsoft.com/office/drawing/2010/main" showMasterSp="1" showMasterPhAnim="1">
+<p:sld xmlns:a="http://schemas.openxmlformats.org/drawingml/2006/main" xmlns:r="http://schemas.openxmlformats.org/officeDocument/2006/relationships" xmlns:p="http://schemas.openxmlformats.org/presentationml/2006/main">
   <p:cSld>
     <p:bg>
       <p:bgPr>
         <a:solidFill>
           <a:srgbClr val="132620"/>
         </a:solidFill>
+        <a:effectLst/>
       </p:bgPr>
     </p:bg>
     <p:spTree>
@@ -6656,11 +6540,6 @@
           <a:ln w="12700">
             <a:miter lim="400000"/>
           </a:ln>
-          <a:extLst>
-            <a:ext uri="{C572A759-6A51-4108-AA02-DFA0A04FC94B}">
-              <ma14:wrappingTextBoxFlag xmlns:ma14="http://schemas.microsoft.com/office/mac/drawingml/2011/main" val="1"/>
-            </a:ext>
-          </a:extLst>
         </p:spPr>
         <p:txBody>
           <a:bodyPr lIns="27432" tIns="27432" rIns="27432" bIns="27432">
@@ -6671,7 +6550,7 @@
               <a:spcBef>
                 <a:spcPts val="600"/>
               </a:spcBef>
-              <a:defRPr b="1" sz="1100">
+              <a:defRPr sz="1100" b="1">
                 <a:solidFill>
                   <a:srgbClr val="CAE270"/>
                 </a:solidFill>
@@ -6683,7 +6562,6 @@
             </a:lvl1pPr>
           </a:lstStyle>
           <a:p>
-            <a:pPr/>
             <a:r>
               <a:t>05 / TWO KEY SCENARIOS</a:t>
             </a:r>
@@ -6707,11 +6585,6 @@
           <a:ln w="12700">
             <a:miter lim="400000"/>
           </a:ln>
-          <a:extLst>
-            <a:ext uri="{C572A759-6A51-4108-AA02-DFA0A04FC94B}">
-              <ma14:wrappingTextBoxFlag xmlns:ma14="http://schemas.microsoft.com/office/mac/drawingml/2011/main" val="1"/>
-            </a:ext>
-          </a:extLst>
         </p:spPr>
         <p:txBody>
           <a:bodyPr lIns="27432" tIns="27432" rIns="27432" bIns="27432">
@@ -6722,7 +6595,7 @@
               <a:spcBef>
                 <a:spcPts val="600"/>
               </a:spcBef>
-              <a:defRPr b="1" sz="2800">
+              <a:defRPr sz="2800" b="1">
                 <a:solidFill>
                   <a:srgbClr val="F7F2E0"/>
                 </a:solidFill>
@@ -6734,7 +6607,6 @@
             </a:lvl1pPr>
           </a:lstStyle>
           <a:p>
-            <a:pPr/>
             <a:r>
               <a:t>Can visitors complete their main tasks?</a:t>
             </a:r>
@@ -6758,11 +6630,6 @@
           <a:ln w="12700">
             <a:miter lim="400000"/>
           </a:ln>
-          <a:extLst>
-            <a:ext uri="{C572A759-6A51-4108-AA02-DFA0A04FC94B}">
-              <ma14:wrappingTextBoxFlag xmlns:ma14="http://schemas.microsoft.com/office/mac/drawingml/2011/main" val="1"/>
-            </a:ext>
-          </a:extLst>
         </p:spPr>
         <p:txBody>
           <a:bodyPr lIns="27432" tIns="27432" rIns="27432" bIns="27432">
@@ -6785,7 +6652,6 @@
             </a:lvl1pPr>
           </a:lstStyle>
           <a:p>
-            <a:pPr/>
             <a:r>
               <a:t>Scenarios turn the website structure into concrete usability goals.</a:t>
             </a:r>
@@ -6809,11 +6675,6 @@
           <a:ln w="12700">
             <a:miter lim="400000"/>
           </a:ln>
-          <a:extLst>
-            <a:ext uri="{C572A759-6A51-4108-AA02-DFA0A04FC94B}">
-              <ma14:wrappingTextBoxFlag xmlns:ma14="http://schemas.microsoft.com/office/mac/drawingml/2011/main" val="1"/>
-            </a:ext>
-          </a:extLst>
         </p:spPr>
         <p:txBody>
           <a:bodyPr lIns="27432" tIns="27432" rIns="27432" bIns="27432">
@@ -6824,7 +6685,7 @@
               <a:spcBef>
                 <a:spcPts val="600"/>
               </a:spcBef>
-              <a:defRPr b="1" sz="900">
+              <a:defRPr sz="900" b="1">
                 <a:solidFill>
                   <a:srgbClr val="BFCCBE"/>
                 </a:solidFill>
@@ -6836,7 +6697,6 @@
             </a:lvl1pPr>
           </a:lstStyle>
           <a:p>
-            <a:pPr/>
             <a:r>
               <a:t>WILD SIGNAL • SEMINAR 2</a:t>
             </a:r>
@@ -6860,11 +6720,6 @@
           <a:ln w="12700">
             <a:miter lim="400000"/>
           </a:ln>
-          <a:extLst>
-            <a:ext uri="{C572A759-6A51-4108-AA02-DFA0A04FC94B}">
-              <ma14:wrappingTextBoxFlag xmlns:ma14="http://schemas.microsoft.com/office/mac/drawingml/2011/main" val="1"/>
-            </a:ext>
-          </a:extLst>
         </p:spPr>
         <p:txBody>
           <a:bodyPr lIns="27432" tIns="27432" rIns="27432" bIns="27432">
@@ -6875,7 +6730,7 @@
               <a:spcBef>
                 <a:spcPts val="600"/>
               </a:spcBef>
-              <a:defRPr b="1" sz="900">
+              <a:defRPr sz="900" b="1">
                 <a:solidFill>
                   <a:srgbClr val="CAE270"/>
                 </a:solidFill>
@@ -6887,7 +6742,6 @@
             </a:lvl1pPr>
           </a:lstStyle>
           <a:p>
-            <a:pPr/>
             <a:r>
               <a:t>05</a:t>
             </a:r>
@@ -6919,7 +6773,7 @@
             </a:solidFill>
           </a:ln>
           <a:effectLst>
-            <a:outerShdw sx="100000" sy="100000" kx="0" ky="0" algn="b" rotWithShape="0" blurRad="38100" dist="23000" dir="5400000">
+            <a:outerShdw blurRad="38100" dist="23000" dir="5400000" rotWithShape="0">
               <a:srgbClr val="000000">
                 <a:alpha val="35000"/>
               </a:srgbClr>
@@ -6963,7 +6817,7 @@
             </a:solidFill>
           </a:ln>
           <a:effectLst>
-            <a:outerShdw sx="100000" sy="100000" kx="0" ky="0" algn="b" rotWithShape="0" blurRad="38100" dist="23000" dir="5400000">
+            <a:outerShdw blurRad="38100" dist="23000" dir="5400000" rotWithShape="0">
               <a:srgbClr val="000000">
                 <a:alpha val="35000"/>
               </a:srgbClr>
@@ -7001,11 +6855,6 @@
           <a:ln w="12700">
             <a:miter lim="400000"/>
           </a:ln>
-          <a:extLst>
-            <a:ext uri="{C572A759-6A51-4108-AA02-DFA0A04FC94B}">
-              <ma14:wrappingTextBoxFlag xmlns:ma14="http://schemas.microsoft.com/office/mac/drawingml/2011/main" val="1"/>
-            </a:ext>
-          </a:extLst>
         </p:spPr>
         <p:txBody>
           <a:bodyPr lIns="27432" tIns="27432" rIns="27432" bIns="27432">
@@ -7016,7 +6865,7 @@
               <a:spcBef>
                 <a:spcPts val="600"/>
               </a:spcBef>
-              <a:defRPr b="1" sz="1600">
+              <a:defRPr sz="1600" b="1">
                 <a:solidFill>
                   <a:srgbClr val="CAE270"/>
                 </a:solidFill>
@@ -7028,7 +6877,6 @@
             </a:lvl1pPr>
           </a:lstStyle>
           <a:p>
-            <a:pPr/>
             <a:r>
               <a:t>SCENARIO 1 — FIND AN EVENT</a:t>
             </a:r>
@@ -7052,11 +6900,6 @@
           <a:ln w="12700">
             <a:miter lim="400000"/>
           </a:ln>
-          <a:extLst>
-            <a:ext uri="{C572A759-6A51-4108-AA02-DFA0A04FC94B}">
-              <ma14:wrappingTextBoxFlag xmlns:ma14="http://schemas.microsoft.com/office/mac/drawingml/2011/main" val="1"/>
-            </a:ext>
-          </a:extLst>
         </p:spPr>
         <p:txBody>
           <a:bodyPr lIns="27432" tIns="27432" rIns="27432" bIns="27432">
@@ -7166,7 +7009,7 @@
             </a:solidFill>
           </a:ln>
           <a:effectLst>
-            <a:outerShdw sx="100000" sy="100000" kx="0" ky="0" algn="b" rotWithShape="0" blurRad="38100" dist="23000" dir="5400000">
+            <a:outerShdw blurRad="38100" dist="23000" dir="5400000" rotWithShape="0">
               <a:srgbClr val="000000">
                 <a:alpha val="35000"/>
               </a:srgbClr>
@@ -7210,7 +7053,7 @@
             </a:solidFill>
           </a:ln>
           <a:effectLst>
-            <a:outerShdw sx="100000" sy="100000" kx="0" ky="0" algn="b" rotWithShape="0" blurRad="38100" dist="23000" dir="5400000">
+            <a:outerShdw blurRad="38100" dist="23000" dir="5400000" rotWithShape="0">
               <a:srgbClr val="000000">
                 <a:alpha val="35000"/>
               </a:srgbClr>
@@ -7248,11 +7091,6 @@
           <a:ln w="12700">
             <a:miter lim="400000"/>
           </a:ln>
-          <a:extLst>
-            <a:ext uri="{C572A759-6A51-4108-AA02-DFA0A04FC94B}">
-              <ma14:wrappingTextBoxFlag xmlns:ma14="http://schemas.microsoft.com/office/mac/drawingml/2011/main" val="1"/>
-            </a:ext>
-          </a:extLst>
         </p:spPr>
         <p:txBody>
           <a:bodyPr lIns="27432" tIns="27432" rIns="27432" bIns="27432">
@@ -7263,7 +7101,7 @@
               <a:spcBef>
                 <a:spcPts val="600"/>
               </a:spcBef>
-              <a:defRPr b="1" sz="1600">
+              <a:defRPr sz="1600" b="1">
                 <a:solidFill>
                   <a:srgbClr val="EB9D69"/>
                 </a:solidFill>
@@ -7275,7 +7113,6 @@
             </a:lvl1pPr>
           </a:lstStyle>
           <a:p>
-            <a:pPr/>
             <a:r>
               <a:t>SCENARIO 2 — CHECK ACCESS INFOS</a:t>
             </a:r>
@@ -7299,11 +7136,6 @@
           <a:ln w="12700">
             <a:miter lim="400000"/>
           </a:ln>
-          <a:extLst>
-            <a:ext uri="{C572A759-6A51-4108-AA02-DFA0A04FC94B}">
-              <ma14:wrappingTextBoxFlag xmlns:ma14="http://schemas.microsoft.com/office/mac/drawingml/2011/main" val="1"/>
-            </a:ext>
-          </a:extLst>
         </p:spPr>
         <p:txBody>
           <a:bodyPr lIns="27432" tIns="27432" rIns="27432" bIns="27432">
@@ -7405,11 +7237,6 @@
           <a:ln w="12700">
             <a:miter lim="400000"/>
           </a:ln>
-          <a:extLst>
-            <a:ext uri="{C572A759-6A51-4108-AA02-DFA0A04FC94B}">
-              <ma14:wrappingTextBoxFlag xmlns:ma14="http://schemas.microsoft.com/office/mac/drawingml/2011/main" val="1"/>
-            </a:ext>
-          </a:extLst>
         </p:spPr>
         <p:txBody>
           <a:bodyPr lIns="27432" tIns="27432" rIns="27432" bIns="27432">
@@ -7420,7 +7247,7 @@
               <a:spcBef>
                 <a:spcPts val="600"/>
               </a:spcBef>
-              <a:defRPr b="1" sz="1500">
+              <a:defRPr sz="1500" b="1">
                 <a:solidFill>
                   <a:srgbClr val="BFCCBE"/>
                 </a:solidFill>
@@ -7432,7 +7259,6 @@
             </a:lvl1pPr>
           </a:lstStyle>
           <a:p>
-            <a:pPr/>
             <a:r>
               <a:t>Test whether visitors can complete both tasks without help.</a:t>
             </a:r>
@@ -7444,18 +7270,19 @@
   <p:clrMapOvr>
     <a:masterClrMapping/>
   </p:clrMapOvr>
-  <p:transition xmlns:p14="http://schemas.microsoft.com/office/powerpoint/2010/main" spd="med" advClick="1"/>
+  <p:transition spd="med"/>
 </p:sld>
 </file>
 
 <file path=ppt/slides/slide6.xml><?xml version="1.0" encoding="utf-8"?>
-<p:sld xmlns:a="http://schemas.openxmlformats.org/drawingml/2006/main" xmlns:r="http://schemas.openxmlformats.org/officeDocument/2006/relationships" xmlns:p="http://schemas.openxmlformats.org/presentationml/2006/main" xmlns:m="http://schemas.openxmlformats.org/officeDocument/2006/math" xmlns:a14="http://schemas.microsoft.com/office/drawing/2010/main" showMasterSp="1" showMasterPhAnim="1">
+<p:sld xmlns:a="http://schemas.openxmlformats.org/drawingml/2006/main" xmlns:r="http://schemas.openxmlformats.org/officeDocument/2006/relationships" xmlns:p="http://schemas.openxmlformats.org/presentationml/2006/main">
   <p:cSld>
     <p:bg>
       <p:bgPr>
         <a:solidFill>
           <a:srgbClr val="132620"/>
         </a:solidFill>
+        <a:effectLst/>
       </p:bgPr>
     </p:bg>
     <p:spTree>
@@ -7489,11 +7316,6 @@
           <a:ln w="12700">
             <a:miter lim="400000"/>
           </a:ln>
-          <a:extLst>
-            <a:ext uri="{C572A759-6A51-4108-AA02-DFA0A04FC94B}">
-              <ma14:wrappingTextBoxFlag xmlns:ma14="http://schemas.microsoft.com/office/mac/drawingml/2011/main" val="1"/>
-            </a:ext>
-          </a:extLst>
         </p:spPr>
         <p:txBody>
           <a:bodyPr lIns="27432" tIns="27432" rIns="27432" bIns="27432">
@@ -7504,7 +7326,7 @@
               <a:spcBef>
                 <a:spcPts val="600"/>
               </a:spcBef>
-              <a:defRPr b="1" sz="1100">
+              <a:defRPr sz="1100" b="1">
                 <a:solidFill>
                   <a:srgbClr val="CAE270"/>
                 </a:solidFill>
@@ -7516,7 +7338,6 @@
             </a:lvl1pPr>
           </a:lstStyle>
           <a:p>
-            <a:pPr/>
             <a:r>
               <a:t>06 / AI USE &amp; VERIFICATION</a:t>
             </a:r>
@@ -7540,11 +7361,6 @@
           <a:ln w="12700">
             <a:miter lim="400000"/>
           </a:ln>
-          <a:extLst>
-            <a:ext uri="{C572A759-6A51-4108-AA02-DFA0A04FC94B}">
-              <ma14:wrappingTextBoxFlag xmlns:ma14="http://schemas.microsoft.com/office/mac/drawingml/2011/main" val="1"/>
-            </a:ext>
-          </a:extLst>
         </p:spPr>
         <p:txBody>
           <a:bodyPr lIns="27432" tIns="27432" rIns="27432" bIns="27432">
@@ -7555,7 +7371,7 @@
               <a:spcBef>
                 <a:spcPts val="600"/>
               </a:spcBef>
-              <a:defRPr b="1" sz="2800">
+              <a:defRPr sz="2800" b="1">
                 <a:solidFill>
                   <a:srgbClr val="F7F2E0"/>
                 </a:solidFill>
@@ -7567,7 +7383,6 @@
             </a:lvl1pPr>
           </a:lstStyle>
           <a:p>
-            <a:pPr/>
             <a:r>
               <a:t>AI can speed up drafting, but it cannot verify itself</a:t>
             </a:r>
@@ -7591,11 +7406,6 @@
           <a:ln w="12700">
             <a:miter lim="400000"/>
           </a:ln>
-          <a:extLst>
-            <a:ext uri="{C572A759-6A51-4108-AA02-DFA0A04FC94B}">
-              <ma14:wrappingTextBoxFlag xmlns:ma14="http://schemas.microsoft.com/office/mac/drawingml/2011/main" val="1"/>
-            </a:ext>
-          </a:extLst>
         </p:spPr>
         <p:txBody>
           <a:bodyPr lIns="27432" tIns="27432" rIns="27432" bIns="27432">
@@ -7618,7 +7428,6 @@
             </a:lvl1pPr>
           </a:lstStyle>
           <a:p>
-            <a:pPr/>
             <a:r>
               <a:t>We treat AI output as a draft and check it before using it.</a:t>
             </a:r>
@@ -7642,11 +7451,6 @@
           <a:ln w="12700">
             <a:miter lim="400000"/>
           </a:ln>
-          <a:extLst>
-            <a:ext uri="{C572A759-6A51-4108-AA02-DFA0A04FC94B}">
-              <ma14:wrappingTextBoxFlag xmlns:ma14="http://schemas.microsoft.com/office/mac/drawingml/2011/main" val="1"/>
-            </a:ext>
-          </a:extLst>
         </p:spPr>
         <p:txBody>
           <a:bodyPr lIns="27432" tIns="27432" rIns="27432" bIns="27432">
@@ -7657,7 +7461,7 @@
               <a:spcBef>
                 <a:spcPts val="600"/>
               </a:spcBef>
-              <a:defRPr b="1" sz="900">
+              <a:defRPr sz="900" b="1">
                 <a:solidFill>
                   <a:srgbClr val="BFCCBE"/>
                 </a:solidFill>
@@ -7669,7 +7473,6 @@
             </a:lvl1pPr>
           </a:lstStyle>
           <a:p>
-            <a:pPr/>
             <a:r>
               <a:t>WILD SIGNAL • SEMINAR 2</a:t>
             </a:r>
@@ -7693,11 +7496,6 @@
           <a:ln w="12700">
             <a:miter lim="400000"/>
           </a:ln>
-          <a:extLst>
-            <a:ext uri="{C572A759-6A51-4108-AA02-DFA0A04FC94B}">
-              <ma14:wrappingTextBoxFlag xmlns:ma14="http://schemas.microsoft.com/office/mac/drawingml/2011/main" val="1"/>
-            </a:ext>
-          </a:extLst>
         </p:spPr>
         <p:txBody>
           <a:bodyPr lIns="27432" tIns="27432" rIns="27432" bIns="27432">
@@ -7708,7 +7506,7 @@
               <a:spcBef>
                 <a:spcPts val="600"/>
               </a:spcBef>
-              <a:defRPr b="1" sz="900">
+              <a:defRPr sz="900" b="1">
                 <a:solidFill>
                   <a:srgbClr val="CAE270"/>
                 </a:solidFill>
@@ -7720,7 +7518,6 @@
             </a:lvl1pPr>
           </a:lstStyle>
           <a:p>
-            <a:pPr/>
             <a:r>
               <a:t>06</a:t>
             </a:r>
@@ -7752,7 +7549,7 @@
             </a:solidFill>
           </a:ln>
           <a:effectLst>
-            <a:outerShdw sx="100000" sy="100000" kx="0" ky="0" algn="b" rotWithShape="0" blurRad="38100" dist="23000" dir="5400000">
+            <a:outerShdw blurRad="38100" dist="23000" dir="5400000" rotWithShape="0">
               <a:srgbClr val="000000">
                 <a:alpha val="35000"/>
               </a:srgbClr>
@@ -7796,7 +7593,7 @@
             </a:solidFill>
           </a:ln>
           <a:effectLst>
-            <a:outerShdw sx="100000" sy="100000" kx="0" ky="0" algn="b" rotWithShape="0" blurRad="38100" dist="23000" dir="5400000">
+            <a:outerShdw blurRad="38100" dist="23000" dir="5400000" rotWithShape="0">
               <a:srgbClr val="000000">
                 <a:alpha val="35000"/>
               </a:srgbClr>
@@ -7834,11 +7631,6 @@
           <a:ln w="12700">
             <a:miter lim="400000"/>
           </a:ln>
-          <a:extLst>
-            <a:ext uri="{C572A759-6A51-4108-AA02-DFA0A04FC94B}">
-              <ma14:wrappingTextBoxFlag xmlns:ma14="http://schemas.microsoft.com/office/mac/drawingml/2011/main" val="1"/>
-            </a:ext>
-          </a:extLst>
         </p:spPr>
         <p:txBody>
           <a:bodyPr lIns="27432" tIns="27432" rIns="27432" bIns="27432">
@@ -7849,7 +7641,7 @@
               <a:spcBef>
                 <a:spcPts val="600"/>
               </a:spcBef>
-              <a:defRPr b="1" sz="1600">
+              <a:defRPr sz="1600" b="1">
                 <a:solidFill>
                   <a:srgbClr val="CAE270"/>
                 </a:solidFill>
@@ -7861,7 +7653,6 @@
             </a:lvl1pPr>
           </a:lstStyle>
           <a:p>
-            <a:pPr/>
             <a:r>
               <a:t>AI HELPED WITH</a:t>
             </a:r>
@@ -7893,7 +7684,7 @@
             </a:solidFill>
           </a:ln>
           <a:effectLst>
-            <a:outerShdw sx="100000" sy="100000" kx="0" ky="0" algn="b" rotWithShape="0" blurRad="38100" dist="23000" dir="5400000">
+            <a:outerShdw blurRad="38100" dist="23000" dir="5400000" rotWithShape="0">
               <a:srgbClr val="000000">
                 <a:alpha val="35000"/>
               </a:srgbClr>
@@ -7937,7 +7728,7 @@
             </a:solidFill>
           </a:ln>
           <a:effectLst>
-            <a:outerShdw sx="100000" sy="100000" kx="0" ky="0" algn="b" rotWithShape="0" blurRad="38100" dist="23000" dir="5400000">
+            <a:outerShdw blurRad="38100" dist="23000" dir="5400000" rotWithShape="0">
               <a:srgbClr val="000000">
                 <a:alpha val="35000"/>
               </a:srgbClr>
@@ -7975,11 +7766,6 @@
           <a:ln w="12700">
             <a:miter lim="400000"/>
           </a:ln>
-          <a:extLst>
-            <a:ext uri="{C572A759-6A51-4108-AA02-DFA0A04FC94B}">
-              <ma14:wrappingTextBoxFlag xmlns:ma14="http://schemas.microsoft.com/office/mac/drawingml/2011/main" val="1"/>
-            </a:ext>
-          </a:extLst>
         </p:spPr>
         <p:txBody>
           <a:bodyPr lIns="27432" tIns="27432" rIns="27432" bIns="27432">
@@ -7990,7 +7776,7 @@
               <a:spcBef>
                 <a:spcPts val="600"/>
               </a:spcBef>
-              <a:defRPr b="1" sz="1600">
+              <a:defRPr sz="1600" b="1">
                 <a:solidFill>
                   <a:srgbClr val="CAE270"/>
                 </a:solidFill>
@@ -8002,7 +7788,6 @@
             </a:lvl1pPr>
           </a:lstStyle>
           <a:p>
-            <a:pPr/>
             <a:r>
               <a:t>HUMAN REVIEW NEEDED</a:t>
             </a:r>
@@ -8026,11 +7811,6 @@
           <a:ln w="12700">
             <a:miter lim="400000"/>
           </a:ln>
-          <a:extLst>
-            <a:ext uri="{C572A759-6A51-4108-AA02-DFA0A04FC94B}">
-              <ma14:wrappingTextBoxFlag xmlns:ma14="http://schemas.microsoft.com/office/mac/drawingml/2011/main" val="1"/>
-            </a:ext>
-          </a:extLst>
         </p:spPr>
         <p:txBody>
           <a:bodyPr lIns="27432" tIns="27432" rIns="27432" bIns="27432">
@@ -8188,11 +7968,6 @@
           <a:ln w="12700">
             <a:miter lim="400000"/>
           </a:ln>
-          <a:extLst>
-            <a:ext uri="{C572A759-6A51-4108-AA02-DFA0A04FC94B}">
-              <ma14:wrappingTextBoxFlag xmlns:ma14="http://schemas.microsoft.com/office/mac/drawingml/2011/main" val="1"/>
-            </a:ext>
-          </a:extLst>
         </p:spPr>
         <p:txBody>
           <a:bodyPr lIns="27432" tIns="27432" rIns="27432" bIns="27432">
@@ -8203,7 +7978,7 @@
               <a:spcBef>
                 <a:spcPts val="600"/>
               </a:spcBef>
-              <a:defRPr b="1" sz="1500">
+              <a:defRPr sz="1500" b="1">
                 <a:solidFill>
                   <a:srgbClr val="BFCCBE"/>
                 </a:solidFill>
@@ -8215,7 +7990,6 @@
             </a:lvl1pPr>
           </a:lstStyle>
           <a:p>
-            <a:pPr/>
             <a:r>
               <a:t>Limitation: data checks do not prove content quality or usability. Group review and scenario testing are still needed.</a:t>
             </a:r>
@@ -8239,11 +8013,6 @@
           <a:ln w="12700">
             <a:miter lim="400000"/>
           </a:ln>
-          <a:extLst>
-            <a:ext uri="{C572A759-6A51-4108-AA02-DFA0A04FC94B}">
-              <ma14:wrappingTextBoxFlag xmlns:ma14="http://schemas.microsoft.com/office/mac/drawingml/2011/main" val="1"/>
-            </a:ext>
-          </a:extLst>
         </p:spPr>
         <p:txBody>
           <a:bodyPr lIns="27432" tIns="27432" rIns="27432" bIns="27432">
@@ -8301,12 +8070,12 @@
   <p:clrMapOvr>
     <a:masterClrMapping/>
   </p:clrMapOvr>
-  <p:transition xmlns:p14="http://schemas.microsoft.com/office/powerpoint/2010/main" spd="med" advClick="1"/>
+  <p:transition spd="med"/>
 </p:sld>
 </file>
 
 <file path=ppt/theme/theme1.xml><?xml version="1.0" encoding="utf-8"?>
-<a:theme xmlns:a="http://schemas.openxmlformats.org/drawingml/2006/main" xmlns:r="http://schemas.openxmlformats.org/officeDocument/2006/relationships" name="Office Theme">
+<a:theme xmlns:a="http://schemas.openxmlformats.org/drawingml/2006/main" name="Office Theme">
   <a:themeElements>
     <a:clrScheme name="Office Theme">
       <a:dk1>
@@ -8432,7 +8201,7 @@
       <a:effectStyleLst>
         <a:effectStyle>
           <a:effectLst>
-            <a:outerShdw sx="100000" sy="100000" kx="0" ky="0" algn="b" rotWithShape="0" blurRad="38100" dist="23000" dir="5400000">
+            <a:outerShdw blurRad="38100" dist="23000" dir="5400000" rotWithShape="0">
               <a:srgbClr val="000000">
                 <a:alpha val="35000"/>
               </a:srgbClr>
@@ -8441,7 +8210,7 @@
         </a:effectStyle>
         <a:effectStyle>
           <a:effectLst>
-            <a:outerShdw sx="100000" sy="100000" kx="0" ky="0" algn="b" rotWithShape="0" blurRad="38100" dist="23000" dir="5400000">
+            <a:outerShdw blurRad="38100" dist="23000" dir="5400000" rotWithShape="0">
               <a:srgbClr val="000000">
                 <a:alpha val="35000"/>
               </a:srgbClr>
@@ -8450,7 +8219,7 @@
         </a:effectStyle>
         <a:effectStyle>
           <a:effectLst>
-            <a:outerShdw sx="100000" sy="100000" kx="0" ky="0" algn="b" rotWithShape="0" blurRad="38100" dist="20000" dir="5400000">
+            <a:outerShdw blurRad="38100" dist="20000" dir="5400000" rotWithShape="0">
               <a:srgbClr val="000000">
                 <a:alpha val="38000"/>
               </a:srgbClr>
@@ -8524,13 +8293,12 @@
           <a:round/>
         </a:ln>
         <a:effectLst>
-          <a:outerShdw sx="100000" sy="100000" kx="0" ky="0" algn="b" rotWithShape="0" blurRad="38100" dist="23000" dir="5400000">
+          <a:outerShdw blurRad="38100" dist="23000" dir="5400000" rotWithShape="0">
             <a:srgbClr val="000000">
               <a:alpha val="35000"/>
             </a:srgbClr>
           </a:outerShdw>
         </a:effectLst>
-        <a:sp3d/>
       </a:spPr>
       <a:bodyPr rot="0" spcFirstLastPara="1" vertOverflow="overflow" horzOverflow="overflow" vert="horz" wrap="square" lIns="45719" tIns="45719" rIns="45719" bIns="45719" numCol="1" spcCol="38100" rtlCol="0" anchor="ctr" upright="0">
         <a:spAutoFit/>
@@ -8550,8 +8318,7 @@
           <a:buSzTx/>
           <a:buFontTx/>
           <a:buNone/>
-          <a:tabLst/>
-          <a:defRPr b="0" baseline="0" cap="none" i="0" spc="0" strike="noStrike" sz="1800" u="none" kumimoji="0" normalizeH="0">
+          <a:defRPr kumimoji="0" sz="1800" b="0" i="0" u="none" strike="noStrike" cap="none" spc="0" normalizeH="0" baseline="0">
             <a:ln>
               <a:noFill/>
             </a:ln>
@@ -8580,8 +8347,7 @@
           <a:buSzTx/>
           <a:buFontTx/>
           <a:buNone/>
-          <a:tabLst/>
-          <a:defRPr b="0" baseline="0" cap="none" i="0" spc="0" strike="noStrike" sz="1800" u="none" kumimoji="0" normalizeH="0">
+          <a:defRPr kumimoji="0" sz="1800" b="0" i="0" u="none" strike="noStrike" cap="none" spc="0" normalizeH="0" baseline="0">
             <a:ln>
               <a:noFill/>
             </a:ln>
@@ -8606,8 +8372,7 @@
           <a:buSzTx/>
           <a:buFontTx/>
           <a:buNone/>
-          <a:tabLst/>
-          <a:defRPr b="0" baseline="0" cap="none" i="0" spc="0" strike="noStrike" sz="1800" u="none" kumimoji="0" normalizeH="0">
+          <a:defRPr kumimoji="0" sz="1800" b="0" i="0" u="none" strike="noStrike" cap="none" spc="0" normalizeH="0" baseline="0">
             <a:ln>
               <a:noFill/>
             </a:ln>
@@ -8632,8 +8397,7 @@
           <a:buSzTx/>
           <a:buFontTx/>
           <a:buNone/>
-          <a:tabLst/>
-          <a:defRPr b="0" baseline="0" cap="none" i="0" spc="0" strike="noStrike" sz="1800" u="none" kumimoji="0" normalizeH="0">
+          <a:defRPr kumimoji="0" sz="1800" b="0" i="0" u="none" strike="noStrike" cap="none" spc="0" normalizeH="0" baseline="0">
             <a:ln>
               <a:noFill/>
             </a:ln>
@@ -8658,8 +8422,7 @@
           <a:buSzTx/>
           <a:buFontTx/>
           <a:buNone/>
-          <a:tabLst/>
-          <a:defRPr b="0" baseline="0" cap="none" i="0" spc="0" strike="noStrike" sz="1800" u="none" kumimoji="0" normalizeH="0">
+          <a:defRPr kumimoji="0" sz="1800" b="0" i="0" u="none" strike="noStrike" cap="none" spc="0" normalizeH="0" baseline="0">
             <a:ln>
               <a:noFill/>
             </a:ln>
@@ -8684,8 +8447,7 @@
           <a:buSzTx/>
           <a:buFontTx/>
           <a:buNone/>
-          <a:tabLst/>
-          <a:defRPr b="0" baseline="0" cap="none" i="0" spc="0" strike="noStrike" sz="1800" u="none" kumimoji="0" normalizeH="0">
+          <a:defRPr kumimoji="0" sz="1800" b="0" i="0" u="none" strike="noStrike" cap="none" spc="0" normalizeH="0" baseline="0">
             <a:ln>
               <a:noFill/>
             </a:ln>
@@ -8710,8 +8472,7 @@
           <a:buSzTx/>
           <a:buFontTx/>
           <a:buNone/>
-          <a:tabLst/>
-          <a:defRPr b="0" baseline="0" cap="none" i="0" spc="0" strike="noStrike" sz="1800" u="none" kumimoji="0" normalizeH="0">
+          <a:defRPr kumimoji="0" sz="1800" b="0" i="0" u="none" strike="noStrike" cap="none" spc="0" normalizeH="0" baseline="0">
             <a:ln>
               <a:noFill/>
             </a:ln>
@@ -8736,8 +8497,7 @@
           <a:buSzTx/>
           <a:buFontTx/>
           <a:buNone/>
-          <a:tabLst/>
-          <a:defRPr b="0" baseline="0" cap="none" i="0" spc="0" strike="noStrike" sz="1800" u="none" kumimoji="0" normalizeH="0">
+          <a:defRPr kumimoji="0" sz="1800" b="0" i="0" u="none" strike="noStrike" cap="none" spc="0" normalizeH="0" baseline="0">
             <a:ln>
               <a:noFill/>
             </a:ln>
@@ -8762,8 +8522,7 @@
           <a:buSzTx/>
           <a:buFontTx/>
           <a:buNone/>
-          <a:tabLst/>
-          <a:defRPr b="0" baseline="0" cap="none" i="0" spc="0" strike="noStrike" sz="1800" u="none" kumimoji="0" normalizeH="0">
+          <a:defRPr kumimoji="0" sz="1800" b="0" i="0" u="none" strike="noStrike" cap="none" spc="0" normalizeH="0" baseline="0">
             <a:ln>
               <a:noFill/>
             </a:ln>
@@ -8788,8 +8547,7 @@
           <a:buSzTx/>
           <a:buFontTx/>
           <a:buNone/>
-          <a:tabLst/>
-          <a:defRPr b="0" baseline="0" cap="none" i="0" spc="0" strike="noStrike" sz="1800" u="none" kumimoji="0" normalizeH="0">
+          <a:defRPr kumimoji="0" sz="1800" b="0" i="0" u="none" strike="noStrike" cap="none" spc="0" normalizeH="0" baseline="0">
             <a:ln>
               <a:noFill/>
             </a:ln>
@@ -8802,9 +8560,15 @@
         </a:lvl9pPr>
       </a:lstStyle>
       <a:style>
-        <a:lnRef idx="0"/>
-        <a:fillRef idx="0"/>
-        <a:effectRef idx="0"/>
+        <a:lnRef idx="0">
+          <a:srgbClr val="FFFFFF"/>
+        </a:lnRef>
+        <a:fillRef idx="0">
+          <a:srgbClr val="FFFFFF"/>
+        </a:fillRef>
+        <a:effectRef idx="0">
+          <a:srgbClr val="FFFFFF"/>
+        </a:effectRef>
         <a:fontRef idx="none"/>
       </a:style>
     </a:spDef>
@@ -8819,13 +8583,12 @@
           <a:round/>
         </a:ln>
         <a:effectLst>
-          <a:outerShdw sx="100000" sy="100000" kx="0" ky="0" algn="b" rotWithShape="0" blurRad="38100" dist="20000" dir="5400000">
+          <a:outerShdw blurRad="38100" dist="20000" dir="5400000" rotWithShape="0">
             <a:srgbClr val="000000">
               <a:alpha val="38000"/>
             </a:srgbClr>
           </a:outerShdw>
         </a:effectLst>
-        <a:sp3d/>
       </a:spPr>
       <a:bodyPr rot="0" spcFirstLastPara="1" vertOverflow="overflow" horzOverflow="overflow" vert="horz" wrap="square" lIns="91439" tIns="45719" rIns="91439" bIns="45719" numCol="1" spcCol="38100" rtlCol="0" anchor="t" upright="0">
         <a:noAutofit/>
@@ -8845,8 +8608,7 @@
           <a:buSzTx/>
           <a:buFontTx/>
           <a:buNone/>
-          <a:tabLst/>
-          <a:defRPr b="0" baseline="0" cap="none" i="0" spc="0" strike="noStrike" sz="1800" u="none" kumimoji="0" normalizeH="0">
+          <a:defRPr kumimoji="0" sz="1800" b="0" i="0" u="none" strike="noStrike" cap="none" spc="0" normalizeH="0" baseline="0">
             <a:ln>
               <a:noFill/>
             </a:ln>
@@ -8871,8 +8633,7 @@
           <a:buSzTx/>
           <a:buFontTx/>
           <a:buNone/>
-          <a:tabLst/>
-          <a:defRPr b="0" baseline="0" cap="none" i="0" spc="0" strike="noStrike" sz="1800" u="none" kumimoji="0" normalizeH="0">
+          <a:defRPr kumimoji="0" sz="1800" b="0" i="0" u="none" strike="noStrike" cap="none" spc="0" normalizeH="0" baseline="0">
             <a:ln>
               <a:noFill/>
             </a:ln>
@@ -8897,8 +8658,7 @@
           <a:buSzTx/>
           <a:buFontTx/>
           <a:buNone/>
-          <a:tabLst/>
-          <a:defRPr b="0" baseline="0" cap="none" i="0" spc="0" strike="noStrike" sz="1800" u="none" kumimoji="0" normalizeH="0">
+          <a:defRPr kumimoji="0" sz="1800" b="0" i="0" u="none" strike="noStrike" cap="none" spc="0" normalizeH="0" baseline="0">
             <a:ln>
               <a:noFill/>
             </a:ln>
@@ -8923,8 +8683,7 @@
           <a:buSzTx/>
           <a:buFontTx/>
           <a:buNone/>
-          <a:tabLst/>
-          <a:defRPr b="0" baseline="0" cap="none" i="0" spc="0" strike="noStrike" sz="1800" u="none" kumimoji="0" normalizeH="0">
+          <a:defRPr kumimoji="0" sz="1800" b="0" i="0" u="none" strike="noStrike" cap="none" spc="0" normalizeH="0" baseline="0">
             <a:ln>
               <a:noFill/>
             </a:ln>
@@ -8949,8 +8708,7 @@
           <a:buSzTx/>
           <a:buFontTx/>
           <a:buNone/>
-          <a:tabLst/>
-          <a:defRPr b="0" baseline="0" cap="none" i="0" spc="0" strike="noStrike" sz="1800" u="none" kumimoji="0" normalizeH="0">
+          <a:defRPr kumimoji="0" sz="1800" b="0" i="0" u="none" strike="noStrike" cap="none" spc="0" normalizeH="0" baseline="0">
             <a:ln>
               <a:noFill/>
             </a:ln>
@@ -8975,8 +8733,7 @@
           <a:buSzTx/>
           <a:buFontTx/>
           <a:buNone/>
-          <a:tabLst/>
-          <a:defRPr b="0" baseline="0" cap="none" i="0" spc="0" strike="noStrike" sz="1800" u="none" kumimoji="0" normalizeH="0">
+          <a:defRPr kumimoji="0" sz="1800" b="0" i="0" u="none" strike="noStrike" cap="none" spc="0" normalizeH="0" baseline="0">
             <a:ln>
               <a:noFill/>
             </a:ln>
@@ -9001,8 +8758,7 @@
           <a:buSzTx/>
           <a:buFontTx/>
           <a:buNone/>
-          <a:tabLst/>
-          <a:defRPr b="0" baseline="0" cap="none" i="0" spc="0" strike="noStrike" sz="1800" u="none" kumimoji="0" normalizeH="0">
+          <a:defRPr kumimoji="0" sz="1800" b="0" i="0" u="none" strike="noStrike" cap="none" spc="0" normalizeH="0" baseline="0">
             <a:ln>
               <a:noFill/>
             </a:ln>
@@ -9027,8 +8783,7 @@
           <a:buSzTx/>
           <a:buFontTx/>
           <a:buNone/>
-          <a:tabLst/>
-          <a:defRPr b="0" baseline="0" cap="none" i="0" spc="0" strike="noStrike" sz="1800" u="none" kumimoji="0" normalizeH="0">
+          <a:defRPr kumimoji="0" sz="1800" b="0" i="0" u="none" strike="noStrike" cap="none" spc="0" normalizeH="0" baseline="0">
             <a:ln>
               <a:noFill/>
             </a:ln>
@@ -9053,8 +8808,7 @@
           <a:buSzTx/>
           <a:buFontTx/>
           <a:buNone/>
-          <a:tabLst/>
-          <a:defRPr b="0" baseline="0" cap="none" i="0" spc="0" strike="noStrike" sz="1800" u="none" kumimoji="0" normalizeH="0">
+          <a:defRPr kumimoji="0" sz="1800" b="0" i="0" u="none" strike="noStrike" cap="none" spc="0" normalizeH="0" baseline="0">
             <a:ln>
               <a:noFill/>
             </a:ln>
@@ -9079,8 +8833,7 @@
           <a:buSzTx/>
           <a:buFontTx/>
           <a:buNone/>
-          <a:tabLst/>
-          <a:defRPr b="0" baseline="0" cap="none" i="0" spc="0" strike="noStrike" sz="1800" u="none" kumimoji="0" normalizeH="0">
+          <a:defRPr kumimoji="0" sz="1800" b="0" i="0" u="none" strike="noStrike" cap="none" spc="0" normalizeH="0" baseline="0">
             <a:ln>
               <a:noFill/>
             </a:ln>
@@ -9093,9 +8846,15 @@
         </a:lvl9pPr>
       </a:lstStyle>
       <a:style>
-        <a:lnRef idx="0"/>
-        <a:fillRef idx="0"/>
-        <a:effectRef idx="0"/>
+        <a:lnRef idx="0">
+          <a:srgbClr val="FFFFFF"/>
+        </a:lnRef>
+        <a:fillRef idx="0">
+          <a:srgbClr val="FFFFFF"/>
+        </a:fillRef>
+        <a:effectRef idx="0">
+          <a:srgbClr val="FFFFFF"/>
+        </a:effectRef>
         <a:fontRef idx="none"/>
       </a:style>
     </a:lnDef>
@@ -9106,8 +8865,6 @@
           <a:noFill/>
           <a:miter lim="400000"/>
         </a:ln>
-        <a:effectLst/>
-        <a:sp3d/>
       </a:spPr>
       <a:bodyPr rot="0" spcFirstLastPara="1" vertOverflow="overflow" horzOverflow="overflow" vert="horz" wrap="square" lIns="45719" tIns="45719" rIns="45719" bIns="45719" numCol="1" spcCol="38100" rtlCol="0" anchor="t" upright="0">
         <a:spAutoFit/>
@@ -9127,8 +8884,7 @@
           <a:buSzTx/>
           <a:buFontTx/>
           <a:buNone/>
-          <a:tabLst/>
-          <a:defRPr b="0" baseline="0" cap="none" i="0" spc="0" strike="noStrike" sz="1800" u="none" kumimoji="0" normalizeH="0">
+          <a:defRPr kumimoji="0" sz="1800" b="0" i="0" u="none" strike="noStrike" cap="none" spc="0" normalizeH="0" baseline="0">
             <a:ln>
               <a:noFill/>
             </a:ln>
@@ -9157,8 +8913,7 @@
           <a:buSzTx/>
           <a:buFontTx/>
           <a:buNone/>
-          <a:tabLst/>
-          <a:defRPr b="0" baseline="0" cap="none" i="0" spc="0" strike="noStrike" sz="1800" u="none" kumimoji="0" normalizeH="0">
+          <a:defRPr kumimoji="0" sz="1800" b="0" i="0" u="none" strike="noStrike" cap="none" spc="0" normalizeH="0" baseline="0">
             <a:ln>
               <a:noFill/>
             </a:ln>
@@ -9183,8 +8938,7 @@
           <a:buSzTx/>
           <a:buFontTx/>
           <a:buNone/>
-          <a:tabLst/>
-          <a:defRPr b="0" baseline="0" cap="none" i="0" spc="0" strike="noStrike" sz="1800" u="none" kumimoji="0" normalizeH="0">
+          <a:defRPr kumimoji="0" sz="1800" b="0" i="0" u="none" strike="noStrike" cap="none" spc="0" normalizeH="0" baseline="0">
             <a:ln>
               <a:noFill/>
             </a:ln>
@@ -9209,8 +8963,7 @@
           <a:buSzTx/>
           <a:buFontTx/>
           <a:buNone/>
-          <a:tabLst/>
-          <a:defRPr b="0" baseline="0" cap="none" i="0" spc="0" strike="noStrike" sz="1800" u="none" kumimoji="0" normalizeH="0">
+          <a:defRPr kumimoji="0" sz="1800" b="0" i="0" u="none" strike="noStrike" cap="none" spc="0" normalizeH="0" baseline="0">
             <a:ln>
               <a:noFill/>
             </a:ln>
@@ -9235,8 +8988,7 @@
           <a:buSzTx/>
           <a:buFontTx/>
           <a:buNone/>
-          <a:tabLst/>
-          <a:defRPr b="0" baseline="0" cap="none" i="0" spc="0" strike="noStrike" sz="1800" u="none" kumimoji="0" normalizeH="0">
+          <a:defRPr kumimoji="0" sz="1800" b="0" i="0" u="none" strike="noStrike" cap="none" spc="0" normalizeH="0" baseline="0">
             <a:ln>
               <a:noFill/>
             </a:ln>
@@ -9261,8 +9013,7 @@
           <a:buSzTx/>
           <a:buFontTx/>
           <a:buNone/>
-          <a:tabLst/>
-          <a:defRPr b="0" baseline="0" cap="none" i="0" spc="0" strike="noStrike" sz="1800" u="none" kumimoji="0" normalizeH="0">
+          <a:defRPr kumimoji="0" sz="1800" b="0" i="0" u="none" strike="noStrike" cap="none" spc="0" normalizeH="0" baseline="0">
             <a:ln>
               <a:noFill/>
             </a:ln>
@@ -9287,8 +9038,7 @@
           <a:buSzTx/>
           <a:buFontTx/>
           <a:buNone/>
-          <a:tabLst/>
-          <a:defRPr b="0" baseline="0" cap="none" i="0" spc="0" strike="noStrike" sz="1800" u="none" kumimoji="0" normalizeH="0">
+          <a:defRPr kumimoji="0" sz="1800" b="0" i="0" u="none" strike="noStrike" cap="none" spc="0" normalizeH="0" baseline="0">
             <a:ln>
               <a:noFill/>
             </a:ln>
@@ -9313,8 +9063,7 @@
           <a:buSzTx/>
           <a:buFontTx/>
           <a:buNone/>
-          <a:tabLst/>
-          <a:defRPr b="0" baseline="0" cap="none" i="0" spc="0" strike="noStrike" sz="1800" u="none" kumimoji="0" normalizeH="0">
+          <a:defRPr kumimoji="0" sz="1800" b="0" i="0" u="none" strike="noStrike" cap="none" spc="0" normalizeH="0" baseline="0">
             <a:ln>
               <a:noFill/>
             </a:ln>
@@ -9339,8 +9088,7 @@
           <a:buSzTx/>
           <a:buFontTx/>
           <a:buNone/>
-          <a:tabLst/>
-          <a:defRPr b="0" baseline="0" cap="none" i="0" spc="0" strike="noStrike" sz="1800" u="none" kumimoji="0" normalizeH="0">
+          <a:defRPr kumimoji="0" sz="1800" b="0" i="0" u="none" strike="noStrike" cap="none" spc="0" normalizeH="0" baseline="0">
             <a:ln>
               <a:noFill/>
             </a:ln>
@@ -9365,8 +9113,7 @@
           <a:buSzTx/>
           <a:buFontTx/>
           <a:buNone/>
-          <a:tabLst/>
-          <a:defRPr b="0" baseline="0" cap="none" i="0" spc="0" strike="noStrike" sz="1800" u="none" kumimoji="0" normalizeH="0">
+          <a:defRPr kumimoji="0" sz="1800" b="0" i="0" u="none" strike="noStrike" cap="none" spc="0" normalizeH="0" baseline="0">
             <a:ln>
               <a:noFill/>
             </a:ln>
@@ -9379,18 +9126,29 @@
         </a:lvl9pPr>
       </a:lstStyle>
       <a:style>
-        <a:lnRef idx="0"/>
-        <a:fillRef idx="0"/>
-        <a:effectRef idx="0"/>
+        <a:lnRef idx="0">
+          <a:srgbClr val="FFFFFF"/>
+        </a:lnRef>
+        <a:fillRef idx="0">
+          <a:srgbClr val="FFFFFF"/>
+        </a:fillRef>
+        <a:effectRef idx="0">
+          <a:srgbClr val="FFFFFF"/>
+        </a:effectRef>
         <a:fontRef idx="none"/>
       </a:style>
     </a:txDef>
   </a:objectDefaults>
+  <a:extLst>
+    <a:ext uri="{05A4C25C-085E-4340-85A3-A5531E510DB2}">
+      <thm15:themeFamily xmlns:thm15="http://schemas.microsoft.com/office/thememl/2012/main" name="Office Theme" id="{62F939B6-93AF-4DB8-9C6B-D6C7DFDC589F}" vid="{4A3C46E8-61CC-4603-A589-7422A47A8E4A}"/>
+    </a:ext>
+  </a:extLst>
 </a:theme>
 </file>
 
 <file path=ppt/theme/theme2.xml><?xml version="1.0" encoding="utf-8"?>
-<a:theme xmlns:a="http://schemas.openxmlformats.org/drawingml/2006/main" xmlns:r="http://schemas.openxmlformats.org/officeDocument/2006/relationships" name="Office Theme">
+<a:theme xmlns:a="http://schemas.openxmlformats.org/drawingml/2006/main" name="Office Theme">
   <a:themeElements>
     <a:clrScheme name="Office Theme">
       <a:dk1>
@@ -9516,7 +9274,7 @@
       <a:effectStyleLst>
         <a:effectStyle>
           <a:effectLst>
-            <a:outerShdw sx="100000" sy="100000" kx="0" ky="0" algn="b" rotWithShape="0" blurRad="38100" dist="23000" dir="5400000">
+            <a:outerShdw blurRad="38100" dist="23000" dir="5400000" rotWithShape="0">
               <a:srgbClr val="000000">
                 <a:alpha val="35000"/>
               </a:srgbClr>
@@ -9525,7 +9283,7 @@
         </a:effectStyle>
         <a:effectStyle>
           <a:effectLst>
-            <a:outerShdw sx="100000" sy="100000" kx="0" ky="0" algn="b" rotWithShape="0" blurRad="38100" dist="23000" dir="5400000">
+            <a:outerShdw blurRad="38100" dist="23000" dir="5400000" rotWithShape="0">
               <a:srgbClr val="000000">
                 <a:alpha val="35000"/>
               </a:srgbClr>
@@ -9534,7 +9292,7 @@
         </a:effectStyle>
         <a:effectStyle>
           <a:effectLst>
-            <a:outerShdw sx="100000" sy="100000" kx="0" ky="0" algn="b" rotWithShape="0" blurRad="38100" dist="20000" dir="5400000">
+            <a:outerShdw blurRad="38100" dist="20000" dir="5400000" rotWithShape="0">
               <a:srgbClr val="000000">
                 <a:alpha val="38000"/>
               </a:srgbClr>
@@ -9608,13 +9366,12 @@
           <a:round/>
         </a:ln>
         <a:effectLst>
-          <a:outerShdw sx="100000" sy="100000" kx="0" ky="0" algn="b" rotWithShape="0" blurRad="38100" dist="23000" dir="5400000">
+          <a:outerShdw blurRad="38100" dist="23000" dir="5400000" rotWithShape="0">
             <a:srgbClr val="000000">
               <a:alpha val="35000"/>
             </a:srgbClr>
           </a:outerShdw>
         </a:effectLst>
-        <a:sp3d/>
       </a:spPr>
       <a:bodyPr rot="0" spcFirstLastPara="1" vertOverflow="overflow" horzOverflow="overflow" vert="horz" wrap="square" lIns="45719" tIns="45719" rIns="45719" bIns="45719" numCol="1" spcCol="38100" rtlCol="0" anchor="ctr" upright="0">
         <a:spAutoFit/>
@@ -9634,8 +9391,7 @@
           <a:buSzTx/>
           <a:buFontTx/>
           <a:buNone/>
-          <a:tabLst/>
-          <a:defRPr b="0" baseline="0" cap="none" i="0" spc="0" strike="noStrike" sz="1800" u="none" kumimoji="0" normalizeH="0">
+          <a:defRPr kumimoji="0" sz="1800" b="0" i="0" u="none" strike="noStrike" cap="none" spc="0" normalizeH="0" baseline="0">
             <a:ln>
               <a:noFill/>
             </a:ln>
@@ -9664,8 +9420,7 @@
           <a:buSzTx/>
           <a:buFontTx/>
           <a:buNone/>
-          <a:tabLst/>
-          <a:defRPr b="0" baseline="0" cap="none" i="0" spc="0" strike="noStrike" sz="1800" u="none" kumimoji="0" normalizeH="0">
+          <a:defRPr kumimoji="0" sz="1800" b="0" i="0" u="none" strike="noStrike" cap="none" spc="0" normalizeH="0" baseline="0">
             <a:ln>
               <a:noFill/>
             </a:ln>
@@ -9690,8 +9445,7 @@
           <a:buSzTx/>
           <a:buFontTx/>
           <a:buNone/>
-          <a:tabLst/>
-          <a:defRPr b="0" baseline="0" cap="none" i="0" spc="0" strike="noStrike" sz="1800" u="none" kumimoji="0" normalizeH="0">
+          <a:defRPr kumimoji="0" sz="1800" b="0" i="0" u="none" strike="noStrike" cap="none" spc="0" normalizeH="0" baseline="0">
             <a:ln>
               <a:noFill/>
             </a:ln>
@@ -9716,8 +9470,7 @@
           <a:buSzTx/>
           <a:buFontTx/>
           <a:buNone/>
-          <a:tabLst/>
-          <a:defRPr b="0" baseline="0" cap="none" i="0" spc="0" strike="noStrike" sz="1800" u="none" kumimoji="0" normalizeH="0">
+          <a:defRPr kumimoji="0" sz="1800" b="0" i="0" u="none" strike="noStrike" cap="none" spc="0" normalizeH="0" baseline="0">
             <a:ln>
               <a:noFill/>
             </a:ln>
@@ -9742,8 +9495,7 @@
           <a:buSzTx/>
           <a:buFontTx/>
           <a:buNone/>
-          <a:tabLst/>
-          <a:defRPr b="0" baseline="0" cap="none" i="0" spc="0" strike="noStrike" sz="1800" u="none" kumimoji="0" normalizeH="0">
+          <a:defRPr kumimoji="0" sz="1800" b="0" i="0" u="none" strike="noStrike" cap="none" spc="0" normalizeH="0" baseline="0">
             <a:ln>
               <a:noFill/>
             </a:ln>
@@ -9768,8 +9520,7 @@
           <a:buSzTx/>
           <a:buFontTx/>
           <a:buNone/>
-          <a:tabLst/>
-          <a:defRPr b="0" baseline="0" cap="none" i="0" spc="0" strike="noStrike" sz="1800" u="none" kumimoji="0" normalizeH="0">
+          <a:defRPr kumimoji="0" sz="1800" b="0" i="0" u="none" strike="noStrike" cap="none" spc="0" normalizeH="0" baseline="0">
             <a:ln>
               <a:noFill/>
             </a:ln>
@@ -9794,8 +9545,7 @@
           <a:buSzTx/>
           <a:buFontTx/>
           <a:buNone/>
-          <a:tabLst/>
-          <a:defRPr b="0" baseline="0" cap="none" i="0" spc="0" strike="noStrike" sz="1800" u="none" kumimoji="0" normalizeH="0">
+          <a:defRPr kumimoji="0" sz="1800" b="0" i="0" u="none" strike="noStrike" cap="none" spc="0" normalizeH="0" baseline="0">
             <a:ln>
               <a:noFill/>
             </a:ln>
@@ -9820,8 +9570,7 @@
           <a:buSzTx/>
           <a:buFontTx/>
           <a:buNone/>
-          <a:tabLst/>
-          <a:defRPr b="0" baseline="0" cap="none" i="0" spc="0" strike="noStrike" sz="1800" u="none" kumimoji="0" normalizeH="0">
+          <a:defRPr kumimoji="0" sz="1800" b="0" i="0" u="none" strike="noStrike" cap="none" spc="0" normalizeH="0" baseline="0">
             <a:ln>
               <a:noFill/>
             </a:ln>
@@ -9846,8 +9595,7 @@
           <a:buSzTx/>
           <a:buFontTx/>
           <a:buNone/>
-          <a:tabLst/>
-          <a:defRPr b="0" baseline="0" cap="none" i="0" spc="0" strike="noStrike" sz="1800" u="none" kumimoji="0" normalizeH="0">
+          <a:defRPr kumimoji="0" sz="1800" b="0" i="0" u="none" strike="noStrike" cap="none" spc="0" normalizeH="0" baseline="0">
             <a:ln>
               <a:noFill/>
             </a:ln>
@@ -9872,8 +9620,7 @@
           <a:buSzTx/>
           <a:buFontTx/>
           <a:buNone/>
-          <a:tabLst/>
-          <a:defRPr b="0" baseline="0" cap="none" i="0" spc="0" strike="noStrike" sz="1800" u="none" kumimoji="0" normalizeH="0">
+          <a:defRPr kumimoji="0" sz="1800" b="0" i="0" u="none" strike="noStrike" cap="none" spc="0" normalizeH="0" baseline="0">
             <a:ln>
               <a:noFill/>
             </a:ln>
@@ -9886,9 +9633,15 @@
         </a:lvl9pPr>
       </a:lstStyle>
       <a:style>
-        <a:lnRef idx="0"/>
-        <a:fillRef idx="0"/>
-        <a:effectRef idx="0"/>
+        <a:lnRef idx="0">
+          <a:srgbClr val="FFFFFF"/>
+        </a:lnRef>
+        <a:fillRef idx="0">
+          <a:srgbClr val="FFFFFF"/>
+        </a:fillRef>
+        <a:effectRef idx="0">
+          <a:srgbClr val="FFFFFF"/>
+        </a:effectRef>
         <a:fontRef idx="none"/>
       </a:style>
     </a:spDef>
@@ -9903,13 +9656,12 @@
           <a:round/>
         </a:ln>
         <a:effectLst>
-          <a:outerShdw sx="100000" sy="100000" kx="0" ky="0" algn="b" rotWithShape="0" blurRad="38100" dist="20000" dir="5400000">
+          <a:outerShdw blurRad="38100" dist="20000" dir="5400000" rotWithShape="0">
             <a:srgbClr val="000000">
               <a:alpha val="38000"/>
             </a:srgbClr>
           </a:outerShdw>
         </a:effectLst>
-        <a:sp3d/>
       </a:spPr>
       <a:bodyPr rot="0" spcFirstLastPara="1" vertOverflow="overflow" horzOverflow="overflow" vert="horz" wrap="square" lIns="91439" tIns="45719" rIns="91439" bIns="45719" numCol="1" spcCol="38100" rtlCol="0" anchor="t" upright="0">
         <a:noAutofit/>
@@ -9929,8 +9681,7 @@
           <a:buSzTx/>
           <a:buFontTx/>
           <a:buNone/>
-          <a:tabLst/>
-          <a:defRPr b="0" baseline="0" cap="none" i="0" spc="0" strike="noStrike" sz="1800" u="none" kumimoji="0" normalizeH="0">
+          <a:defRPr kumimoji="0" sz="1800" b="0" i="0" u="none" strike="noStrike" cap="none" spc="0" normalizeH="0" baseline="0">
             <a:ln>
               <a:noFill/>
             </a:ln>
@@ -9955,8 +9706,7 @@
           <a:buSzTx/>
           <a:buFontTx/>
           <a:buNone/>
-          <a:tabLst/>
-          <a:defRPr b="0" baseline="0" cap="none" i="0" spc="0" strike="noStrike" sz="1800" u="none" kumimoji="0" normalizeH="0">
+          <a:defRPr kumimoji="0" sz="1800" b="0" i="0" u="none" strike="noStrike" cap="none" spc="0" normalizeH="0" baseline="0">
             <a:ln>
               <a:noFill/>
             </a:ln>
@@ -9981,8 +9731,7 @@
           <a:buSzTx/>
           <a:buFontTx/>
           <a:buNone/>
-          <a:tabLst/>
-          <a:defRPr b="0" baseline="0" cap="none" i="0" spc="0" strike="noStrike" sz="1800" u="none" kumimoji="0" normalizeH="0">
+          <a:defRPr kumimoji="0" sz="1800" b="0" i="0" u="none" strike="noStrike" cap="none" spc="0" normalizeH="0" baseline="0">
             <a:ln>
               <a:noFill/>
             </a:ln>
@@ -10007,8 +9756,7 @@
           <a:buSzTx/>
           <a:buFontTx/>
           <a:buNone/>
-          <a:tabLst/>
-          <a:defRPr b="0" baseline="0" cap="none" i="0" spc="0" strike="noStrike" sz="1800" u="none" kumimoji="0" normalizeH="0">
+          <a:defRPr kumimoji="0" sz="1800" b="0" i="0" u="none" strike="noStrike" cap="none" spc="0" normalizeH="0" baseline="0">
             <a:ln>
               <a:noFill/>
             </a:ln>
@@ -10033,8 +9781,7 @@
           <a:buSzTx/>
           <a:buFontTx/>
           <a:buNone/>
-          <a:tabLst/>
-          <a:defRPr b="0" baseline="0" cap="none" i="0" spc="0" strike="noStrike" sz="1800" u="none" kumimoji="0" normalizeH="0">
+          <a:defRPr kumimoji="0" sz="1800" b="0" i="0" u="none" strike="noStrike" cap="none" spc="0" normalizeH="0" baseline="0">
             <a:ln>
               <a:noFill/>
             </a:ln>
@@ -10059,8 +9806,7 @@
           <a:buSzTx/>
           <a:buFontTx/>
           <a:buNone/>
-          <a:tabLst/>
-          <a:defRPr b="0" baseline="0" cap="none" i="0" spc="0" strike="noStrike" sz="1800" u="none" kumimoji="0" normalizeH="0">
+          <a:defRPr kumimoji="0" sz="1800" b="0" i="0" u="none" strike="noStrike" cap="none" spc="0" normalizeH="0" baseline="0">
             <a:ln>
               <a:noFill/>
             </a:ln>
@@ -10085,8 +9831,7 @@
           <a:buSzTx/>
           <a:buFontTx/>
           <a:buNone/>
-          <a:tabLst/>
-          <a:defRPr b="0" baseline="0" cap="none" i="0" spc="0" strike="noStrike" sz="1800" u="none" kumimoji="0" normalizeH="0">
+          <a:defRPr kumimoji="0" sz="1800" b="0" i="0" u="none" strike="noStrike" cap="none" spc="0" normalizeH="0" baseline="0">
             <a:ln>
               <a:noFill/>
             </a:ln>
@@ -10111,8 +9856,7 @@
           <a:buSzTx/>
           <a:buFontTx/>
           <a:buNone/>
-          <a:tabLst/>
-          <a:defRPr b="0" baseline="0" cap="none" i="0" spc="0" strike="noStrike" sz="1800" u="none" kumimoji="0" normalizeH="0">
+          <a:defRPr kumimoji="0" sz="1800" b="0" i="0" u="none" strike="noStrike" cap="none" spc="0" normalizeH="0" baseline="0">
             <a:ln>
               <a:noFill/>
             </a:ln>
@@ -10137,8 +9881,7 @@
           <a:buSzTx/>
           <a:buFontTx/>
           <a:buNone/>
-          <a:tabLst/>
-          <a:defRPr b="0" baseline="0" cap="none" i="0" spc="0" strike="noStrike" sz="1800" u="none" kumimoji="0" normalizeH="0">
+          <a:defRPr kumimoji="0" sz="1800" b="0" i="0" u="none" strike="noStrike" cap="none" spc="0" normalizeH="0" baseline="0">
             <a:ln>
               <a:noFill/>
             </a:ln>
@@ -10163,8 +9906,7 @@
           <a:buSzTx/>
           <a:buFontTx/>
           <a:buNone/>
-          <a:tabLst/>
-          <a:defRPr b="0" baseline="0" cap="none" i="0" spc="0" strike="noStrike" sz="1800" u="none" kumimoji="0" normalizeH="0">
+          <a:defRPr kumimoji="0" sz="1800" b="0" i="0" u="none" strike="noStrike" cap="none" spc="0" normalizeH="0" baseline="0">
             <a:ln>
               <a:noFill/>
             </a:ln>
@@ -10177,9 +9919,15 @@
         </a:lvl9pPr>
       </a:lstStyle>
       <a:style>
-        <a:lnRef idx="0"/>
-        <a:fillRef idx="0"/>
-        <a:effectRef idx="0"/>
+        <a:lnRef idx="0">
+          <a:srgbClr val="FFFFFF"/>
+        </a:lnRef>
+        <a:fillRef idx="0">
+          <a:srgbClr val="FFFFFF"/>
+        </a:fillRef>
+        <a:effectRef idx="0">
+          <a:srgbClr val="FFFFFF"/>
+        </a:effectRef>
         <a:fontRef idx="none"/>
       </a:style>
     </a:lnDef>
@@ -10190,8 +9938,6 @@
           <a:noFill/>
           <a:miter lim="400000"/>
         </a:ln>
-        <a:effectLst/>
-        <a:sp3d/>
       </a:spPr>
       <a:bodyPr rot="0" spcFirstLastPara="1" vertOverflow="overflow" horzOverflow="overflow" vert="horz" wrap="square" lIns="45719" tIns="45719" rIns="45719" bIns="45719" numCol="1" spcCol="38100" rtlCol="0" anchor="t" upright="0">
         <a:spAutoFit/>
@@ -10211,8 +9957,7 @@
           <a:buSzTx/>
           <a:buFontTx/>
           <a:buNone/>
-          <a:tabLst/>
-          <a:defRPr b="0" baseline="0" cap="none" i="0" spc="0" strike="noStrike" sz="1800" u="none" kumimoji="0" normalizeH="0">
+          <a:defRPr kumimoji="0" sz="1800" b="0" i="0" u="none" strike="noStrike" cap="none" spc="0" normalizeH="0" baseline="0">
             <a:ln>
               <a:noFill/>
             </a:ln>
@@ -10241,8 +9986,7 @@
           <a:buSzTx/>
           <a:buFontTx/>
           <a:buNone/>
-          <a:tabLst/>
-          <a:defRPr b="0" baseline="0" cap="none" i="0" spc="0" strike="noStrike" sz="1800" u="none" kumimoji="0" normalizeH="0">
+          <a:defRPr kumimoji="0" sz="1800" b="0" i="0" u="none" strike="noStrike" cap="none" spc="0" normalizeH="0" baseline="0">
             <a:ln>
               <a:noFill/>
             </a:ln>
@@ -10267,8 +10011,7 @@
           <a:buSzTx/>
           <a:buFontTx/>
           <a:buNone/>
-          <a:tabLst/>
-          <a:defRPr b="0" baseline="0" cap="none" i="0" spc="0" strike="noStrike" sz="1800" u="none" kumimoji="0" normalizeH="0">
+          <a:defRPr kumimoji="0" sz="1800" b="0" i="0" u="none" strike="noStrike" cap="none" spc="0" normalizeH="0" baseline="0">
             <a:ln>
               <a:noFill/>
             </a:ln>
@@ -10293,8 +10036,7 @@
           <a:buSzTx/>
           <a:buFontTx/>
           <a:buNone/>
-          <a:tabLst/>
-          <a:defRPr b="0" baseline="0" cap="none" i="0" spc="0" strike="noStrike" sz="1800" u="none" kumimoji="0" normalizeH="0">
+          <a:defRPr kumimoji="0" sz="1800" b="0" i="0" u="none" strike="noStrike" cap="none" spc="0" normalizeH="0" baseline="0">
             <a:ln>
               <a:noFill/>
             </a:ln>
@@ -10319,8 +10061,7 @@
           <a:buSzTx/>
           <a:buFontTx/>
           <a:buNone/>
-          <a:tabLst/>
-          <a:defRPr b="0" baseline="0" cap="none" i="0" spc="0" strike="noStrike" sz="1800" u="none" kumimoji="0" normalizeH="0">
+          <a:defRPr kumimoji="0" sz="1800" b="0" i="0" u="none" strike="noStrike" cap="none" spc="0" normalizeH="0" baseline="0">
             <a:ln>
               <a:noFill/>
             </a:ln>
@@ -10345,8 +10086,7 @@
           <a:buSzTx/>
           <a:buFontTx/>
           <a:buNone/>
-          <a:tabLst/>
-          <a:defRPr b="0" baseline="0" cap="none" i="0" spc="0" strike="noStrike" sz="1800" u="none" kumimoji="0" normalizeH="0">
+          <a:defRPr kumimoji="0" sz="1800" b="0" i="0" u="none" strike="noStrike" cap="none" spc="0" normalizeH="0" baseline="0">
             <a:ln>
               <a:noFill/>
             </a:ln>
@@ -10371,8 +10111,7 @@
           <a:buSzTx/>
           <a:buFontTx/>
           <a:buNone/>
-          <a:tabLst/>
-          <a:defRPr b="0" baseline="0" cap="none" i="0" spc="0" strike="noStrike" sz="1800" u="none" kumimoji="0" normalizeH="0">
+          <a:defRPr kumimoji="0" sz="1800" b="0" i="0" u="none" strike="noStrike" cap="none" spc="0" normalizeH="0" baseline="0">
             <a:ln>
               <a:noFill/>
             </a:ln>
@@ -10397,8 +10136,7 @@
           <a:buSzTx/>
           <a:buFontTx/>
           <a:buNone/>
-          <a:tabLst/>
-          <a:defRPr b="0" baseline="0" cap="none" i="0" spc="0" strike="noStrike" sz="1800" u="none" kumimoji="0" normalizeH="0">
+          <a:defRPr kumimoji="0" sz="1800" b="0" i="0" u="none" strike="noStrike" cap="none" spc="0" normalizeH="0" baseline="0">
             <a:ln>
               <a:noFill/>
             </a:ln>
@@ -10423,8 +10161,7 @@
           <a:buSzTx/>
           <a:buFontTx/>
           <a:buNone/>
-          <a:tabLst/>
-          <a:defRPr b="0" baseline="0" cap="none" i="0" spc="0" strike="noStrike" sz="1800" u="none" kumimoji="0" normalizeH="0">
+          <a:defRPr kumimoji="0" sz="1800" b="0" i="0" u="none" strike="noStrike" cap="none" spc="0" normalizeH="0" baseline="0">
             <a:ln>
               <a:noFill/>
             </a:ln>
@@ -10449,8 +10186,7 @@
           <a:buSzTx/>
           <a:buFontTx/>
           <a:buNone/>
-          <a:tabLst/>
-          <a:defRPr b="0" baseline="0" cap="none" i="0" spc="0" strike="noStrike" sz="1800" u="none" kumimoji="0" normalizeH="0">
+          <a:defRPr kumimoji="0" sz="1800" b="0" i="0" u="none" strike="noStrike" cap="none" spc="0" normalizeH="0" baseline="0">
             <a:ln>
               <a:noFill/>
             </a:ln>
@@ -10463,12 +10199,23 @@
         </a:lvl9pPr>
       </a:lstStyle>
       <a:style>
-        <a:lnRef idx="0"/>
-        <a:fillRef idx="0"/>
-        <a:effectRef idx="0"/>
+        <a:lnRef idx="0">
+          <a:srgbClr val="FFFFFF"/>
+        </a:lnRef>
+        <a:fillRef idx="0">
+          <a:srgbClr val="FFFFFF"/>
+        </a:fillRef>
+        <a:effectRef idx="0">
+          <a:srgbClr val="FFFFFF"/>
+        </a:effectRef>
         <a:fontRef idx="none"/>
       </a:style>
     </a:txDef>
   </a:objectDefaults>
+  <a:extLst>
+    <a:ext uri="{05A4C25C-085E-4340-85A3-A5531E510DB2}">
+      <thm15:themeFamily xmlns:thm15="http://schemas.microsoft.com/office/thememl/2012/main" name="Office Theme" id="{62F939B6-93AF-4DB8-9C6B-D6C7DFDC589F}" vid="{4A3C46E8-61CC-4603-A589-7422A47A8E4A}"/>
+    </a:ext>
+  </a:extLst>
 </a:theme>
 </file>
</xml_diff>